<commit_message>
context: one-slide architecture v3 'Signal Dark' — image strip removed, larger clearer text, flow-field background, design doc
Per screenshots/: the four-image strip under the flow crowded the slide and is
gone; the FRD page and STTM sheet previews now sit inside the SharePoint and
Outputs nodes as thumbnails. Body 11 pt near-white, titles 14.5 pt, nothing
under 8.5 pt, ~110 words. Theme 'Signal Dark' (theme-factory custom theme
chosen by Arjun): Blueprint dark neutrals; Claude orange (brand-guidelines
accent) marks the single model call; turquoise = code, gold = human, indigo =
external. Background is a seeded, reproducible flow-field (algorithmic-art
'Field Dynamics') calm where the nodes sit. Philosophy + theme spec in
scripts/deck_assets/ONEPAGER_DESIGN.md (canvas-design). Validated; QA'd via
LibreOffice render.

Co-Authored-By: Claude Fable 5 <noreply@anthropic.com>
</commit_message>
<xml_diff>
--- a/context/FRD_to_STTM_Agent_System_Architecture.pptx
+++ b/context/FRD_to_STTM_Agent_System_Architecture.pptx
@@ -3400,8 +3400,8 @@
         </p:nvSpPr>
         <p:spPr>
           <a:xfrm>
-            <a:off x="548640" y="384048"/>
-            <a:ext cx="8229600" cy="201168"/>
+            <a:off x="548640" y="420624"/>
+            <a:ext cx="8229600" cy="219456"/>
           </a:xfrm>
           <a:prstGeom prst="rect">
             <a:avLst/>
@@ -3416,9 +3416,9 @@
           <a:p>
             <a:pPr algn="l"/>
             <a:r>
-              <a:rPr sz="800" b="0" spc="160">
+              <a:rPr sz="900" b="0" spc="160">
                 <a:solidFill>
-                  <a:srgbClr val="738091"/>
+                  <a:srgbClr val="8F99A8"/>
                 </a:solidFill>
                 <a:latin typeface="Courier New"/>
               </a:rPr>
@@ -3435,8 +3435,8 @@
         </p:nvSpPr>
         <p:spPr>
           <a:xfrm>
-            <a:off x="548640" y="585216"/>
-            <a:ext cx="8229600" cy="502920"/>
+            <a:off x="548640" y="658368"/>
+            <a:ext cx="8686800" cy="548640"/>
           </a:xfrm>
           <a:prstGeom prst="rect">
             <a:avLst/>
@@ -3451,7 +3451,7 @@
           <a:p>
             <a:pPr algn="l"/>
             <a:r>
-              <a:rPr sz="2800" b="1">
+              <a:rPr sz="3000" b="1">
                 <a:solidFill>
                   <a:srgbClr val="FFFFFF"/>
                 </a:solidFill>
@@ -3460,7 +3460,7 @@
               <a:t>FRD → STTM Agent</a:t>
             </a:r>
             <a:r>
-              <a:rPr sz="1500" b="0">
+              <a:rPr sz="1600" b="0">
                 <a:solidFill>
                   <a:srgbClr val="8F99A8"/>
                 </a:solidFill>
@@ -3479,8 +3479,8 @@
         </p:nvSpPr>
         <p:spPr>
           <a:xfrm>
-            <a:off x="548640" y="1060704"/>
-            <a:ext cx="6949440" cy="274320"/>
+            <a:off x="548640" y="1170432"/>
+            <a:ext cx="11064240" cy="274320"/>
           </a:xfrm>
           <a:prstGeom prst="rect">
             <a:avLst/>
@@ -3495,9 +3495,9 @@
           <a:p>
             <a:pPr algn="l"/>
             <a:r>
-              <a:rPr sz="1100" b="0">
+              <a:rPr sz="1200" b="0">
                 <a:solidFill>
-                  <a:srgbClr val="ABB3BF"/>
+                  <a:srgbClr val="C5CBD3"/>
                 </a:solidFill>
                 <a:latin typeface="Calibri"/>
               </a:rPr>
@@ -3514,8 +3514,8 @@
         </p:nvSpPr>
         <p:spPr>
           <a:xfrm>
-            <a:off x="7666329" y="640080"/>
-            <a:ext cx="1828800" cy="237744"/>
+            <a:off x="548640" y="1536192"/>
+            <a:ext cx="2011679" cy="274320"/>
           </a:xfrm>
           <a:prstGeom prst="roundRect">
             <a:avLst>
@@ -3523,7 +3523,7 @@
             </a:avLst>
           </a:prstGeom>
           <a:noFill/>
-          <a:ln w="7620">
+          <a:ln w="9525">
             <a:solidFill>
               <a:srgbClr val="634DBF"/>
             </a:solidFill>
@@ -3558,8 +3558,8 @@
         </p:nvSpPr>
         <p:spPr>
           <a:xfrm>
-            <a:off x="7666329" y="690372"/>
-            <a:ext cx="1828800" cy="164592"/>
+            <a:off x="548640" y="1600200"/>
+            <a:ext cx="2011679" cy="182880"/>
           </a:xfrm>
           <a:prstGeom prst="rect">
             <a:avLst/>
@@ -3574,7 +3574,7 @@
           <a:p>
             <a:pPr algn="ctr"/>
             <a:r>
-              <a:rPr sz="750" b="0" spc="100">
+              <a:rPr sz="850" b="0" spc="100">
                 <a:solidFill>
                   <a:srgbClr val="9881F3"/>
                 </a:solidFill>
@@ -3593,8 +3593,8 @@
         </p:nvSpPr>
         <p:spPr>
           <a:xfrm>
-            <a:off x="9586569" y="640080"/>
-            <a:ext cx="2056485" cy="237744"/>
+            <a:off x="2670048" y="1536192"/>
+            <a:ext cx="2432303" cy="274320"/>
           </a:xfrm>
           <a:prstGeom prst="roundRect">
             <a:avLst>
@@ -3602,9 +3602,9 @@
             </a:avLst>
           </a:prstGeom>
           <a:noFill/>
-          <a:ln w="7620">
+          <a:ln w="9525">
             <a:solidFill>
-              <a:srgbClr val="0F6894"/>
+              <a:srgbClr val="8A4A36"/>
             </a:solidFill>
           </a:ln>
           <a:effectLst/>
@@ -3637,8 +3637,8 @@
         </p:nvSpPr>
         <p:spPr>
           <a:xfrm>
-            <a:off x="9586569" y="690372"/>
-            <a:ext cx="2056485" cy="164592"/>
+            <a:off x="2670048" y="1600200"/>
+            <a:ext cx="2432303" cy="182880"/>
           </a:xfrm>
           <a:prstGeom prst="rect">
             <a:avLst/>
@@ -3653,13 +3653,13 @@
           <a:p>
             <a:pPr algn="ctr"/>
             <a:r>
-              <a:rPr sz="750" b="0" spc="100">
+              <a:rPr sz="850" b="0" spc="100">
                 <a:solidFill>
-                  <a:srgbClr val="3FA6DA"/>
+                  <a:srgbClr val="D97757"/>
                 </a:solidFill>
                 <a:latin typeface="Courier New"/>
               </a:rPr>
-              <a:t>1 MODEL CALL / DOCUMENT</a:t>
+              <a:t>1 MODEL CALL PER DOCUMENT</a:t>
             </a:r>
           </a:p>
         </p:txBody>
@@ -3672,8 +3672,8 @@
         </p:nvSpPr>
         <p:spPr>
           <a:xfrm>
-            <a:off x="7742224" y="950976"/>
-            <a:ext cx="2208276" cy="237744"/>
+            <a:off x="5212080" y="1536192"/>
+            <a:ext cx="2432303" cy="274320"/>
           </a:xfrm>
           <a:prstGeom prst="roundRect">
             <a:avLst>
@@ -3681,7 +3681,7 @@
             </a:avLst>
           </a:prstGeom>
           <a:noFill/>
-          <a:ln w="7620">
+          <a:ln w="9525">
             <a:solidFill>
               <a:srgbClr val="007067"/>
             </a:solidFill>
@@ -3716,8 +3716,8 @@
         </p:nvSpPr>
         <p:spPr>
           <a:xfrm>
-            <a:off x="7742224" y="1001268"/>
-            <a:ext cx="2208276" cy="164592"/>
+            <a:off x="5212080" y="1600200"/>
+            <a:ext cx="2432303" cy="182880"/>
           </a:xfrm>
           <a:prstGeom prst="rect">
             <a:avLst/>
@@ -3732,7 +3732,7 @@
           <a:p>
             <a:pPr algn="ctr"/>
             <a:r>
-              <a:rPr sz="750" b="0" spc="100">
+              <a:rPr sz="850" b="0" spc="100">
                 <a:solidFill>
                   <a:srgbClr val="13C9BA"/>
                 </a:solidFill>
@@ -3751,91 +3751,12 @@
         </p:nvSpPr>
         <p:spPr>
           <a:xfrm>
-            <a:off x="10041940" y="950976"/>
-            <a:ext cx="1601114" cy="237744"/>
+            <a:off x="548640" y="2011680"/>
+            <a:ext cx="2011680" cy="2788920"/>
           </a:xfrm>
           <a:prstGeom prst="roundRect">
             <a:avLst>
-              <a:gd name="adj" fmla="val 50000"/>
-            </a:avLst>
-          </a:prstGeom>
-          <a:noFill/>
-          <a:ln w="7620">
-            <a:solidFill>
-              <a:srgbClr val="866103"/>
-            </a:solidFill>
-          </a:ln>
-          <a:effectLst/>
-        </p:spPr>
-        <p:style>
-          <a:lnRef idx="1">
-            <a:schemeClr val="accent1"/>
-          </a:lnRef>
-          <a:fillRef idx="3">
-            <a:schemeClr val="accent1"/>
-          </a:fillRef>
-          <a:effectRef idx="2">
-            <a:schemeClr val="accent1"/>
-          </a:effectRef>
-          <a:fontRef idx="minor">
-            <a:schemeClr val="lt1"/>
-          </a:fontRef>
-        </p:style>
-        <p:txBody>
-          <a:bodyPr rtlCol="0" anchor="ctr"/>
-          <a:lstStyle/>
-          <a:p/>
-        </p:txBody>
-      </p:sp>
-      <p:sp>
-        <p:nvSpPr>
-          <p:cNvPr id="21" name="TextBox 20"/>
-          <p:cNvSpPr txBox="1"/>
-          <p:nvPr/>
-        </p:nvSpPr>
-        <p:spPr>
-          <a:xfrm>
-            <a:off x="10041940" y="1001268"/>
-            <a:ext cx="1601114" cy="164592"/>
-          </a:xfrm>
-          <a:prstGeom prst="rect">
-            <a:avLst/>
-          </a:prstGeom>
-          <a:noFill/>
-        </p:spPr>
-        <p:txBody>
-          <a:bodyPr wrap="square" lIns="0" rIns="0" tIns="0" bIns="0" anchor="t">
-            <a:spAutoFit/>
-          </a:bodyPr>
-          <a:lstStyle/>
-          <a:p>
-            <a:pPr algn="ctr"/>
-            <a:r>
-              <a:rPr sz="750" b="0" spc="100">
-                <a:solidFill>
-                  <a:srgbClr val="F0B726"/>
-                </a:solidFill>
-                <a:latin typeface="Courier New"/>
-              </a:rPr>
-              <a:t>HUMAN IN THE LOOP</a:t>
-            </a:r>
-          </a:p>
-        </p:txBody>
-      </p:sp>
-      <p:sp>
-        <p:nvSpPr>
-          <p:cNvPr id="22" name="Rounded Rectangle 21"/>
-          <p:cNvSpPr/>
-          <p:nvPr/>
-        </p:nvSpPr>
-        <p:spPr>
-          <a:xfrm>
-            <a:off x="548640" y="1691640"/>
-            <a:ext cx="1874519" cy="1783080"/>
-          </a:xfrm>
-          <a:prstGeom prst="roundRect">
-            <a:avLst>
-              <a:gd name="adj" fmla="val 4000"/>
+              <a:gd name="adj" fmla="val 3500"/>
             </a:avLst>
           </a:prstGeom>
           <a:solidFill>
@@ -3870,14 +3791,14 @@
       </p:sp>
       <p:sp>
         <p:nvSpPr>
-          <p:cNvPr id="23" name="Oval 22"/>
+          <p:cNvPr id="21" name="Oval 20"/>
           <p:cNvSpPr/>
           <p:nvPr/>
         </p:nvSpPr>
         <p:spPr>
           <a:xfrm>
-            <a:off x="722375" y="1892808"/>
-            <a:ext cx="91440" cy="91440"/>
+            <a:off x="736092" y="2235708"/>
+            <a:ext cx="100584" cy="100584"/>
           </a:xfrm>
           <a:prstGeom prst="ellipse">
             <a:avLst/>
@@ -3914,14 +3835,14 @@
       </p:sp>
       <p:sp>
         <p:nvSpPr>
-          <p:cNvPr id="24" name="TextBox 23"/>
+          <p:cNvPr id="22" name="TextBox 21"/>
           <p:cNvSpPr txBox="1"/>
           <p:nvPr/>
         </p:nvSpPr>
         <p:spPr>
           <a:xfrm>
-            <a:off x="914400" y="1847088"/>
-            <a:ext cx="822960" cy="201168"/>
+            <a:off x="950976" y="2185416"/>
+            <a:ext cx="914400" cy="219456"/>
           </a:xfrm>
           <a:prstGeom prst="rect">
             <a:avLst/>
@@ -3936,7 +3857,7 @@
           <a:p>
             <a:pPr algn="l"/>
             <a:r>
-              <a:rPr sz="850" b="0" spc="140">
+              <a:rPr sz="900" b="0" spc="140">
                 <a:solidFill>
                   <a:srgbClr val="9881F3"/>
                 </a:solidFill>
@@ -3949,14 +3870,14 @@
       </p:sp>
       <p:sp>
         <p:nvSpPr>
-          <p:cNvPr id="25" name="TextBox 24"/>
+          <p:cNvPr id="23" name="TextBox 22"/>
           <p:cNvSpPr txBox="1"/>
           <p:nvPr/>
         </p:nvSpPr>
         <p:spPr>
           <a:xfrm>
-            <a:off x="749808" y="2075688"/>
-            <a:ext cx="1234439" cy="274320"/>
+            <a:off x="768096" y="2432304"/>
+            <a:ext cx="1645920" cy="310896"/>
           </a:xfrm>
           <a:prstGeom prst="rect">
             <a:avLst/>
@@ -3971,20 +3892,20 @@
           <a:p>
             <a:pPr algn="l"/>
             <a:r>
-              <a:rPr sz="1300" b="1">
+              <a:rPr sz="1450" b="1">
                 <a:solidFill>
                   <a:srgbClr val="F6F7F9"/>
                 </a:solidFill>
                 <a:latin typeface="Calibri"/>
               </a:rPr>
-              <a:t>SharePoint library</a:t>
+              <a:t>SharePoint</a:t>
             </a:r>
           </a:p>
         </p:txBody>
       </p:sp>
       <p:pic>
         <p:nvPicPr>
-          <p:cNvPr id="26" name="Picture 25" descr="folder.png"/>
+          <p:cNvPr id="24" name="Picture 23" descr="folder.png"/>
           <p:cNvPicPr>
             <a:picLocks noChangeAspect="1"/>
           </p:cNvPicPr>
@@ -3998,7 +3919,7 @@
         </p:blipFill>
         <p:spPr>
           <a:xfrm>
-            <a:off x="1947672" y="1847088"/>
+            <a:off x="2084832" y="2157984"/>
             <a:ext cx="274320" cy="274320"/>
           </a:xfrm>
           <a:prstGeom prst="rect">
@@ -4008,14 +3929,14 @@
       </p:pic>
       <p:sp>
         <p:nvSpPr>
-          <p:cNvPr id="27" name="TextBox 26"/>
+          <p:cNvPr id="25" name="TextBox 24"/>
           <p:cNvSpPr txBox="1"/>
           <p:nvPr/>
         </p:nvSpPr>
         <p:spPr>
           <a:xfrm>
-            <a:off x="749808" y="2404872"/>
-            <a:ext cx="1508760" cy="960119"/>
+            <a:off x="768096" y="2816352"/>
+            <a:ext cx="1591056" cy="1097280"/>
           </a:xfrm>
           <a:prstGeom prst="rect">
             <a:avLst/>
@@ -4034,9 +3955,9 @@
               </a:lnSpc>
             </a:pPr>
             <a:r>
-              <a:rPr sz="950" b="0">
+              <a:rPr sz="1100" b="0">
                 <a:solidFill>
-                  <a:srgbClr val="ABB3BF"/>
+                  <a:srgbClr val="C5CBD3"/>
                 </a:solidFill>
                 <a:latin typeface="Calibri"/>
               </a:rPr>
@@ -4047,18 +3968,88 @@
       </p:sp>
       <p:sp>
         <p:nvSpPr>
+          <p:cNvPr id="26" name="Rounded Rectangle 25"/>
+          <p:cNvSpPr/>
+          <p:nvPr/>
+        </p:nvSpPr>
+        <p:spPr>
+          <a:xfrm>
+            <a:off x="694944" y="3758183"/>
+            <a:ext cx="1719072" cy="896112"/>
+          </a:xfrm>
+          <a:prstGeom prst="roundRect">
+            <a:avLst>
+              <a:gd name="adj" fmla="val 3000"/>
+            </a:avLst>
+          </a:prstGeom>
+          <a:solidFill>
+            <a:srgbClr val="252A31"/>
+          </a:solidFill>
+          <a:ln w="9525">
+            <a:solidFill>
+              <a:srgbClr val="404854"/>
+            </a:solidFill>
+          </a:ln>
+          <a:effectLst/>
+        </p:spPr>
+        <p:style>
+          <a:lnRef idx="1">
+            <a:schemeClr val="accent1"/>
+          </a:lnRef>
+          <a:fillRef idx="3">
+            <a:schemeClr val="accent1"/>
+          </a:fillRef>
+          <a:effectRef idx="2">
+            <a:schemeClr val="accent1"/>
+          </a:effectRef>
+          <a:fontRef idx="minor">
+            <a:schemeClr val="lt1"/>
+          </a:fontRef>
+        </p:style>
+        <p:txBody>
+          <a:bodyPr rtlCol="0" anchor="ctr"/>
+          <a:lstStyle/>
+          <a:p/>
+        </p:txBody>
+      </p:sp>
+      <p:pic>
+        <p:nvPicPr>
+          <p:cNvPr id="27" name="Picture 26" descr="frd_page.png"/>
+          <p:cNvPicPr>
+            <a:picLocks noChangeAspect="1"/>
+          </p:cNvPicPr>
+          <p:nvPr/>
+        </p:nvPicPr>
+        <p:blipFill>
+          <a:blip r:embed="rId4"/>
+          <a:stretch>
+            <a:fillRect/>
+          </a:stretch>
+        </p:blipFill>
+        <p:spPr>
+          <a:xfrm>
+            <a:off x="885952" y="3776472"/>
+            <a:ext cx="1337055" cy="859536"/>
+          </a:xfrm>
+          <a:prstGeom prst="rect">
+            <a:avLst/>
+          </a:prstGeom>
+        </p:spPr>
+      </p:pic>
+      <p:sp>
+        <p:nvSpPr>
           <p:cNvPr id="28" name="Rounded Rectangle 27"/>
           <p:cNvSpPr/>
           <p:nvPr/>
         </p:nvSpPr>
         <p:spPr>
           <a:xfrm>
-            <a:off x="2743200" y="1691640"/>
-            <a:ext cx="1874519" cy="1783080"/>
+            <a:off x="2834640" y="2011680"/>
+            <a:ext cx="1874519" cy="2788920"/>
           </a:xfrm>
           <a:prstGeom prst="roundRect">
             <a:avLst>
-              <a:gd name="adj" fmla="val 4000"/>
+              <a:gd name="adj" fmla="val 3500"/>
             </a:avLst>
           </a:prstGeom>
           <a:solidFill>
@@ -4099,8 +4090,8 @@
         </p:nvSpPr>
         <p:spPr>
           <a:xfrm>
-            <a:off x="2916936" y="1892808"/>
-            <a:ext cx="91440" cy="91440"/>
+            <a:off x="3022092" y="2235708"/>
+            <a:ext cx="100584" cy="100584"/>
           </a:xfrm>
           <a:prstGeom prst="ellipse">
             <a:avLst/>
@@ -4143,8 +4134,8 @@
         </p:nvSpPr>
         <p:spPr>
           <a:xfrm>
-            <a:off x="3108960" y="1847088"/>
-            <a:ext cx="822960" cy="201168"/>
+            <a:off x="3236976" y="2185416"/>
+            <a:ext cx="914400" cy="219456"/>
           </a:xfrm>
           <a:prstGeom prst="rect">
             <a:avLst/>
@@ -4159,7 +4150,7 @@
           <a:p>
             <a:pPr algn="l"/>
             <a:r>
-              <a:rPr sz="850" b="0" spc="140">
+              <a:rPr sz="900" b="0" spc="140">
                 <a:solidFill>
                   <a:srgbClr val="13C9BA"/>
                 </a:solidFill>
@@ -4178,8 +4169,8 @@
         </p:nvSpPr>
         <p:spPr>
           <a:xfrm>
-            <a:off x="2944368" y="2075688"/>
-            <a:ext cx="1234439" cy="274320"/>
+            <a:off x="3054096" y="2432304"/>
+            <a:ext cx="1508760" cy="310896"/>
           </a:xfrm>
           <a:prstGeom prst="rect">
             <a:avLst/>
@@ -4194,7 +4185,7 @@
           <a:p>
             <a:pPr algn="l"/>
             <a:r>
-              <a:rPr sz="1300" b="1">
+              <a:rPr sz="1450" b="1">
                 <a:solidFill>
                   <a:srgbClr val="F6F7F9"/>
                 </a:solidFill>
@@ -4214,14 +4205,14 @@
           <p:nvPr/>
         </p:nvPicPr>
         <p:blipFill>
-          <a:blip r:embed="rId4"/>
+          <a:blip r:embed="rId5"/>
           <a:stretch>
             <a:fillRect/>
           </a:stretch>
         </p:blipFill>
         <p:spPr>
           <a:xfrm>
-            <a:off x="4142231" y="1847088"/>
+            <a:off x="4233672" y="2157984"/>
             <a:ext cx="274320" cy="274320"/>
           </a:xfrm>
           <a:prstGeom prst="rect">
@@ -4237,8 +4228,8 @@
         </p:nvSpPr>
         <p:spPr>
           <a:xfrm>
-            <a:off x="2944368" y="2404872"/>
-            <a:ext cx="1508760" cy="960119"/>
+            <a:off x="3054096" y="2816352"/>
+            <a:ext cx="1453895" cy="1097280"/>
           </a:xfrm>
           <a:prstGeom prst="rect">
             <a:avLst/>
@@ -4257,13 +4248,13 @@
               </a:lnSpc>
             </a:pPr>
             <a:r>
-              <a:rPr sz="950" b="0">
+              <a:rPr sz="1100" b="0">
                 <a:solidFill>
-                  <a:srgbClr val="ABB3BF"/>
+                  <a:srgbClr val="C5CBD3"/>
                 </a:solidFill>
                 <a:latin typeface="Calibri"/>
               </a:rPr>
-              <a:t>Every 15 min, incremental. Pairs each FRD with its STTM and indexes the corpus in Unity Catalog. Zero model calls.</a:t>
+              <a:t>Every 15 minutes, incremental. Pairs each FRD with its STTM and indexes the corpus in Unity Catalog. Zero model calls.</a:t>
             </a:r>
           </a:p>
         </p:txBody>
@@ -4276,12 +4267,12 @@
         </p:nvSpPr>
         <p:spPr>
           <a:xfrm>
-            <a:off x="4937760" y="1691640"/>
-            <a:ext cx="2880360" cy="1783080"/>
+            <a:off x="4983480" y="2011680"/>
+            <a:ext cx="2697480" cy="2788920"/>
           </a:xfrm>
           <a:prstGeom prst="roundRect">
             <a:avLst>
-              <a:gd name="adj" fmla="val 4000"/>
+              <a:gd name="adj" fmla="val 3500"/>
             </a:avLst>
           </a:prstGeom>
           <a:solidFill>
@@ -4322,8 +4313,8 @@
         </p:nvSpPr>
         <p:spPr>
           <a:xfrm>
-            <a:off x="5111496" y="1892808"/>
-            <a:ext cx="91440" cy="91440"/>
+            <a:off x="5170932" y="2235708"/>
+            <a:ext cx="100584" cy="100584"/>
           </a:xfrm>
           <a:prstGeom prst="ellipse">
             <a:avLst/>
@@ -4366,8 +4357,8 @@
         </p:nvSpPr>
         <p:spPr>
           <a:xfrm>
-            <a:off x="5303520" y="1847088"/>
-            <a:ext cx="822960" cy="201168"/>
+            <a:off x="5385816" y="2185416"/>
+            <a:ext cx="914400" cy="219456"/>
           </a:xfrm>
           <a:prstGeom prst="rect">
             <a:avLst/>
@@ -4382,13 +4373,13 @@
           <a:p>
             <a:pPr algn="l"/>
             <a:r>
-              <a:rPr sz="850" b="0" spc="140">
+              <a:rPr sz="900" b="0" spc="140">
                 <a:solidFill>
                   <a:srgbClr val="13C9BA"/>
                 </a:solidFill>
                 <a:latin typeface="Courier New"/>
               </a:rPr>
-              <a:t>01-04</a:t>
+              <a:t>01–04</a:t>
             </a:r>
           </a:p>
         </p:txBody>
@@ -4401,8 +4392,8 @@
         </p:nvSpPr>
         <p:spPr>
           <a:xfrm>
-            <a:off x="5138928" y="2075688"/>
-            <a:ext cx="2240280" cy="274320"/>
+            <a:off x="5202936" y="2432304"/>
+            <a:ext cx="2331720" cy="310896"/>
           </a:xfrm>
           <a:prstGeom prst="rect">
             <a:avLst/>
@@ -4417,7 +4408,7 @@
           <a:p>
             <a:pPr algn="l"/>
             <a:r>
-              <a:rPr sz="1300" b="1">
+              <a:rPr sz="1450" b="1">
                 <a:solidFill>
                   <a:srgbClr val="F6F7F9"/>
                 </a:solidFill>
@@ -4436,8 +4427,8 @@
         </p:nvSpPr>
         <p:spPr>
           <a:xfrm>
-            <a:off x="5138928" y="2404872"/>
-            <a:ext cx="2514600" cy="960119"/>
+            <a:off x="5202936" y="2816352"/>
+            <a:ext cx="2276856" cy="1097280"/>
           </a:xfrm>
           <a:prstGeom prst="rect">
             <a:avLst/>
@@ -4456,13 +4447,13 @@
               </a:lnSpc>
             </a:pPr>
             <a:r>
-              <a:rPr sz="950" b="0">
+              <a:rPr sz="1100" b="0">
                 <a:solidFill>
-                  <a:srgbClr val="ABB3BF"/>
+                  <a:srgbClr val="C5CBD3"/>
                 </a:solidFill>
                 <a:latin typeface="Calibri"/>
               </a:rPr>
-              <a:t>Four stages on Databricks. Extract is the single Claude call; parse, audit, gate and render are code.</a:t>
+              <a:t>Four stages on Databricks. Extract is the single Claude call; parsing, grounding audit, gate and render are code.</a:t>
             </a:r>
           </a:p>
         </p:txBody>
@@ -4475,12 +4466,12 @@
         </p:nvSpPr>
         <p:spPr>
           <a:xfrm>
-            <a:off x="8138160" y="1691640"/>
-            <a:ext cx="1874519" cy="1783080"/>
+            <a:off x="7955279" y="2011680"/>
+            <a:ext cx="1783080" cy="2788920"/>
           </a:xfrm>
           <a:prstGeom prst="roundRect">
             <a:avLst>
-              <a:gd name="adj" fmla="val 4000"/>
+              <a:gd name="adj" fmla="val 3500"/>
             </a:avLst>
           </a:prstGeom>
           <a:solidFill>
@@ -4521,8 +4512,8 @@
         </p:nvSpPr>
         <p:spPr>
           <a:xfrm>
-            <a:off x="8311896" y="1892808"/>
-            <a:ext cx="91440" cy="91440"/>
+            <a:off x="8142731" y="2235708"/>
+            <a:ext cx="100584" cy="100584"/>
           </a:xfrm>
           <a:prstGeom prst="ellipse">
             <a:avLst/>
@@ -4565,8 +4556,8 @@
         </p:nvSpPr>
         <p:spPr>
           <a:xfrm>
-            <a:off x="8503920" y="1847088"/>
-            <a:ext cx="822960" cy="201168"/>
+            <a:off x="8357615" y="2185416"/>
+            <a:ext cx="914400" cy="219456"/>
           </a:xfrm>
           <a:prstGeom prst="rect">
             <a:avLst/>
@@ -4581,7 +4572,7 @@
           <a:p>
             <a:pPr algn="l"/>
             <a:r>
-              <a:rPr sz="850" b="0" spc="140">
+              <a:rPr sz="900" b="0" spc="140">
                 <a:solidFill>
                   <a:srgbClr val="F0B726"/>
                 </a:solidFill>
@@ -4600,8 +4591,8 @@
         </p:nvSpPr>
         <p:spPr>
           <a:xfrm>
-            <a:off x="8339328" y="2075688"/>
-            <a:ext cx="1234439" cy="274320"/>
+            <a:off x="8174736" y="2432304"/>
+            <a:ext cx="1417319" cy="310896"/>
           </a:xfrm>
           <a:prstGeom prst="rect">
             <a:avLst/>
@@ -4616,7 +4607,7 @@
           <a:p>
             <a:pPr algn="l"/>
             <a:r>
-              <a:rPr sz="1300" b="1">
+              <a:rPr sz="1450" b="1">
                 <a:solidFill>
                   <a:srgbClr val="F6F7F9"/>
                 </a:solidFill>
@@ -4636,14 +4627,14 @@
           <p:nvPr/>
         </p:nvPicPr>
         <p:blipFill>
-          <a:blip r:embed="rId5"/>
+          <a:blip r:embed="rId6"/>
           <a:stretch>
             <a:fillRect/>
           </a:stretch>
         </p:blipFill>
         <p:spPr>
           <a:xfrm>
-            <a:off x="9537192" y="1847088"/>
+            <a:off x="9262872" y="2157984"/>
             <a:ext cx="274320" cy="274320"/>
           </a:xfrm>
           <a:prstGeom prst="rect">
@@ -4659,8 +4650,8 @@
         </p:nvSpPr>
         <p:spPr>
           <a:xfrm>
-            <a:off x="8339328" y="2404872"/>
-            <a:ext cx="1508760" cy="960119"/>
+            <a:off x="8174736" y="2816352"/>
+            <a:ext cx="1362456" cy="1097280"/>
           </a:xfrm>
           <a:prstGeom prst="rect">
             <a:avLst/>
@@ -4679,9 +4670,9 @@
               </a:lnSpc>
             </a:pPr>
             <a:r>
-              <a:rPr sz="950" b="0">
+              <a:rPr sz="1100" b="0">
                 <a:solidFill>
-                  <a:srgbClr val="ABB3BF"/>
+                  <a:srgbClr val="C5CBD3"/>
                 </a:solidFill>
                 <a:latin typeface="Calibri"/>
               </a:rPr>
@@ -4698,12 +4689,12 @@
         </p:nvSpPr>
         <p:spPr>
           <a:xfrm>
-            <a:off x="10332720" y="1691640"/>
-            <a:ext cx="1325880" cy="1783080"/>
+            <a:off x="10012680" y="2011680"/>
+            <a:ext cx="1627632" cy="2788920"/>
           </a:xfrm>
           <a:prstGeom prst="roundRect">
             <a:avLst>
-              <a:gd name="adj" fmla="val 4000"/>
+              <a:gd name="adj" fmla="val 3500"/>
             </a:avLst>
           </a:prstGeom>
           <a:solidFill>
@@ -4744,8 +4735,8 @@
         </p:nvSpPr>
         <p:spPr>
           <a:xfrm>
-            <a:off x="10506456" y="1892808"/>
-            <a:ext cx="91440" cy="91440"/>
+            <a:off x="10200132" y="2235708"/>
+            <a:ext cx="100584" cy="100584"/>
           </a:xfrm>
           <a:prstGeom prst="ellipse">
             <a:avLst/>
@@ -4788,8 +4779,8 @@
         </p:nvSpPr>
         <p:spPr>
           <a:xfrm>
-            <a:off x="10698480" y="1847088"/>
-            <a:ext cx="822960" cy="201168"/>
+            <a:off x="10415015" y="2185416"/>
+            <a:ext cx="914400" cy="219456"/>
           </a:xfrm>
           <a:prstGeom prst="rect">
             <a:avLst/>
@@ -4804,7 +4795,7 @@
           <a:p>
             <a:pPr algn="l"/>
             <a:r>
-              <a:rPr sz="850" b="0" spc="140">
+              <a:rPr sz="900" b="0" spc="140">
                 <a:solidFill>
                   <a:srgbClr val="9881F3"/>
                 </a:solidFill>
@@ -4823,8 +4814,8 @@
         </p:nvSpPr>
         <p:spPr>
           <a:xfrm>
-            <a:off x="10533888" y="2075688"/>
-            <a:ext cx="685800" cy="274320"/>
+            <a:off x="10232136" y="2432304"/>
+            <a:ext cx="1261872" cy="310896"/>
           </a:xfrm>
           <a:prstGeom prst="rect">
             <a:avLst/>
@@ -4839,7 +4830,7 @@
           <a:p>
             <a:pPr algn="l"/>
             <a:r>
-              <a:rPr sz="1300" b="1">
+              <a:rPr sz="1450" b="1">
                 <a:solidFill>
                   <a:srgbClr val="F6F7F9"/>
                 </a:solidFill>
@@ -4859,14 +4850,14 @@
           <p:nvPr/>
         </p:nvPicPr>
         <p:blipFill>
-          <a:blip r:embed="rId6"/>
+          <a:blip r:embed="rId7"/>
           <a:stretch>
             <a:fillRect/>
           </a:stretch>
         </p:blipFill>
         <p:spPr>
           <a:xfrm>
-            <a:off x="11183112" y="1847088"/>
+            <a:off x="11164824" y="2157984"/>
             <a:ext cx="274320" cy="274320"/>
           </a:xfrm>
           <a:prstGeom prst="rect">
@@ -4882,8 +4873,8 @@
         </p:nvSpPr>
         <p:spPr>
           <a:xfrm>
-            <a:off x="10533888" y="2404872"/>
-            <a:ext cx="960119" cy="960119"/>
+            <a:off x="10232136" y="2816352"/>
+            <a:ext cx="1207008" cy="1097280"/>
           </a:xfrm>
           <a:prstGeom prst="rect">
             <a:avLst/>
@@ -4902,9 +4893,9 @@
               </a:lnSpc>
             </a:pPr>
             <a:r>
-              <a:rPr sz="950" b="0">
+              <a:rPr sz="1100" b="0">
                 <a:solidFill>
-                  <a:srgbClr val="ABB3BF"/>
+                  <a:srgbClr val="C5CBD3"/>
                 </a:solidFill>
                 <a:latin typeface="Calibri"/>
               </a:rPr>
@@ -4921,12 +4912,12 @@
         </p:nvSpPr>
         <p:spPr>
           <a:xfrm>
-            <a:off x="5138928" y="2907791"/>
-            <a:ext cx="550926" cy="384048"/>
+            <a:off x="10158984" y="3758183"/>
+            <a:ext cx="1335024" cy="896112"/>
           </a:xfrm>
           <a:prstGeom prst="roundRect">
             <a:avLst>
-              <a:gd name="adj" fmla="val 12000"/>
+              <a:gd name="adj" fmla="val 3000"/>
             </a:avLst>
           </a:prstGeom>
           <a:solidFill>
@@ -4934,7 +4925,7 @@
           </a:solidFill>
           <a:ln w="9525">
             <a:solidFill>
-              <a:srgbClr val="383E47"/>
+              <a:srgbClr val="404854"/>
             </a:solidFill>
           </a:ln>
           <a:effectLst/>
@@ -4959,16 +4950,86 @@
           <a:p/>
         </p:txBody>
       </p:sp>
-      <p:sp>
-        <p:nvSpPr>
-          <p:cNvPr id="52" name="TextBox 51"/>
+      <p:pic>
+        <p:nvPicPr>
+          <p:cNvPr id="52" name="Picture 51" descr="sttm_sheet.png"/>
+          <p:cNvPicPr>
+            <a:picLocks noChangeAspect="1"/>
+          </p:cNvPicPr>
+          <p:nvPr/>
+        </p:nvPicPr>
+        <p:blipFill>
+          <a:blip r:embed="rId8"/>
+          <a:stretch>
+            <a:fillRect/>
+          </a:stretch>
+        </p:blipFill>
+        <p:spPr>
+          <a:xfrm>
+            <a:off x="10177272" y="3788881"/>
+            <a:ext cx="1298448" cy="834716"/>
+          </a:xfrm>
+          <a:prstGeom prst="rect">
+            <a:avLst/>
+          </a:prstGeom>
+        </p:spPr>
+      </p:pic>
+      <p:sp>
+        <p:nvSpPr>
+          <p:cNvPr id="53" name="Rounded Rectangle 52"/>
+          <p:cNvSpPr/>
+          <p:nvPr/>
+        </p:nvSpPr>
+        <p:spPr>
+          <a:xfrm>
+            <a:off x="5202936" y="3904487"/>
+            <a:ext cx="496062" cy="457200"/>
+          </a:xfrm>
+          <a:prstGeom prst="roundRect">
+            <a:avLst>
+              <a:gd name="adj" fmla="val 10000"/>
+            </a:avLst>
+          </a:prstGeom>
+          <a:solidFill>
+            <a:srgbClr val="252A31"/>
+          </a:solidFill>
+          <a:ln w="9525">
+            <a:solidFill>
+              <a:srgbClr val="404854"/>
+            </a:solidFill>
+          </a:ln>
+          <a:effectLst/>
+        </p:spPr>
+        <p:style>
+          <a:lnRef idx="1">
+            <a:schemeClr val="accent1"/>
+          </a:lnRef>
+          <a:fillRef idx="3">
+            <a:schemeClr val="accent1"/>
+          </a:fillRef>
+          <a:effectRef idx="2">
+            <a:schemeClr val="accent1"/>
+          </a:effectRef>
+          <a:fontRef idx="minor">
+            <a:schemeClr val="lt1"/>
+          </a:fontRef>
+        </p:style>
+        <p:txBody>
+          <a:bodyPr rtlCol="0" anchor="ctr"/>
+          <a:lstStyle/>
+          <a:p/>
+        </p:txBody>
+      </p:sp>
+      <p:sp>
+        <p:nvSpPr>
+          <p:cNvPr id="54" name="TextBox 53"/>
           <p:cNvSpPr txBox="1"/>
           <p:nvPr/>
         </p:nvSpPr>
         <p:spPr>
           <a:xfrm>
-            <a:off x="5138928" y="2962656"/>
-            <a:ext cx="550926" cy="137160"/>
+            <a:off x="5202936" y="3968496"/>
+            <a:ext cx="496062" cy="164592"/>
           </a:xfrm>
           <a:prstGeom prst="rect">
             <a:avLst/>
@@ -4983,7 +5044,7 @@
           <a:p>
             <a:pPr algn="ctr"/>
             <a:r>
-              <a:rPr sz="750" b="0">
+              <a:rPr sz="850" b="0">
                 <a:solidFill>
                   <a:srgbClr val="13C9BA"/>
                 </a:solidFill>
@@ -4996,14 +5057,14 @@
       </p:sp>
       <p:sp>
         <p:nvSpPr>
-          <p:cNvPr id="53" name="TextBox 52"/>
+          <p:cNvPr id="55" name="TextBox 54"/>
           <p:cNvSpPr txBox="1"/>
           <p:nvPr/>
         </p:nvSpPr>
         <p:spPr>
           <a:xfrm>
-            <a:off x="5138928" y="3090672"/>
-            <a:ext cx="550926" cy="182880"/>
+            <a:off x="5202936" y="4123944"/>
+            <a:ext cx="496062" cy="201168"/>
           </a:xfrm>
           <a:prstGeom prst="rect">
             <a:avLst/>
@@ -5018,9 +5079,9 @@
           <a:p>
             <a:pPr algn="ctr"/>
             <a:r>
-              <a:rPr sz="850" b="0">
+              <a:rPr sz="950" b="0">
                 <a:solidFill>
-                  <a:srgbClr val="C5CBD3"/>
+                  <a:srgbClr val="F6F7F9"/>
                 </a:solidFill>
                 <a:latin typeface="Calibri"/>
               </a:rPr>
@@ -5031,13 +5092,13 @@
       </p:sp>
       <p:cxnSp>
         <p:nvCxnSpPr>
-          <p:cNvPr id="54" name="Connector 53"/>
+          <p:cNvPr id="56" name="Connector 55"/>
           <p:cNvCxnSpPr/>
           <p:nvPr/>
         </p:nvCxnSpPr>
         <p:spPr>
           <a:xfrm>
-            <a:off x="5698998" y="3099815"/>
+            <a:off x="5708142" y="4133087"/>
             <a:ext cx="73152" cy="0"/>
           </a:xfrm>
           <a:prstGeom prst="line">
@@ -5045,7 +5106,7 @@
           </a:prstGeom>
           <a:ln w="9525">
             <a:solidFill>
-              <a:srgbClr val="5F6B7C"/>
+              <a:srgbClr val="404854"/>
             </a:solidFill>
             <a:tailEnd type="triangle" w="sm" len="sm"/>
           </a:ln>
@@ -5067,26 +5128,26 @@
       </p:cxnSp>
       <p:sp>
         <p:nvSpPr>
-          <p:cNvPr id="55" name="Rounded Rectangle 54"/>
+          <p:cNvPr id="57" name="Rounded Rectangle 56"/>
           <p:cNvSpPr/>
           <p:nvPr/>
         </p:nvSpPr>
         <p:spPr>
           <a:xfrm>
-            <a:off x="5781294" y="2907791"/>
-            <a:ext cx="550926" cy="384048"/>
+            <a:off x="5790438" y="3904487"/>
+            <a:ext cx="496062" cy="457200"/>
           </a:xfrm>
           <a:prstGeom prst="roundRect">
             <a:avLst>
-              <a:gd name="adj" fmla="val 12000"/>
+              <a:gd name="adj" fmla="val 10000"/>
             </a:avLst>
           </a:prstGeom>
           <a:solidFill>
-            <a:srgbClr val="252A31"/>
+            <a:srgbClr val="8A4A36"/>
           </a:solidFill>
-          <a:ln w="9525">
+          <a:ln w="12700">
             <a:solidFill>
-              <a:srgbClr val="0F6894"/>
+              <a:srgbClr val="D97757"/>
             </a:solidFill>
           </a:ln>
           <a:effectLst/>
@@ -5113,14 +5174,14 @@
       </p:sp>
       <p:sp>
         <p:nvSpPr>
-          <p:cNvPr id="56" name="TextBox 55"/>
+          <p:cNvPr id="58" name="TextBox 57"/>
           <p:cNvSpPr txBox="1"/>
           <p:nvPr/>
         </p:nvSpPr>
         <p:spPr>
           <a:xfrm>
-            <a:off x="5781294" y="2962656"/>
-            <a:ext cx="550926" cy="137160"/>
+            <a:off x="5790438" y="3968496"/>
+            <a:ext cx="496062" cy="164592"/>
           </a:xfrm>
           <a:prstGeom prst="rect">
             <a:avLst/>
@@ -5135,9 +5196,9 @@
           <a:p>
             <a:pPr algn="ctr"/>
             <a:r>
-              <a:rPr sz="750" b="0">
+              <a:rPr sz="850" b="0">
                 <a:solidFill>
-                  <a:srgbClr val="3FA6DA"/>
+                  <a:srgbClr val="F6F7F9"/>
                 </a:solidFill>
                 <a:latin typeface="Courier New"/>
               </a:rPr>
@@ -5148,14 +5209,14 @@
       </p:sp>
       <p:sp>
         <p:nvSpPr>
-          <p:cNvPr id="57" name="TextBox 56"/>
+          <p:cNvPr id="59" name="TextBox 58"/>
           <p:cNvSpPr txBox="1"/>
           <p:nvPr/>
         </p:nvSpPr>
         <p:spPr>
           <a:xfrm>
-            <a:off x="5781294" y="3090672"/>
-            <a:ext cx="550926" cy="182880"/>
+            <a:off x="5790438" y="4123944"/>
+            <a:ext cx="496062" cy="201168"/>
           </a:xfrm>
           <a:prstGeom prst="rect">
             <a:avLst/>
@@ -5170,7 +5231,7 @@
           <a:p>
             <a:pPr algn="ctr"/>
             <a:r>
-              <a:rPr sz="850" b="1">
+              <a:rPr sz="950" b="1">
                 <a:solidFill>
                   <a:srgbClr val="F6F7F9"/>
                 </a:solidFill>
@@ -5183,13 +5244,13 @@
       </p:sp>
       <p:cxnSp>
         <p:nvCxnSpPr>
-          <p:cNvPr id="58" name="Connector 57"/>
+          <p:cNvPr id="60" name="Connector 59"/>
           <p:cNvCxnSpPr/>
           <p:nvPr/>
         </p:nvCxnSpPr>
         <p:spPr>
           <a:xfrm>
-            <a:off x="6341364" y="3099815"/>
+            <a:off x="6295644" y="4133087"/>
             <a:ext cx="73152" cy="0"/>
           </a:xfrm>
           <a:prstGeom prst="line">
@@ -5197,7 +5258,7 @@
           </a:prstGeom>
           <a:ln w="9525">
             <a:solidFill>
-              <a:srgbClr val="5F6B7C"/>
+              <a:srgbClr val="404854"/>
             </a:solidFill>
             <a:tailEnd type="triangle" w="sm" len="sm"/>
           </a:ln>
@@ -5219,18 +5280,18 @@
       </p:cxnSp>
       <p:sp>
         <p:nvSpPr>
-          <p:cNvPr id="59" name="Rounded Rectangle 58"/>
+          <p:cNvPr id="61" name="Rounded Rectangle 60"/>
           <p:cNvSpPr/>
           <p:nvPr/>
         </p:nvSpPr>
         <p:spPr>
           <a:xfrm>
-            <a:off x="6423660" y="2907791"/>
-            <a:ext cx="550926" cy="384048"/>
+            <a:off x="6377940" y="3904487"/>
+            <a:ext cx="496062" cy="457200"/>
           </a:xfrm>
           <a:prstGeom prst="roundRect">
             <a:avLst>
-              <a:gd name="adj" fmla="val 12000"/>
+              <a:gd name="adj" fmla="val 10000"/>
             </a:avLst>
           </a:prstGeom>
           <a:solidFill>
@@ -5238,7 +5299,7 @@
           </a:solidFill>
           <a:ln w="9525">
             <a:solidFill>
-              <a:srgbClr val="383E47"/>
+              <a:srgbClr val="404854"/>
             </a:solidFill>
           </a:ln>
           <a:effectLst/>
@@ -5265,14 +5326,14 @@
       </p:sp>
       <p:sp>
         <p:nvSpPr>
-          <p:cNvPr id="60" name="TextBox 59"/>
+          <p:cNvPr id="62" name="TextBox 61"/>
           <p:cNvSpPr txBox="1"/>
           <p:nvPr/>
         </p:nvSpPr>
         <p:spPr>
           <a:xfrm>
-            <a:off x="6423660" y="2962656"/>
-            <a:ext cx="550926" cy="137160"/>
+            <a:off x="6377940" y="3968496"/>
+            <a:ext cx="496062" cy="164592"/>
           </a:xfrm>
           <a:prstGeom prst="rect">
             <a:avLst/>
@@ -5287,7 +5348,7 @@
           <a:p>
             <a:pPr algn="ctr"/>
             <a:r>
-              <a:rPr sz="750" b="0">
+              <a:rPr sz="850" b="0">
                 <a:solidFill>
                   <a:srgbClr val="13C9BA"/>
                 </a:solidFill>
@@ -5300,14 +5361,14 @@
       </p:sp>
       <p:sp>
         <p:nvSpPr>
-          <p:cNvPr id="61" name="TextBox 60"/>
+          <p:cNvPr id="63" name="TextBox 62"/>
           <p:cNvSpPr txBox="1"/>
           <p:nvPr/>
         </p:nvSpPr>
         <p:spPr>
           <a:xfrm>
-            <a:off x="6423660" y="3090672"/>
-            <a:ext cx="550926" cy="182880"/>
+            <a:off x="6377940" y="4123944"/>
+            <a:ext cx="496062" cy="201168"/>
           </a:xfrm>
           <a:prstGeom prst="rect">
             <a:avLst/>
@@ -5322,26 +5383,26 @@
           <a:p>
             <a:pPr algn="ctr"/>
             <a:r>
-              <a:rPr sz="850" b="0">
+              <a:rPr sz="950" b="0">
                 <a:solidFill>
-                  <a:srgbClr val="C5CBD3"/>
+                  <a:srgbClr val="F6F7F9"/>
                 </a:solidFill>
                 <a:latin typeface="Calibri"/>
               </a:rPr>
-              <a:t>Audit · gate</a:t>
+              <a:t>Audit</a:t>
             </a:r>
           </a:p>
         </p:txBody>
       </p:sp>
       <p:cxnSp>
         <p:nvCxnSpPr>
-          <p:cNvPr id="62" name="Connector 61"/>
+          <p:cNvPr id="64" name="Connector 63"/>
           <p:cNvCxnSpPr/>
           <p:nvPr/>
         </p:nvCxnSpPr>
         <p:spPr>
           <a:xfrm>
-            <a:off x="6983730" y="3099815"/>
+            <a:off x="6883146" y="4133087"/>
             <a:ext cx="73152" cy="0"/>
           </a:xfrm>
           <a:prstGeom prst="line">
@@ -5349,7 +5410,7 @@
           </a:prstGeom>
           <a:ln w="9525">
             <a:solidFill>
-              <a:srgbClr val="5F6B7C"/>
+              <a:srgbClr val="404854"/>
             </a:solidFill>
             <a:tailEnd type="triangle" w="sm" len="sm"/>
           </a:ln>
@@ -5371,18 +5432,18 @@
       </p:cxnSp>
       <p:sp>
         <p:nvSpPr>
-          <p:cNvPr id="63" name="Rounded Rectangle 62"/>
+          <p:cNvPr id="65" name="Rounded Rectangle 64"/>
           <p:cNvSpPr/>
           <p:nvPr/>
         </p:nvSpPr>
         <p:spPr>
           <a:xfrm>
-            <a:off x="7066026" y="2907791"/>
-            <a:ext cx="550926" cy="384048"/>
+            <a:off x="6965442" y="3904487"/>
+            <a:ext cx="496062" cy="457200"/>
           </a:xfrm>
           <a:prstGeom prst="roundRect">
             <a:avLst>
-              <a:gd name="adj" fmla="val 12000"/>
+              <a:gd name="adj" fmla="val 10000"/>
             </a:avLst>
           </a:prstGeom>
           <a:solidFill>
@@ -5390,7 +5451,7 @@
           </a:solidFill>
           <a:ln w="9525">
             <a:solidFill>
-              <a:srgbClr val="383E47"/>
+              <a:srgbClr val="404854"/>
             </a:solidFill>
           </a:ln>
           <a:effectLst/>
@@ -5417,14 +5478,14 @@
       </p:sp>
       <p:sp>
         <p:nvSpPr>
-          <p:cNvPr id="64" name="TextBox 63"/>
+          <p:cNvPr id="66" name="TextBox 65"/>
           <p:cNvSpPr txBox="1"/>
           <p:nvPr/>
         </p:nvSpPr>
         <p:spPr>
           <a:xfrm>
-            <a:off x="7066026" y="2962656"/>
-            <a:ext cx="550926" cy="137160"/>
+            <a:off x="6965442" y="3968496"/>
+            <a:ext cx="496062" cy="164592"/>
           </a:xfrm>
           <a:prstGeom prst="rect">
             <a:avLst/>
@@ -5439,7 +5500,7 @@
           <a:p>
             <a:pPr algn="ctr"/>
             <a:r>
-              <a:rPr sz="750" b="0">
+              <a:rPr sz="850" b="0">
                 <a:solidFill>
                   <a:srgbClr val="13C9BA"/>
                 </a:solidFill>
@@ -5452,14 +5513,14 @@
       </p:sp>
       <p:sp>
         <p:nvSpPr>
-          <p:cNvPr id="65" name="TextBox 64"/>
+          <p:cNvPr id="67" name="TextBox 66"/>
           <p:cNvSpPr txBox="1"/>
           <p:nvPr/>
         </p:nvSpPr>
         <p:spPr>
           <a:xfrm>
-            <a:off x="7066026" y="3090672"/>
-            <a:ext cx="550926" cy="182880"/>
+            <a:off x="6965442" y="4123944"/>
+            <a:ext cx="496062" cy="201168"/>
           </a:xfrm>
           <a:prstGeom prst="rect">
             <a:avLst/>
@@ -5474,9 +5535,9 @@
           <a:p>
             <a:pPr algn="ctr"/>
             <a:r>
-              <a:rPr sz="850" b="0">
+              <a:rPr sz="950" b="0">
                 <a:solidFill>
-                  <a:srgbClr val="C5CBD3"/>
+                  <a:srgbClr val="F6F7F9"/>
                 </a:solidFill>
                 <a:latin typeface="Calibri"/>
               </a:rPr>
@@ -5485,114 +5546,41 @@
           </a:p>
         </p:txBody>
       </p:sp>
-      <p:cxnSp>
-        <p:nvCxnSpPr>
-          <p:cNvPr id="66" name="Connector 65"/>
-          <p:cNvCxnSpPr/>
-          <p:nvPr/>
-        </p:nvCxnSpPr>
-        <p:spPr>
-          <a:xfrm>
-            <a:off x="2441448" y="2194560"/>
-            <a:ext cx="283464" cy="0"/>
-          </a:xfrm>
-          <a:prstGeom prst="line">
-            <a:avLst/>
-          </a:prstGeom>
-          <a:ln w="12700">
-            <a:solidFill>
-              <a:srgbClr val="738091"/>
-            </a:solidFill>
-            <a:tailEnd type="triangle" w="sm" len="sm"/>
-          </a:ln>
-        </p:spPr>
-        <p:style>
-          <a:lnRef idx="2">
-            <a:schemeClr val="accent1"/>
-          </a:lnRef>
-          <a:fillRef idx="0">
-            <a:schemeClr val="accent1"/>
-          </a:fillRef>
-          <a:effectRef idx="1">
-            <a:schemeClr val="accent1"/>
-          </a:effectRef>
-          <a:fontRef idx="minor">
-            <a:schemeClr val="tx1"/>
-          </a:fontRef>
-        </p:style>
-      </p:cxnSp>
-      <p:cxnSp>
-        <p:nvCxnSpPr>
-          <p:cNvPr id="67" name="Connector 66"/>
-          <p:cNvCxnSpPr/>
-          <p:nvPr/>
-        </p:nvCxnSpPr>
-        <p:spPr>
-          <a:xfrm>
-            <a:off x="4636007" y="2194560"/>
-            <a:ext cx="283465" cy="0"/>
-          </a:xfrm>
-          <a:prstGeom prst="line">
-            <a:avLst/>
-          </a:prstGeom>
-          <a:ln w="12700">
-            <a:solidFill>
-              <a:srgbClr val="738091"/>
-            </a:solidFill>
-            <a:tailEnd type="triangle" w="sm" len="sm"/>
-          </a:ln>
-        </p:spPr>
-        <p:style>
-          <a:lnRef idx="2">
-            <a:schemeClr val="accent1"/>
-          </a:lnRef>
-          <a:fillRef idx="0">
-            <a:schemeClr val="accent1"/>
-          </a:fillRef>
-          <a:effectRef idx="1">
-            <a:schemeClr val="accent1"/>
-          </a:effectRef>
-          <a:fontRef idx="minor">
-            <a:schemeClr val="tx1"/>
-          </a:fontRef>
-        </p:style>
-      </p:cxnSp>
-      <p:cxnSp>
-        <p:nvCxnSpPr>
-          <p:cNvPr id="68" name="Connector 67"/>
-          <p:cNvCxnSpPr/>
-          <p:nvPr/>
-        </p:nvCxnSpPr>
-        <p:spPr>
-          <a:xfrm>
-            <a:off x="7836408" y="2194560"/>
-            <a:ext cx="283464" cy="0"/>
-          </a:xfrm>
-          <a:prstGeom prst="line">
-            <a:avLst/>
-          </a:prstGeom>
-          <a:ln w="12700">
-            <a:solidFill>
-              <a:srgbClr val="738091"/>
-            </a:solidFill>
-            <a:tailEnd type="triangle" w="sm" len="sm"/>
-          </a:ln>
-        </p:spPr>
-        <p:style>
-          <a:lnRef idx="2">
-            <a:schemeClr val="accent1"/>
-          </a:lnRef>
-          <a:fillRef idx="0">
-            <a:schemeClr val="accent1"/>
-          </a:fillRef>
-          <a:effectRef idx="1">
-            <a:schemeClr val="accent1"/>
-          </a:effectRef>
-          <a:fontRef idx="minor">
-            <a:schemeClr val="tx1"/>
-          </a:fontRef>
-        </p:style>
-      </p:cxnSp>
+      <p:sp>
+        <p:nvSpPr>
+          <p:cNvPr id="68" name="TextBox 67"/>
+          <p:cNvSpPr txBox="1"/>
+          <p:nvPr/>
+        </p:nvSpPr>
+        <p:spPr>
+          <a:xfrm>
+            <a:off x="5202936" y="4453127"/>
+            <a:ext cx="2258568" cy="219456"/>
+          </a:xfrm>
+          <a:prstGeom prst="rect">
+            <a:avLst/>
+          </a:prstGeom>
+          <a:noFill/>
+        </p:spPr>
+        <p:txBody>
+          <a:bodyPr wrap="square" lIns="0" rIns="0" tIns="0" bIns="0" anchor="t">
+            <a:spAutoFit/>
+          </a:bodyPr>
+          <a:lstStyle/>
+          <a:p>
+            <a:pPr algn="ctr"/>
+            <a:r>
+              <a:rPr sz="950" b="0">
+                <a:solidFill>
+                  <a:srgbClr val="D97757"/>
+                </a:solidFill>
+                <a:latin typeface="Calibri"/>
+              </a:rPr>
+              <a:t>02 is the only model call</a:t>
+            </a:r>
+          </a:p>
+        </p:txBody>
+      </p:sp>
       <p:cxnSp>
         <p:nvCxnSpPr>
           <p:cNvPr id="69" name="Connector 68"/>
@@ -5601,15 +5589,15 @@
         </p:nvCxnSpPr>
         <p:spPr>
           <a:xfrm>
-            <a:off x="10030967" y="2194560"/>
-            <a:ext cx="283465" cy="0"/>
+            <a:off x="2578608" y="2560320"/>
+            <a:ext cx="237744" cy="0"/>
           </a:xfrm>
           <a:prstGeom prst="line">
             <a:avLst/>
           </a:prstGeom>
           <a:ln w="12700">
             <a:solidFill>
-              <a:srgbClr val="738091"/>
+              <a:srgbClr val="8F99A8"/>
             </a:solidFill>
             <a:tailEnd type="triangle" w="sm" len="sm"/>
           </a:ln>
@@ -5637,17 +5625,17 @@
         </p:nvCxnSpPr>
         <p:spPr>
           <a:xfrm>
-            <a:off x="8686800" y="3474720"/>
-            <a:ext cx="0" cy="182880"/>
+            <a:off x="4727448" y="2560320"/>
+            <a:ext cx="237744" cy="0"/>
           </a:xfrm>
           <a:prstGeom prst="line">
             <a:avLst/>
           </a:prstGeom>
           <a:ln w="12700">
             <a:solidFill>
-              <a:srgbClr val="866103"/>
+              <a:srgbClr val="8F99A8"/>
             </a:solidFill>
-            <a:prstDash val="dash"/>
+            <a:tailEnd type="triangle" w="sm" len="sm"/>
           </a:ln>
         </p:spPr>
         <p:style>
@@ -5672,18 +5660,18 @@
           <p:nvPr/>
         </p:nvCxnSpPr>
         <p:spPr>
-          <a:xfrm flipH="1">
-            <a:off x="1097280" y="3657600"/>
-            <a:ext cx="7589520" cy="0"/>
+          <a:xfrm>
+            <a:off x="7699248" y="2560320"/>
+            <a:ext cx="237744" cy="0"/>
           </a:xfrm>
           <a:prstGeom prst="line">
             <a:avLst/>
           </a:prstGeom>
           <a:ln w="12700">
             <a:solidFill>
-              <a:srgbClr val="866103"/>
+              <a:srgbClr val="8F99A8"/>
             </a:solidFill>
-            <a:prstDash val="dash"/>
+            <a:tailEnd type="triangle" w="sm" len="sm"/>
           </a:ln>
         </p:spPr>
         <p:style>
@@ -5708,14 +5696,122 @@
           <p:nvPr/>
         </p:nvCxnSpPr>
         <p:spPr>
+          <a:xfrm>
+            <a:off x="9756647" y="2560320"/>
+            <a:ext cx="237745" cy="0"/>
+          </a:xfrm>
+          <a:prstGeom prst="line">
+            <a:avLst/>
+          </a:prstGeom>
+          <a:ln w="12700">
+            <a:solidFill>
+              <a:srgbClr val="8F99A8"/>
+            </a:solidFill>
+            <a:tailEnd type="triangle" w="sm" len="sm"/>
+          </a:ln>
+        </p:spPr>
+        <p:style>
+          <a:lnRef idx="2">
+            <a:schemeClr val="accent1"/>
+          </a:lnRef>
+          <a:fillRef idx="0">
+            <a:schemeClr val="accent1"/>
+          </a:fillRef>
+          <a:effectRef idx="1">
+            <a:schemeClr val="accent1"/>
+          </a:effectRef>
+          <a:fontRef idx="minor">
+            <a:schemeClr val="tx1"/>
+          </a:fontRef>
+        </p:style>
+      </p:cxnSp>
+      <p:cxnSp>
+        <p:nvCxnSpPr>
+          <p:cNvPr id="73" name="Connector 72"/>
+          <p:cNvCxnSpPr/>
+          <p:nvPr/>
+        </p:nvCxnSpPr>
+        <p:spPr>
+          <a:xfrm>
+            <a:off x="8595359" y="4800600"/>
+            <a:ext cx="0" cy="237744"/>
+          </a:xfrm>
+          <a:prstGeom prst="line">
+            <a:avLst/>
+          </a:prstGeom>
+          <a:ln w="15875">
+            <a:solidFill>
+              <a:srgbClr val="866103"/>
+            </a:solidFill>
+            <a:prstDash val="dash"/>
+          </a:ln>
+        </p:spPr>
+        <p:style>
+          <a:lnRef idx="2">
+            <a:schemeClr val="accent1"/>
+          </a:lnRef>
+          <a:fillRef idx="0">
+            <a:schemeClr val="accent1"/>
+          </a:fillRef>
+          <a:effectRef idx="1">
+            <a:schemeClr val="accent1"/>
+          </a:effectRef>
+          <a:fontRef idx="minor">
+            <a:schemeClr val="tx1"/>
+          </a:fontRef>
+        </p:style>
+      </p:cxnSp>
+      <p:cxnSp>
+        <p:nvCxnSpPr>
+          <p:cNvPr id="74" name="Connector 73"/>
+          <p:cNvCxnSpPr/>
+          <p:nvPr/>
+        </p:nvCxnSpPr>
+        <p:spPr>
+          <a:xfrm flipH="1">
+            <a:off x="1188719" y="5038344"/>
+            <a:ext cx="7406640" cy="0"/>
+          </a:xfrm>
+          <a:prstGeom prst="line">
+            <a:avLst/>
+          </a:prstGeom>
+          <a:ln w="15875">
+            <a:solidFill>
+              <a:srgbClr val="866103"/>
+            </a:solidFill>
+            <a:prstDash val="dash"/>
+          </a:ln>
+        </p:spPr>
+        <p:style>
+          <a:lnRef idx="2">
+            <a:schemeClr val="accent1"/>
+          </a:lnRef>
+          <a:fillRef idx="0">
+            <a:schemeClr val="accent1"/>
+          </a:fillRef>
+          <a:effectRef idx="1">
+            <a:schemeClr val="accent1"/>
+          </a:effectRef>
+          <a:fontRef idx="minor">
+            <a:schemeClr val="tx1"/>
+          </a:fontRef>
+        </p:style>
+      </p:cxnSp>
+      <p:cxnSp>
+        <p:nvCxnSpPr>
+          <p:cNvPr id="75" name="Connector 74"/>
+          <p:cNvCxnSpPr/>
+          <p:nvPr/>
+        </p:nvCxnSpPr>
+        <p:spPr>
           <a:xfrm flipV="1">
-            <a:off x="1097280" y="3493008"/>
-            <a:ext cx="0" cy="164592"/>
+            <a:off x="1188719" y="4818888"/>
+            <a:ext cx="0" cy="219456"/>
           </a:xfrm>
           <a:prstGeom prst="line">
             <a:avLst/>
           </a:prstGeom>
-          <a:ln w="12700">
+          <a:ln w="15875">
             <a:solidFill>
               <a:srgbClr val="866103"/>
             </a:solidFill>
@@ -5740,14 +5836,14 @@
       </p:cxnSp>
       <p:sp>
         <p:nvSpPr>
-          <p:cNvPr id="73" name="TextBox 72"/>
+          <p:cNvPr id="76" name="TextBox 75"/>
           <p:cNvSpPr txBox="1"/>
           <p:nvPr/>
         </p:nvSpPr>
         <p:spPr>
           <a:xfrm>
-            <a:off x="2103120" y="3703320"/>
-            <a:ext cx="6583680" cy="201168"/>
+            <a:off x="1097280" y="5111496"/>
+            <a:ext cx="8778240" cy="237744"/>
           </a:xfrm>
           <a:prstGeom prst="rect">
             <a:avLst/>
@@ -5762,982 +5858,26 @@
           <a:p>
             <a:pPr algn="ctr"/>
             <a:r>
-              <a:rPr sz="800" b="0">
+              <a:rPr sz="900" b="0">
                 <a:solidFill>
                   <a:srgbClr val="F0B726"/>
                 </a:solidFill>
                 <a:latin typeface="Courier New"/>
               </a:rPr>
-              <a:t>the reviewer uploads the approved STTM  →  the next sync pairs it  →  it becomes a template</a:t>
-            </a:r>
-          </a:p>
-        </p:txBody>
-      </p:sp>
-      <p:sp>
-        <p:nvSpPr>
-          <p:cNvPr id="74" name="Rounded Rectangle 73"/>
-          <p:cNvSpPr/>
-          <p:nvPr/>
-        </p:nvSpPr>
-        <p:spPr>
-          <a:xfrm>
-            <a:off x="548640" y="4069080"/>
-            <a:ext cx="2606040" cy="1737360"/>
-          </a:xfrm>
-          <a:prstGeom prst="roundRect">
-            <a:avLst>
-              <a:gd name="adj" fmla="val 3000"/>
-            </a:avLst>
-          </a:prstGeom>
-          <a:solidFill>
-            <a:srgbClr val="1C2127"/>
-          </a:solidFill>
-          <a:ln w="9525">
-            <a:solidFill>
-              <a:srgbClr val="383E47"/>
-            </a:solidFill>
-          </a:ln>
-          <a:effectLst/>
-        </p:spPr>
-        <p:style>
-          <a:lnRef idx="1">
-            <a:schemeClr val="accent1"/>
-          </a:lnRef>
-          <a:fillRef idx="3">
-            <a:schemeClr val="accent1"/>
-          </a:fillRef>
-          <a:effectRef idx="2">
-            <a:schemeClr val="accent1"/>
-          </a:effectRef>
-          <a:fontRef idx="minor">
-            <a:schemeClr val="lt1"/>
-          </a:fontRef>
-        </p:style>
-        <p:txBody>
-          <a:bodyPr rtlCol="0" anchor="ctr"/>
-          <a:lstStyle/>
-          <a:p/>
-        </p:txBody>
-      </p:sp>
-      <p:sp>
-        <p:nvSpPr>
-          <p:cNvPr id="75" name="Rounded Rectangle 74"/>
-          <p:cNvSpPr/>
-          <p:nvPr/>
-        </p:nvSpPr>
-        <p:spPr>
-          <a:xfrm>
-            <a:off x="640080" y="4160520"/>
-            <a:ext cx="2423160" cy="1170431"/>
-          </a:xfrm>
-          <a:prstGeom prst="roundRect">
-            <a:avLst>
-              <a:gd name="adj" fmla="val 2000"/>
-            </a:avLst>
-          </a:prstGeom>
-          <a:solidFill>
-            <a:srgbClr val="252A31"/>
-          </a:solidFill>
-          <a:ln w="9525">
-            <a:solidFill>
-              <a:srgbClr val="2F343C"/>
-            </a:solidFill>
-          </a:ln>
-          <a:effectLst/>
-        </p:spPr>
-        <p:style>
-          <a:lnRef idx="1">
-            <a:schemeClr val="accent1"/>
-          </a:lnRef>
-          <a:fillRef idx="3">
-            <a:schemeClr val="accent1"/>
-          </a:fillRef>
-          <a:effectRef idx="2">
-            <a:schemeClr val="accent1"/>
-          </a:effectRef>
-          <a:fontRef idx="minor">
-            <a:schemeClr val="lt1"/>
-          </a:fontRef>
-        </p:style>
-        <p:txBody>
-          <a:bodyPr rtlCol="0" anchor="ctr"/>
-          <a:lstStyle/>
-          <a:p/>
-        </p:txBody>
-      </p:sp>
-      <p:pic>
-        <p:nvPicPr>
-          <p:cNvPr id="76" name="Picture 75" descr="frd_page.png"/>
-          <p:cNvPicPr>
-            <a:picLocks noChangeAspect="1"/>
-          </p:cNvPicPr>
-          <p:nvPr/>
-        </p:nvPicPr>
-        <p:blipFill>
-          <a:blip r:embed="rId7"/>
-          <a:stretch>
-            <a:fillRect/>
-          </a:stretch>
-        </p:blipFill>
-        <p:spPr>
-          <a:xfrm>
-            <a:off x="688730" y="4178808"/>
-            <a:ext cx="2325858" cy="1133855"/>
-          </a:xfrm>
-          <a:prstGeom prst="rect">
-            <a:avLst/>
-          </a:prstGeom>
-        </p:spPr>
-      </p:pic>
-      <p:sp>
-        <p:nvSpPr>
-          <p:cNvPr id="77" name="Oval 76"/>
-          <p:cNvSpPr/>
-          <p:nvPr/>
-        </p:nvSpPr>
-        <p:spPr>
-          <a:xfrm>
-            <a:off x="694944" y="5440679"/>
-            <a:ext cx="73152" cy="73152"/>
-          </a:xfrm>
-          <a:prstGeom prst="ellipse">
-            <a:avLst/>
-          </a:prstGeom>
-          <a:solidFill>
-            <a:srgbClr val="3FA6DA"/>
-          </a:solidFill>
-          <a:ln>
-            <a:noFill/>
-          </a:ln>
-          <a:effectLst/>
-        </p:spPr>
-        <p:style>
-          <a:lnRef idx="1">
-            <a:schemeClr val="accent1"/>
-          </a:lnRef>
-          <a:fillRef idx="3">
-            <a:schemeClr val="accent1"/>
-          </a:fillRef>
-          <a:effectRef idx="2">
-            <a:schemeClr val="accent1"/>
-          </a:effectRef>
-          <a:fontRef idx="minor">
-            <a:schemeClr val="lt1"/>
-          </a:fontRef>
-        </p:style>
-        <p:txBody>
-          <a:bodyPr rtlCol="0" anchor="ctr"/>
-          <a:lstStyle/>
-          <a:p>
-            <a:pPr algn="ctr"/>
-          </a:p>
-        </p:txBody>
-      </p:sp>
-      <p:sp>
-        <p:nvSpPr>
-          <p:cNvPr id="78" name="TextBox 77"/>
-          <p:cNvSpPr txBox="1"/>
-          <p:nvPr/>
-        </p:nvSpPr>
-        <p:spPr>
-          <a:xfrm>
-            <a:off x="850392" y="5394959"/>
-            <a:ext cx="2194560" cy="201168"/>
-          </a:xfrm>
-          <a:prstGeom prst="rect">
-            <a:avLst/>
-          </a:prstGeom>
-          <a:noFill/>
-        </p:spPr>
-        <p:txBody>
-          <a:bodyPr wrap="square" lIns="0" rIns="0" tIns="0" bIns="0" anchor="t">
-            <a:spAutoFit/>
-          </a:bodyPr>
-          <a:lstStyle/>
-          <a:p>
-            <a:pPr algn="l"/>
-            <a:r>
-              <a:rPr sz="950" b="1">
-                <a:solidFill>
-                  <a:srgbClr val="F6F7F9"/>
-                </a:solidFill>
-                <a:latin typeface="Calibri"/>
-              </a:rPr>
-              <a:t>the FRD</a:t>
-            </a:r>
-            <a:r>
-              <a:rPr sz="750" b="0">
-                <a:solidFill>
-                  <a:srgbClr val="738091"/>
-                </a:solidFill>
-                <a:latin typeface="Courier New"/>
-              </a:rPr>
-              <a:t>   in</a:t>
-            </a:r>
-          </a:p>
-        </p:txBody>
-      </p:sp>
-      <p:sp>
-        <p:nvSpPr>
-          <p:cNvPr id="79" name="TextBox 78"/>
-          <p:cNvSpPr txBox="1"/>
-          <p:nvPr/>
-        </p:nvSpPr>
-        <p:spPr>
-          <a:xfrm>
-            <a:off x="850392" y="5586983"/>
-            <a:ext cx="2194560" cy="201168"/>
-          </a:xfrm>
-          <a:prstGeom prst="rect">
-            <a:avLst/>
-          </a:prstGeom>
-          <a:noFill/>
-        </p:spPr>
-        <p:txBody>
-          <a:bodyPr wrap="square" lIns="0" rIns="0" tIns="0" bIns="0" anchor="t">
-            <a:spAutoFit/>
-          </a:bodyPr>
-          <a:lstStyle/>
-          <a:p>
-            <a:pPr algn="l"/>
-            <a:r>
-              <a:rPr sz="750" b="0">
-                <a:solidFill>
-                  <a:srgbClr val="8F99A8"/>
-                </a:solidFill>
-                <a:latin typeface="Calibri"/>
-              </a:rPr>
-              <a:t>strict fields — paths, patterns, tables — must appear verbatim; underlined is what 03 checks</a:t>
-            </a:r>
-          </a:p>
-        </p:txBody>
-      </p:sp>
-      <p:sp>
-        <p:nvSpPr>
-          <p:cNvPr id="80" name="Rounded Rectangle 79"/>
-          <p:cNvSpPr/>
-          <p:nvPr/>
-        </p:nvSpPr>
-        <p:spPr>
-          <a:xfrm>
-            <a:off x="3337560" y="4069080"/>
-            <a:ext cx="2606040" cy="1737360"/>
-          </a:xfrm>
-          <a:prstGeom prst="roundRect">
-            <a:avLst>
-              <a:gd name="adj" fmla="val 3000"/>
-            </a:avLst>
-          </a:prstGeom>
-          <a:solidFill>
-            <a:srgbClr val="1C2127"/>
-          </a:solidFill>
-          <a:ln w="9525">
-            <a:solidFill>
-              <a:srgbClr val="383E47"/>
-            </a:solidFill>
-          </a:ln>
-          <a:effectLst/>
-        </p:spPr>
-        <p:style>
-          <a:lnRef idx="1">
-            <a:schemeClr val="accent1"/>
-          </a:lnRef>
-          <a:fillRef idx="3">
-            <a:schemeClr val="accent1"/>
-          </a:fillRef>
-          <a:effectRef idx="2">
-            <a:schemeClr val="accent1"/>
-          </a:effectRef>
-          <a:fontRef idx="minor">
-            <a:schemeClr val="lt1"/>
-          </a:fontRef>
-        </p:style>
-        <p:txBody>
-          <a:bodyPr rtlCol="0" anchor="ctr"/>
-          <a:lstStyle/>
-          <a:p/>
-        </p:txBody>
-      </p:sp>
-      <p:sp>
-        <p:nvSpPr>
-          <p:cNvPr id="81" name="Rounded Rectangle 80"/>
-          <p:cNvSpPr/>
-          <p:nvPr/>
-        </p:nvSpPr>
-        <p:spPr>
-          <a:xfrm>
-            <a:off x="3429000" y="4160520"/>
-            <a:ext cx="2423160" cy="1170431"/>
-          </a:xfrm>
-          <a:prstGeom prst="roundRect">
-            <a:avLst>
-              <a:gd name="adj" fmla="val 2000"/>
-            </a:avLst>
-          </a:prstGeom>
-          <a:solidFill>
-            <a:srgbClr val="252A31"/>
-          </a:solidFill>
-          <a:ln w="9525">
-            <a:solidFill>
-              <a:srgbClr val="2F343C"/>
-            </a:solidFill>
-          </a:ln>
-          <a:effectLst/>
-        </p:spPr>
-        <p:style>
-          <a:lnRef idx="1">
-            <a:schemeClr val="accent1"/>
-          </a:lnRef>
-          <a:fillRef idx="3">
-            <a:schemeClr val="accent1"/>
-          </a:fillRef>
-          <a:effectRef idx="2">
-            <a:schemeClr val="accent1"/>
-          </a:effectRef>
-          <a:fontRef idx="minor">
-            <a:schemeClr val="lt1"/>
-          </a:fontRef>
-        </p:style>
-        <p:txBody>
-          <a:bodyPr rtlCol="0" anchor="ctr"/>
-          <a:lstStyle/>
-          <a:p/>
-        </p:txBody>
-      </p:sp>
-      <p:pic>
-        <p:nvPicPr>
-          <p:cNvPr id="82" name="Picture 81" descr="shot_pick.png"/>
-          <p:cNvPicPr>
-            <a:picLocks noChangeAspect="1"/>
-          </p:cNvPicPr>
-          <p:nvPr/>
-        </p:nvPicPr>
-        <p:blipFill>
-          <a:blip r:embed="rId8"/>
-          <a:stretch>
-            <a:fillRect/>
-          </a:stretch>
-        </p:blipFill>
-        <p:spPr>
-          <a:xfrm>
-            <a:off x="3447288" y="4214200"/>
-            <a:ext cx="2386584" cy="1063071"/>
-          </a:xfrm>
-          <a:prstGeom prst="rect">
-            <a:avLst/>
-          </a:prstGeom>
-        </p:spPr>
-      </p:pic>
-      <p:sp>
-        <p:nvSpPr>
-          <p:cNvPr id="83" name="Oval 82"/>
-          <p:cNvSpPr/>
-          <p:nvPr/>
-        </p:nvSpPr>
-        <p:spPr>
-          <a:xfrm>
-            <a:off x="3483864" y="5440679"/>
-            <a:ext cx="73152" cy="73152"/>
-          </a:xfrm>
-          <a:prstGeom prst="ellipse">
-            <a:avLst/>
-          </a:prstGeom>
-          <a:solidFill>
-            <a:srgbClr val="13C9BA"/>
-          </a:solidFill>
-          <a:ln>
-            <a:noFill/>
-          </a:ln>
-          <a:effectLst/>
-        </p:spPr>
-        <p:style>
-          <a:lnRef idx="1">
-            <a:schemeClr val="accent1"/>
-          </a:lnRef>
-          <a:fillRef idx="3">
-            <a:schemeClr val="accent1"/>
-          </a:fillRef>
-          <a:effectRef idx="2">
-            <a:schemeClr val="accent1"/>
-          </a:effectRef>
-          <a:fontRef idx="minor">
-            <a:schemeClr val="lt1"/>
-          </a:fontRef>
-        </p:style>
-        <p:txBody>
-          <a:bodyPr rtlCol="0" anchor="ctr"/>
-          <a:lstStyle/>
-          <a:p>
-            <a:pPr algn="ctr"/>
-          </a:p>
-        </p:txBody>
-      </p:sp>
-      <p:sp>
-        <p:nvSpPr>
-          <p:cNvPr id="84" name="TextBox 83"/>
-          <p:cNvSpPr txBox="1"/>
-          <p:nvPr/>
-        </p:nvSpPr>
-        <p:spPr>
-          <a:xfrm>
-            <a:off x="3639312" y="5394959"/>
-            <a:ext cx="2194560" cy="201168"/>
-          </a:xfrm>
-          <a:prstGeom prst="rect">
-            <a:avLst/>
-          </a:prstGeom>
-          <a:noFill/>
-        </p:spPr>
-        <p:txBody>
-          <a:bodyPr wrap="square" lIns="0" rIns="0" tIns="0" bIns="0" anchor="t">
-            <a:spAutoFit/>
-          </a:bodyPr>
-          <a:lstStyle/>
-          <a:p>
-            <a:pPr algn="l"/>
-            <a:r>
-              <a:rPr sz="950" b="1">
-                <a:solidFill>
-                  <a:srgbClr val="F6F7F9"/>
-                </a:solidFill>
-                <a:latin typeface="Calibri"/>
-              </a:rPr>
-              <a:t>pick an FRD</a:t>
-            </a:r>
-            <a:r>
-              <a:rPr sz="750" b="0">
-                <a:solidFill>
-                  <a:srgbClr val="738091"/>
-                </a:solidFill>
-                <a:latin typeface="Courier New"/>
-              </a:rPr>
-              <a:t>   app</a:t>
-            </a:r>
-          </a:p>
-        </p:txBody>
-      </p:sp>
-      <p:sp>
-        <p:nvSpPr>
-          <p:cNvPr id="85" name="TextBox 84"/>
-          <p:cNvSpPr txBox="1"/>
-          <p:nvPr/>
-        </p:nvSpPr>
-        <p:spPr>
-          <a:xfrm>
-            <a:off x="3639312" y="5586983"/>
-            <a:ext cx="2194560" cy="201168"/>
-          </a:xfrm>
-          <a:prstGeom prst="rect">
-            <a:avLst/>
-          </a:prstGeom>
-          <a:noFill/>
-        </p:spPr>
-        <p:txBody>
-          <a:bodyPr wrap="square" lIns="0" rIns="0" tIns="0" bIns="0" anchor="t">
-            <a:spAutoFit/>
-          </a:bodyPr>
-          <a:lstStyle/>
-          <a:p>
-            <a:pPr algn="l"/>
-            <a:r>
-              <a:rPr sz="750" b="0">
-                <a:solidFill>
-                  <a:srgbClr val="8F99A8"/>
-                </a:solidFill>
-                <a:latin typeface="Calibri"/>
-              </a:rPr>
-              <a:t>the corpus the sync landed: unmapped FRDs get Generate, mapped ones show their approved STTM</a:t>
-            </a:r>
-          </a:p>
-        </p:txBody>
-      </p:sp>
-      <p:sp>
-        <p:nvSpPr>
-          <p:cNvPr id="86" name="Rounded Rectangle 85"/>
-          <p:cNvSpPr/>
-          <p:nvPr/>
-        </p:nvSpPr>
-        <p:spPr>
-          <a:xfrm>
-            <a:off x="6126480" y="4069080"/>
-            <a:ext cx="2606040" cy="1737360"/>
-          </a:xfrm>
-          <a:prstGeom prst="roundRect">
-            <a:avLst>
-              <a:gd name="adj" fmla="val 3000"/>
-            </a:avLst>
-          </a:prstGeom>
-          <a:solidFill>
-            <a:srgbClr val="1C2127"/>
-          </a:solidFill>
-          <a:ln w="9525">
-            <a:solidFill>
-              <a:srgbClr val="383E47"/>
-            </a:solidFill>
-          </a:ln>
-          <a:effectLst/>
-        </p:spPr>
-        <p:style>
-          <a:lnRef idx="1">
-            <a:schemeClr val="accent1"/>
-          </a:lnRef>
-          <a:fillRef idx="3">
-            <a:schemeClr val="accent1"/>
-          </a:fillRef>
-          <a:effectRef idx="2">
-            <a:schemeClr val="accent1"/>
-          </a:effectRef>
-          <a:fontRef idx="minor">
-            <a:schemeClr val="lt1"/>
-          </a:fontRef>
-        </p:style>
-        <p:txBody>
-          <a:bodyPr rtlCol="0" anchor="ctr"/>
-          <a:lstStyle/>
-          <a:p/>
-        </p:txBody>
-      </p:sp>
-      <p:sp>
-        <p:nvSpPr>
-          <p:cNvPr id="87" name="Rounded Rectangle 86"/>
-          <p:cNvSpPr/>
-          <p:nvPr/>
-        </p:nvSpPr>
-        <p:spPr>
-          <a:xfrm>
-            <a:off x="6217920" y="4160520"/>
-            <a:ext cx="2423160" cy="1170431"/>
-          </a:xfrm>
-          <a:prstGeom prst="roundRect">
-            <a:avLst>
-              <a:gd name="adj" fmla="val 2000"/>
-            </a:avLst>
-          </a:prstGeom>
-          <a:solidFill>
-            <a:srgbClr val="252A31"/>
-          </a:solidFill>
-          <a:ln w="9525">
-            <a:solidFill>
-              <a:srgbClr val="2F343C"/>
-            </a:solidFill>
-          </a:ln>
-          <a:effectLst/>
-        </p:spPr>
-        <p:style>
-          <a:lnRef idx="1">
-            <a:schemeClr val="accent1"/>
-          </a:lnRef>
-          <a:fillRef idx="3">
-            <a:schemeClr val="accent1"/>
-          </a:fillRef>
-          <a:effectRef idx="2">
-            <a:schemeClr val="accent1"/>
-          </a:effectRef>
-          <a:fontRef idx="minor">
-            <a:schemeClr val="lt1"/>
-          </a:fontRef>
-        </p:style>
-        <p:txBody>
-          <a:bodyPr rtlCol="0" anchor="ctr"/>
-          <a:lstStyle/>
-          <a:p/>
-        </p:txBody>
-      </p:sp>
-      <p:pic>
-        <p:nvPicPr>
-          <p:cNvPr id="88" name="Picture 87" descr="shot_review.png"/>
-          <p:cNvPicPr>
-            <a:picLocks noChangeAspect="1"/>
-          </p:cNvPicPr>
-          <p:nvPr/>
-        </p:nvPicPr>
-        <p:blipFill>
-          <a:blip r:embed="rId9"/>
-          <a:stretch>
-            <a:fillRect/>
-          </a:stretch>
-        </p:blipFill>
-        <p:spPr>
-          <a:xfrm>
-            <a:off x="6236208" y="4214200"/>
-            <a:ext cx="2386584" cy="1063071"/>
-          </a:xfrm>
-          <a:prstGeom prst="rect">
-            <a:avLst/>
-          </a:prstGeom>
-        </p:spPr>
-      </p:pic>
-      <p:sp>
-        <p:nvSpPr>
-          <p:cNvPr id="89" name="Oval 88"/>
-          <p:cNvSpPr/>
-          <p:nvPr/>
-        </p:nvSpPr>
-        <p:spPr>
-          <a:xfrm>
-            <a:off x="6272784" y="5440679"/>
-            <a:ext cx="73152" cy="73152"/>
-          </a:xfrm>
-          <a:prstGeom prst="ellipse">
-            <a:avLst/>
-          </a:prstGeom>
-          <a:solidFill>
-            <a:srgbClr val="F0B726"/>
-          </a:solidFill>
-          <a:ln>
-            <a:noFill/>
-          </a:ln>
-          <a:effectLst/>
-        </p:spPr>
-        <p:style>
-          <a:lnRef idx="1">
-            <a:schemeClr val="accent1"/>
-          </a:lnRef>
-          <a:fillRef idx="3">
-            <a:schemeClr val="accent1"/>
-          </a:fillRef>
-          <a:effectRef idx="2">
-            <a:schemeClr val="accent1"/>
-          </a:effectRef>
-          <a:fontRef idx="minor">
-            <a:schemeClr val="lt1"/>
-          </a:fontRef>
-        </p:style>
-        <p:txBody>
-          <a:bodyPr rtlCol="0" anchor="ctr"/>
-          <a:lstStyle/>
-          <a:p>
-            <a:pPr algn="ctr"/>
-          </a:p>
-        </p:txBody>
-      </p:sp>
-      <p:sp>
-        <p:nvSpPr>
-          <p:cNvPr id="90" name="TextBox 89"/>
-          <p:cNvSpPr txBox="1"/>
-          <p:nvPr/>
-        </p:nvSpPr>
-        <p:spPr>
-          <a:xfrm>
-            <a:off x="6428232" y="5394959"/>
-            <a:ext cx="2194560" cy="201168"/>
-          </a:xfrm>
-          <a:prstGeom prst="rect">
-            <a:avLst/>
-          </a:prstGeom>
-          <a:noFill/>
-        </p:spPr>
-        <p:txBody>
-          <a:bodyPr wrap="square" lIns="0" rIns="0" tIns="0" bIns="0" anchor="t">
-            <a:spAutoFit/>
-          </a:bodyPr>
-          <a:lstStyle/>
-          <a:p>
-            <a:pPr algn="l"/>
-            <a:r>
-              <a:rPr sz="950" b="1">
-                <a:solidFill>
-                  <a:srgbClr val="F6F7F9"/>
-                </a:solidFill>
-                <a:latin typeface="Calibri"/>
-              </a:rPr>
-              <a:t>resolve what the agent could not</a:t>
-            </a:r>
-            <a:r>
-              <a:rPr sz="750" b="0">
-                <a:solidFill>
-                  <a:srgbClr val="738091"/>
-                </a:solidFill>
-                <a:latin typeface="Courier New"/>
-              </a:rPr>
-              <a:t>   app</a:t>
-            </a:r>
-          </a:p>
-        </p:txBody>
-      </p:sp>
-      <p:sp>
-        <p:nvSpPr>
-          <p:cNvPr id="91" name="TextBox 90"/>
-          <p:cNvSpPr txBox="1"/>
-          <p:nvPr/>
-        </p:nvSpPr>
-        <p:spPr>
-          <a:xfrm>
-            <a:off x="6428232" y="5586983"/>
-            <a:ext cx="2194560" cy="201168"/>
-          </a:xfrm>
-          <a:prstGeom prst="rect">
-            <a:avLst/>
-          </a:prstGeom>
-          <a:noFill/>
-        </p:spPr>
-        <p:txBody>
-          <a:bodyPr wrap="square" lIns="0" rIns="0" tIns="0" bIns="0" anchor="t">
-            <a:spAutoFit/>
-          </a:bodyPr>
-          <a:lstStyle/>
-          <a:p>
-            <a:pPr algn="l"/>
-            <a:r>
-              <a:rPr sz="750" b="0">
-                <a:solidFill>
-                  <a:srgbClr val="8F99A8"/>
-                </a:solidFill>
-                <a:latin typeface="Calibri"/>
-              </a:rPr>
-              <a:t>gated questions answered in place; re-render is stage 04 only — nothing re-extracted or billed</a:t>
-            </a:r>
-          </a:p>
-        </p:txBody>
-      </p:sp>
-      <p:sp>
-        <p:nvSpPr>
-          <p:cNvPr id="92" name="Rounded Rectangle 91"/>
-          <p:cNvSpPr/>
-          <p:nvPr/>
-        </p:nvSpPr>
-        <p:spPr>
-          <a:xfrm>
-            <a:off x="8915400" y="4069080"/>
-            <a:ext cx="2743200" cy="1737360"/>
-          </a:xfrm>
-          <a:prstGeom prst="roundRect">
-            <a:avLst>
-              <a:gd name="adj" fmla="val 3000"/>
-            </a:avLst>
-          </a:prstGeom>
-          <a:solidFill>
-            <a:srgbClr val="1C2127"/>
-          </a:solidFill>
-          <a:ln w="9525">
-            <a:solidFill>
-              <a:srgbClr val="383E47"/>
-            </a:solidFill>
-          </a:ln>
-          <a:effectLst/>
-        </p:spPr>
-        <p:style>
-          <a:lnRef idx="1">
-            <a:schemeClr val="accent1"/>
-          </a:lnRef>
-          <a:fillRef idx="3">
-            <a:schemeClr val="accent1"/>
-          </a:fillRef>
-          <a:effectRef idx="2">
-            <a:schemeClr val="accent1"/>
-          </a:effectRef>
-          <a:fontRef idx="minor">
-            <a:schemeClr val="lt1"/>
-          </a:fontRef>
-        </p:style>
-        <p:txBody>
-          <a:bodyPr rtlCol="0" anchor="ctr"/>
-          <a:lstStyle/>
-          <a:p/>
-        </p:txBody>
-      </p:sp>
-      <p:sp>
-        <p:nvSpPr>
-          <p:cNvPr id="93" name="Rounded Rectangle 92"/>
-          <p:cNvSpPr/>
-          <p:nvPr/>
-        </p:nvSpPr>
-        <p:spPr>
-          <a:xfrm>
-            <a:off x="9006840" y="4160520"/>
-            <a:ext cx="2560320" cy="1170431"/>
-          </a:xfrm>
-          <a:prstGeom prst="roundRect">
-            <a:avLst>
-              <a:gd name="adj" fmla="val 2000"/>
-            </a:avLst>
-          </a:prstGeom>
-          <a:solidFill>
-            <a:srgbClr val="252A31"/>
-          </a:solidFill>
-          <a:ln w="9525">
-            <a:solidFill>
-              <a:srgbClr val="2F343C"/>
-            </a:solidFill>
-          </a:ln>
-          <a:effectLst/>
-        </p:spPr>
-        <p:style>
-          <a:lnRef idx="1">
-            <a:schemeClr val="accent1"/>
-          </a:lnRef>
-          <a:fillRef idx="3">
-            <a:schemeClr val="accent1"/>
-          </a:fillRef>
-          <a:effectRef idx="2">
-            <a:schemeClr val="accent1"/>
-          </a:effectRef>
-          <a:fontRef idx="minor">
-            <a:schemeClr val="lt1"/>
-          </a:fontRef>
-        </p:style>
-        <p:txBody>
-          <a:bodyPr rtlCol="0" anchor="ctr"/>
-          <a:lstStyle/>
-          <a:p/>
-        </p:txBody>
-      </p:sp>
-      <p:pic>
-        <p:nvPicPr>
-          <p:cNvPr id="94" name="Picture 93" descr="sttm_sheet.png"/>
-          <p:cNvPicPr>
-            <a:picLocks noChangeAspect="1"/>
-          </p:cNvPicPr>
-          <p:nvPr/>
-        </p:nvPicPr>
-        <p:blipFill>
-          <a:blip r:embed="rId10"/>
-          <a:stretch>
-            <a:fillRect/>
-          </a:stretch>
-        </p:blipFill>
-        <p:spPr>
-          <a:xfrm>
-            <a:off x="9124070" y="4178808"/>
-            <a:ext cx="2325858" cy="1133855"/>
-          </a:xfrm>
-          <a:prstGeom prst="rect">
-            <a:avLst/>
-          </a:prstGeom>
-        </p:spPr>
-      </p:pic>
-      <p:sp>
-        <p:nvSpPr>
-          <p:cNvPr id="95" name="Oval 94"/>
-          <p:cNvSpPr/>
-          <p:nvPr/>
-        </p:nvSpPr>
-        <p:spPr>
-          <a:xfrm>
-            <a:off x="9061704" y="5440679"/>
-            <a:ext cx="73152" cy="73152"/>
-          </a:xfrm>
-          <a:prstGeom prst="ellipse">
-            <a:avLst/>
-          </a:prstGeom>
-          <a:solidFill>
-            <a:srgbClr val="13C9BA"/>
-          </a:solidFill>
-          <a:ln>
-            <a:noFill/>
-          </a:ln>
-          <a:effectLst/>
-        </p:spPr>
-        <p:style>
-          <a:lnRef idx="1">
-            <a:schemeClr val="accent1"/>
-          </a:lnRef>
-          <a:fillRef idx="3">
-            <a:schemeClr val="accent1"/>
-          </a:fillRef>
-          <a:effectRef idx="2">
-            <a:schemeClr val="accent1"/>
-          </a:effectRef>
-          <a:fontRef idx="minor">
-            <a:schemeClr val="lt1"/>
-          </a:fontRef>
-        </p:style>
-        <p:txBody>
-          <a:bodyPr rtlCol="0" anchor="ctr"/>
-          <a:lstStyle/>
-          <a:p>
-            <a:pPr algn="ctr"/>
-          </a:p>
-        </p:txBody>
-      </p:sp>
-      <p:sp>
-        <p:nvSpPr>
-          <p:cNvPr id="96" name="TextBox 95"/>
-          <p:cNvSpPr txBox="1"/>
-          <p:nvPr/>
-        </p:nvSpPr>
-        <p:spPr>
-          <a:xfrm>
-            <a:off x="9217152" y="5394959"/>
-            <a:ext cx="2331720" cy="201168"/>
-          </a:xfrm>
-          <a:prstGeom prst="rect">
-            <a:avLst/>
-          </a:prstGeom>
-          <a:noFill/>
-        </p:spPr>
-        <p:txBody>
-          <a:bodyPr wrap="square" lIns="0" rIns="0" tIns="0" bIns="0" anchor="t">
-            <a:spAutoFit/>
-          </a:bodyPr>
-          <a:lstStyle/>
-          <a:p>
-            <a:pPr algn="l"/>
-            <a:r>
-              <a:rPr sz="950" b="1">
-                <a:solidFill>
-                  <a:srgbClr val="F6F7F9"/>
-                </a:solidFill>
-                <a:latin typeface="Calibri"/>
-              </a:rPr>
-              <a:t>the STTM</a:t>
-            </a:r>
-            <a:r>
-              <a:rPr sz="750" b="0">
-                <a:solidFill>
-                  <a:srgbClr val="738091"/>
-                </a:solidFill>
-                <a:latin typeface="Courier New"/>
-              </a:rPr>
-              <a:t>   out</a:t>
-            </a:r>
-          </a:p>
-        </p:txBody>
-      </p:sp>
-      <p:sp>
-        <p:nvSpPr>
-          <p:cNvPr id="97" name="TextBox 96"/>
-          <p:cNvSpPr txBox="1"/>
-          <p:nvPr/>
-        </p:nvSpPr>
-        <p:spPr>
-          <a:xfrm>
-            <a:off x="9217152" y="5586983"/>
-            <a:ext cx="2331720" cy="201168"/>
-          </a:xfrm>
-          <a:prstGeom prst="rect">
-            <a:avLst/>
-          </a:prstGeom>
-          <a:noFill/>
-        </p:spPr>
-        <p:txBody>
-          <a:bodyPr wrap="square" lIns="0" rIns="0" tIns="0" bIns="0" anchor="t">
-            <a:spAutoFit/>
-          </a:bodyPr>
-          <a:lstStyle/>
-          <a:p>
-            <a:pPr algn="l"/>
-            <a:r>
-              <a:rPr sz="750" b="0">
-                <a:solidFill>
-                  <a:srgbClr val="8F99A8"/>
-                </a:solidFill>
-                <a:latin typeface="Calibri"/>
-              </a:rPr>
-              <a:t>client dialect, one sheet per table; the FRD rule sits in the Comment cell of the row it names</a:t>
+              <a:t>the reviewer uploads the approved STTM   →   the next sync pairs it   →   it becomes a template</a:t>
             </a:r>
           </a:p>
         </p:txBody>
       </p:sp>
       <p:cxnSp>
         <p:nvCxnSpPr>
-          <p:cNvPr id="98" name="Connector 97"/>
+          <p:cNvPr id="77" name="Connector 76"/>
           <p:cNvCxnSpPr/>
           <p:nvPr/>
         </p:nvCxnSpPr>
         <p:spPr>
           <a:xfrm>
-            <a:off x="548640" y="6053328"/>
+            <a:off x="548640" y="5760720"/>
             <a:ext cx="11094415" cy="0"/>
           </a:xfrm>
           <a:prstGeom prst="line">
@@ -6766,14 +5906,14 @@
       </p:cxnSp>
       <p:sp>
         <p:nvSpPr>
-          <p:cNvPr id="99" name="TextBox 98"/>
+          <p:cNvPr id="78" name="TextBox 77"/>
           <p:cNvSpPr txBox="1"/>
           <p:nvPr/>
         </p:nvSpPr>
         <p:spPr>
           <a:xfrm>
-            <a:off x="548640" y="6163056"/>
-            <a:ext cx="7772400" cy="274320"/>
+            <a:off x="548640" y="5888736"/>
+            <a:ext cx="8686800" cy="310896"/>
           </a:xfrm>
           <a:prstGeom prst="rect">
             <a:avLst/>
@@ -6788,25 +5928,25 @@
           <a:p>
             <a:pPr algn="l"/>
             <a:r>
-              <a:rPr sz="1100" b="1">
+              <a:rPr sz="1200" b="1">
                 <a:solidFill>
-                  <a:srgbClr val="3FA6DA"/>
+                  <a:srgbClr val="D97757"/>
                 </a:solidFill>
                 <a:latin typeface="Calibri"/>
               </a:rPr>
               <a:t>the model proposes</a:t>
             </a:r>
             <a:r>
-              <a:rPr sz="1100" b="0">
+              <a:rPr sz="1200" b="0">
                 <a:solidFill>
                   <a:srgbClr val="404854"/>
                 </a:solidFill>
                 <a:latin typeface="Calibri"/>
               </a:rPr>
-              <a:t>     ·     </a:t>
-            </a:r>
-            <a:r>
-              <a:rPr sz="1100" b="1">
+              <a:t>      ·      </a:t>
+            </a:r>
+            <a:r>
+              <a:rPr sz="1200" b="1">
                 <a:solidFill>
                   <a:srgbClr val="13C9BA"/>
                 </a:solidFill>
@@ -6815,16 +5955,16 @@
               <a:t>deterministic code audits and decides</a:t>
             </a:r>
             <a:r>
-              <a:rPr sz="1100" b="0">
+              <a:rPr sz="1200" b="0">
                 <a:solidFill>
                   <a:srgbClr val="404854"/>
                 </a:solidFill>
                 <a:latin typeface="Calibri"/>
               </a:rPr>
-              <a:t>     ·     </a:t>
-            </a:r>
-            <a:r>
-              <a:rPr sz="1100" b="1">
+              <a:t>      ·      </a:t>
+            </a:r>
+            <a:r>
+              <a:rPr sz="1200" b="1">
                 <a:solidFill>
                   <a:srgbClr val="F0B726"/>
                 </a:solidFill>
@@ -6837,14 +5977,14 @@
       </p:sp>
       <p:sp>
         <p:nvSpPr>
-          <p:cNvPr id="100" name="TextBox 99"/>
+          <p:cNvPr id="79" name="TextBox 78"/>
           <p:cNvSpPr txBox="1"/>
           <p:nvPr/>
         </p:nvSpPr>
         <p:spPr>
           <a:xfrm>
-            <a:off x="548640" y="6437376"/>
-            <a:ext cx="8686800" cy="228600"/>
+            <a:off x="548640" y="6217920"/>
+            <a:ext cx="11064240" cy="274320"/>
           </a:xfrm>
           <a:prstGeom prst="rect">
             <a:avLst/>
@@ -6859,27 +5999,27 @@
           <a:p>
             <a:pPr algn="l"/>
             <a:r>
-              <a:rPr sz="850" b="0">
+              <a:rPr sz="1000" b="0">
                 <a:solidFill>
-                  <a:srgbClr val="ABB3BF"/>
+                  <a:srgbClr val="C5CBD3"/>
                 </a:solidFill>
                 <a:latin typeface="Calibri"/>
               </a:rPr>
-              <a:t>Grounding checks, gate status, pairing verdicts, template choice and eval scores are computed in code — never by the model. Fail loud: no silent mock, no silent live, no stale copies.</a:t>
-            </a:r>
-          </a:p>
-        </p:txBody>
-      </p:sp>
-      <p:sp>
-        <p:nvSpPr>
-          <p:cNvPr id="101" name="TextBox 100"/>
+              <a:t>Grounding checks, gate status, pairing verdicts, template choice and eval scores are computed in code, never by the model. Fail loud — no silent mock, no silent live, no stale copies.</a:t>
+            </a:r>
+          </a:p>
+        </p:txBody>
+      </p:sp>
+      <p:sp>
+        <p:nvSpPr>
+          <p:cNvPr id="80" name="TextBox 79"/>
           <p:cNvSpPr txBox="1"/>
           <p:nvPr/>
         </p:nvSpPr>
         <p:spPr>
           <a:xfrm>
-            <a:off x="7985455" y="6208776"/>
-            <a:ext cx="3657600" cy="182880"/>
+            <a:off x="7253935" y="5943600"/>
+            <a:ext cx="4389120" cy="201168"/>
           </a:xfrm>
           <a:prstGeom prst="rect">
             <a:avLst/>
@@ -6894,9 +6034,9 @@
           <a:p>
             <a:pPr algn="r"/>
             <a:r>
-              <a:rPr sz="750" b="0">
+              <a:rPr sz="850" b="0">
                 <a:solidFill>
-                  <a:srgbClr val="5F6B7C"/>
+                  <a:srgbClr val="8F99A8"/>
                 </a:solidFill>
                 <a:latin typeface="Courier New"/>
               </a:rPr>

</xml_diff>

<commit_message>
context: one-slide architecture v4 — white canvas; light theme variant (text/accent shades, dark icons, pale field)
Same layout as v3; canvas is white. Every accent now has a shape shade and a
darker text shade so it passes on white; Lucide icons re-rendered dark-gray
into scripts/deck_assets/icons_light; document previews framed as paper; the
flow-field background is pale. ONEPAGER_DESIGN.md carries the light spec with
the dark v3 values kept for reference.

Co-Authored-By: Claude Fable 5 <noreply@anthropic.com>
</commit_message>
<xml_diff>
--- a/context/FRD_to_STTM_Agent_System_Architecture.pptx
+++ b/context/FRD_to_STTM_Agent_System_Architecture.pptx
@@ -3128,7 +3128,7 @@
           </a:prstGeom>
           <a:ln w="6350">
             <a:solidFill>
-              <a:srgbClr val="404854"/>
+              <a:srgbClr val="C5CBD3"/>
             </a:solidFill>
           </a:ln>
         </p:spPr>
@@ -3163,7 +3163,7 @@
           </a:prstGeom>
           <a:ln w="6350">
             <a:solidFill>
-              <a:srgbClr val="404854"/>
+              <a:srgbClr val="C5CBD3"/>
             </a:solidFill>
           </a:ln>
         </p:spPr>
@@ -3198,7 +3198,7 @@
           </a:prstGeom>
           <a:ln w="6350">
             <a:solidFill>
-              <a:srgbClr val="404854"/>
+              <a:srgbClr val="C5CBD3"/>
             </a:solidFill>
           </a:ln>
         </p:spPr>
@@ -3233,7 +3233,7 @@
           </a:prstGeom>
           <a:ln w="6350">
             <a:solidFill>
-              <a:srgbClr val="404854"/>
+              <a:srgbClr val="C5CBD3"/>
             </a:solidFill>
           </a:ln>
         </p:spPr>
@@ -3268,7 +3268,7 @@
           </a:prstGeom>
           <a:ln w="6350">
             <a:solidFill>
-              <a:srgbClr val="404854"/>
+              <a:srgbClr val="C5CBD3"/>
             </a:solidFill>
           </a:ln>
         </p:spPr>
@@ -3303,7 +3303,7 @@
           </a:prstGeom>
           <a:ln w="6350">
             <a:solidFill>
-              <a:srgbClr val="404854"/>
+              <a:srgbClr val="C5CBD3"/>
             </a:solidFill>
           </a:ln>
         </p:spPr>
@@ -3338,7 +3338,7 @@
           </a:prstGeom>
           <a:ln w="6350">
             <a:solidFill>
-              <a:srgbClr val="404854"/>
+              <a:srgbClr val="C5CBD3"/>
             </a:solidFill>
           </a:ln>
         </p:spPr>
@@ -3373,7 +3373,7 @@
           </a:prstGeom>
           <a:ln w="6350">
             <a:solidFill>
-              <a:srgbClr val="404854"/>
+              <a:srgbClr val="C5CBD3"/>
             </a:solidFill>
           </a:ln>
         </p:spPr>
@@ -3418,7 +3418,7 @@
             <a:r>
               <a:rPr sz="900" b="0" spc="160">
                 <a:solidFill>
-                  <a:srgbClr val="8F99A8"/>
+                  <a:srgbClr val="738091"/>
                 </a:solidFill>
                 <a:latin typeface="Courier New"/>
               </a:rPr>
@@ -3453,7 +3453,7 @@
             <a:r>
               <a:rPr sz="3000" b="1">
                 <a:solidFill>
-                  <a:srgbClr val="FFFFFF"/>
+                  <a:srgbClr val="111418"/>
                 </a:solidFill>
                 <a:latin typeface="Calibri"/>
               </a:rPr>
@@ -3462,7 +3462,7 @@
             <a:r>
               <a:rPr sz="1600" b="0">
                 <a:solidFill>
-                  <a:srgbClr val="8F99A8"/>
+                  <a:srgbClr val="738091"/>
                 </a:solidFill>
                 <a:latin typeface="Calibri"/>
               </a:rPr>
@@ -3497,7 +3497,7 @@
             <a:r>
               <a:rPr sz="1200" b="0">
                 <a:solidFill>
-                  <a:srgbClr val="C5CBD3"/>
+                  <a:srgbClr val="404854"/>
                 </a:solidFill>
                 <a:latin typeface="Calibri"/>
               </a:rPr>
@@ -3525,7 +3525,7 @@
           <a:noFill/>
           <a:ln w="9525">
             <a:solidFill>
-              <a:srgbClr val="634DBF"/>
+              <a:srgbClr val="7961DB"/>
             </a:solidFill>
           </a:ln>
           <a:effectLst/>
@@ -3576,7 +3576,7 @@
             <a:r>
               <a:rPr sz="850" b="0" spc="100">
                 <a:solidFill>
-                  <a:srgbClr val="9881F3"/>
+                  <a:srgbClr val="5642A6"/>
                 </a:solidFill>
                 <a:latin typeface="Courier New"/>
               </a:rPr>
@@ -3604,7 +3604,7 @@
           <a:noFill/>
           <a:ln w="9525">
             <a:solidFill>
-              <a:srgbClr val="8A4A36"/>
+              <a:srgbClr val="D97757"/>
             </a:solidFill>
           </a:ln>
           <a:effectLst/>
@@ -3655,7 +3655,7 @@
             <a:r>
               <a:rPr sz="850" b="0" spc="100">
                 <a:solidFill>
-                  <a:srgbClr val="D97757"/>
+                  <a:srgbClr val="A04D2C"/>
                 </a:solidFill>
                 <a:latin typeface="Courier New"/>
               </a:rPr>
@@ -3683,7 +3683,7 @@
           <a:noFill/>
           <a:ln w="9525">
             <a:solidFill>
-              <a:srgbClr val="007067"/>
+              <a:srgbClr val="00A396"/>
             </a:solidFill>
           </a:ln>
           <a:effectLst/>
@@ -3734,7 +3734,7 @@
             <a:r>
               <a:rPr sz="850" b="0" spc="100">
                 <a:solidFill>
-                  <a:srgbClr val="13C9BA"/>
+                  <a:srgbClr val="007067"/>
                 </a:solidFill>
                 <a:latin typeface="Courier New"/>
               </a:rPr>
@@ -3760,11 +3760,11 @@
             </a:avLst>
           </a:prstGeom>
           <a:solidFill>
-            <a:srgbClr val="1C2127"/>
+            <a:srgbClr val="F6F7F9"/>
           </a:solidFill>
           <a:ln w="9525">
             <a:solidFill>
-              <a:srgbClr val="383E47"/>
+              <a:srgbClr val="D3D8DE"/>
             </a:solidFill>
           </a:ln>
           <a:effectLst/>
@@ -3804,7 +3804,7 @@
             <a:avLst/>
           </a:prstGeom>
           <a:solidFill>
-            <a:srgbClr val="9881F3"/>
+            <a:srgbClr val="7961DB"/>
           </a:solidFill>
           <a:ln>
             <a:noFill/>
@@ -3859,7 +3859,7 @@
             <a:r>
               <a:rPr sz="900" b="0" spc="140">
                 <a:solidFill>
-                  <a:srgbClr val="9881F3"/>
+                  <a:srgbClr val="5642A6"/>
                 </a:solidFill>
                 <a:latin typeface="Courier New"/>
               </a:rPr>
@@ -3894,7 +3894,7 @@
             <a:r>
               <a:rPr sz="1450" b="1">
                 <a:solidFill>
-                  <a:srgbClr val="F6F7F9"/>
+                  <a:srgbClr val="1C2127"/>
                 </a:solidFill>
                 <a:latin typeface="Calibri"/>
               </a:rPr>
@@ -3957,7 +3957,7 @@
             <a:r>
               <a:rPr sz="1100" b="0">
                 <a:solidFill>
-                  <a:srgbClr val="C5CBD3"/>
+                  <a:srgbClr val="404854"/>
                 </a:solidFill>
                 <a:latin typeface="Calibri"/>
               </a:rPr>
@@ -3983,11 +3983,11 @@
             </a:avLst>
           </a:prstGeom>
           <a:solidFill>
-            <a:srgbClr val="252A31"/>
+            <a:srgbClr val="EDEFF2"/>
           </a:solidFill>
           <a:ln w="9525">
             <a:solidFill>
-              <a:srgbClr val="404854"/>
+              <a:srgbClr val="C5CBD3"/>
             </a:solidFill>
           </a:ln>
           <a:effectLst/>
@@ -4053,11 +4053,11 @@
             </a:avLst>
           </a:prstGeom>
           <a:solidFill>
-            <a:srgbClr val="1C2127"/>
+            <a:srgbClr val="F6F7F9"/>
           </a:solidFill>
           <a:ln w="9525">
             <a:solidFill>
-              <a:srgbClr val="383E47"/>
+              <a:srgbClr val="D3D8DE"/>
             </a:solidFill>
           </a:ln>
           <a:effectLst/>
@@ -4097,7 +4097,7 @@
             <a:avLst/>
           </a:prstGeom>
           <a:solidFill>
-            <a:srgbClr val="13C9BA"/>
+            <a:srgbClr val="00A396"/>
           </a:solidFill>
           <a:ln>
             <a:noFill/>
@@ -4152,7 +4152,7 @@
             <a:r>
               <a:rPr sz="900" b="0" spc="140">
                 <a:solidFill>
-                  <a:srgbClr val="13C9BA"/>
+                  <a:srgbClr val="007067"/>
                 </a:solidFill>
                 <a:latin typeface="Courier New"/>
               </a:rPr>
@@ -4187,7 +4187,7 @@
             <a:r>
               <a:rPr sz="1450" b="1">
                 <a:solidFill>
-                  <a:srgbClr val="F6F7F9"/>
+                  <a:srgbClr val="1C2127"/>
                 </a:solidFill>
                 <a:latin typeface="Calibri"/>
               </a:rPr>
@@ -4250,7 +4250,7 @@
             <a:r>
               <a:rPr sz="1100" b="0">
                 <a:solidFill>
-                  <a:srgbClr val="C5CBD3"/>
+                  <a:srgbClr val="404854"/>
                 </a:solidFill>
                 <a:latin typeface="Calibri"/>
               </a:rPr>
@@ -4276,11 +4276,11 @@
             </a:avLst>
           </a:prstGeom>
           <a:solidFill>
-            <a:srgbClr val="1C2127"/>
+            <a:srgbClr val="F6F7F9"/>
           </a:solidFill>
           <a:ln w="9525">
             <a:solidFill>
-              <a:srgbClr val="383E47"/>
+              <a:srgbClr val="D3D8DE"/>
             </a:solidFill>
           </a:ln>
           <a:effectLst/>
@@ -4320,7 +4320,7 @@
             <a:avLst/>
           </a:prstGeom>
           <a:solidFill>
-            <a:srgbClr val="13C9BA"/>
+            <a:srgbClr val="00A396"/>
           </a:solidFill>
           <a:ln>
             <a:noFill/>
@@ -4375,7 +4375,7 @@
             <a:r>
               <a:rPr sz="900" b="0" spc="140">
                 <a:solidFill>
-                  <a:srgbClr val="13C9BA"/>
+                  <a:srgbClr val="007067"/>
                 </a:solidFill>
                 <a:latin typeface="Courier New"/>
               </a:rPr>
@@ -4410,7 +4410,7 @@
             <a:r>
               <a:rPr sz="1450" b="1">
                 <a:solidFill>
-                  <a:srgbClr val="F6F7F9"/>
+                  <a:srgbClr val="1C2127"/>
                 </a:solidFill>
                 <a:latin typeface="Calibri"/>
               </a:rPr>
@@ -4449,7 +4449,7 @@
             <a:r>
               <a:rPr sz="1100" b="0">
                 <a:solidFill>
-                  <a:srgbClr val="C5CBD3"/>
+                  <a:srgbClr val="404854"/>
                 </a:solidFill>
                 <a:latin typeface="Calibri"/>
               </a:rPr>
@@ -4475,11 +4475,11 @@
             </a:avLst>
           </a:prstGeom>
           <a:solidFill>
-            <a:srgbClr val="1C2127"/>
+            <a:srgbClr val="F6F7F9"/>
           </a:solidFill>
           <a:ln w="9525">
             <a:solidFill>
-              <a:srgbClr val="383E47"/>
+              <a:srgbClr val="D3D8DE"/>
             </a:solidFill>
           </a:ln>
           <a:effectLst/>
@@ -4519,7 +4519,7 @@
             <a:avLst/>
           </a:prstGeom>
           <a:solidFill>
-            <a:srgbClr val="F0B726"/>
+            <a:srgbClr val="D1980B"/>
           </a:solidFill>
           <a:ln>
             <a:noFill/>
@@ -4574,7 +4574,7 @@
             <a:r>
               <a:rPr sz="900" b="0" spc="140">
                 <a:solidFill>
-                  <a:srgbClr val="F0B726"/>
+                  <a:srgbClr val="866103"/>
                 </a:solidFill>
                 <a:latin typeface="Courier New"/>
               </a:rPr>
@@ -4609,7 +4609,7 @@
             <a:r>
               <a:rPr sz="1450" b="1">
                 <a:solidFill>
-                  <a:srgbClr val="F6F7F9"/>
+                  <a:srgbClr val="1C2127"/>
                 </a:solidFill>
                 <a:latin typeface="Calibri"/>
               </a:rPr>
@@ -4672,7 +4672,7 @@
             <a:r>
               <a:rPr sz="1100" b="0">
                 <a:solidFill>
-                  <a:srgbClr val="C5CBD3"/>
+                  <a:srgbClr val="404854"/>
                 </a:solidFill>
                 <a:latin typeface="Calibri"/>
               </a:rPr>
@@ -4698,11 +4698,11 @@
             </a:avLst>
           </a:prstGeom>
           <a:solidFill>
-            <a:srgbClr val="1C2127"/>
+            <a:srgbClr val="F6F7F9"/>
           </a:solidFill>
           <a:ln w="9525">
             <a:solidFill>
-              <a:srgbClr val="383E47"/>
+              <a:srgbClr val="D3D8DE"/>
             </a:solidFill>
           </a:ln>
           <a:effectLst/>
@@ -4742,7 +4742,7 @@
             <a:avLst/>
           </a:prstGeom>
           <a:solidFill>
-            <a:srgbClr val="9881F3"/>
+            <a:srgbClr val="7961DB"/>
           </a:solidFill>
           <a:ln>
             <a:noFill/>
@@ -4797,7 +4797,7 @@
             <a:r>
               <a:rPr sz="900" b="0" spc="140">
                 <a:solidFill>
-                  <a:srgbClr val="9881F3"/>
+                  <a:srgbClr val="5642A6"/>
                 </a:solidFill>
                 <a:latin typeface="Courier New"/>
               </a:rPr>
@@ -4832,7 +4832,7 @@
             <a:r>
               <a:rPr sz="1450" b="1">
                 <a:solidFill>
-                  <a:srgbClr val="F6F7F9"/>
+                  <a:srgbClr val="1C2127"/>
                 </a:solidFill>
                 <a:latin typeface="Calibri"/>
               </a:rPr>
@@ -4895,7 +4895,7 @@
             <a:r>
               <a:rPr sz="1100" b="0">
                 <a:solidFill>
-                  <a:srgbClr val="C5CBD3"/>
+                  <a:srgbClr val="404854"/>
                 </a:solidFill>
                 <a:latin typeface="Calibri"/>
               </a:rPr>
@@ -4921,11 +4921,11 @@
             </a:avLst>
           </a:prstGeom>
           <a:solidFill>
-            <a:srgbClr val="252A31"/>
+            <a:srgbClr val="EDEFF2"/>
           </a:solidFill>
           <a:ln w="9525">
             <a:solidFill>
-              <a:srgbClr val="404854"/>
+              <a:srgbClr val="C5CBD3"/>
             </a:solidFill>
           </a:ln>
           <a:effectLst/>
@@ -4991,11 +4991,11 @@
             </a:avLst>
           </a:prstGeom>
           <a:solidFill>
-            <a:srgbClr val="252A31"/>
+            <a:srgbClr val="EDEFF2"/>
           </a:solidFill>
           <a:ln w="9525">
             <a:solidFill>
-              <a:srgbClr val="404854"/>
+              <a:srgbClr val="C5CBD3"/>
             </a:solidFill>
           </a:ln>
           <a:effectLst/>
@@ -5046,7 +5046,7 @@
             <a:r>
               <a:rPr sz="850" b="0">
                 <a:solidFill>
-                  <a:srgbClr val="13C9BA"/>
+                  <a:srgbClr val="007067"/>
                 </a:solidFill>
                 <a:latin typeface="Courier New"/>
               </a:rPr>
@@ -5081,7 +5081,7 @@
             <a:r>
               <a:rPr sz="950" b="0">
                 <a:solidFill>
-                  <a:srgbClr val="F6F7F9"/>
+                  <a:srgbClr val="1C2127"/>
                 </a:solidFill>
                 <a:latin typeface="Calibri"/>
               </a:rPr>
@@ -5106,7 +5106,7 @@
           </a:prstGeom>
           <a:ln w="9525">
             <a:solidFill>
-              <a:srgbClr val="404854"/>
+              <a:srgbClr val="C5CBD3"/>
             </a:solidFill>
             <a:tailEnd type="triangle" w="sm" len="sm"/>
           </a:ln>
@@ -5143,9 +5143,9 @@
             </a:avLst>
           </a:prstGeom>
           <a:solidFill>
-            <a:srgbClr val="8A4A36"/>
+            <a:srgbClr val="FBEEE8"/>
           </a:solidFill>
-          <a:ln w="12700">
+          <a:ln w="15875">
             <a:solidFill>
               <a:srgbClr val="D97757"/>
             </a:solidFill>
@@ -5198,7 +5198,7 @@
             <a:r>
               <a:rPr sz="850" b="0">
                 <a:solidFill>
-                  <a:srgbClr val="F6F7F9"/>
+                  <a:srgbClr val="A04D2C"/>
                 </a:solidFill>
                 <a:latin typeface="Courier New"/>
               </a:rPr>
@@ -5233,7 +5233,7 @@
             <a:r>
               <a:rPr sz="950" b="1">
                 <a:solidFill>
-                  <a:srgbClr val="F6F7F9"/>
+                  <a:srgbClr val="A04D2C"/>
                 </a:solidFill>
                 <a:latin typeface="Calibri"/>
               </a:rPr>
@@ -5258,7 +5258,7 @@
           </a:prstGeom>
           <a:ln w="9525">
             <a:solidFill>
-              <a:srgbClr val="404854"/>
+              <a:srgbClr val="C5CBD3"/>
             </a:solidFill>
             <a:tailEnd type="triangle" w="sm" len="sm"/>
           </a:ln>
@@ -5295,11 +5295,11 @@
             </a:avLst>
           </a:prstGeom>
           <a:solidFill>
-            <a:srgbClr val="252A31"/>
+            <a:srgbClr val="EDEFF2"/>
           </a:solidFill>
           <a:ln w="9525">
             <a:solidFill>
-              <a:srgbClr val="404854"/>
+              <a:srgbClr val="C5CBD3"/>
             </a:solidFill>
           </a:ln>
           <a:effectLst/>
@@ -5350,7 +5350,7 @@
             <a:r>
               <a:rPr sz="850" b="0">
                 <a:solidFill>
-                  <a:srgbClr val="13C9BA"/>
+                  <a:srgbClr val="007067"/>
                 </a:solidFill>
                 <a:latin typeface="Courier New"/>
               </a:rPr>
@@ -5385,7 +5385,7 @@
             <a:r>
               <a:rPr sz="950" b="0">
                 <a:solidFill>
-                  <a:srgbClr val="F6F7F9"/>
+                  <a:srgbClr val="1C2127"/>
                 </a:solidFill>
                 <a:latin typeface="Calibri"/>
               </a:rPr>
@@ -5410,7 +5410,7 @@
           </a:prstGeom>
           <a:ln w="9525">
             <a:solidFill>
-              <a:srgbClr val="404854"/>
+              <a:srgbClr val="C5CBD3"/>
             </a:solidFill>
             <a:tailEnd type="triangle" w="sm" len="sm"/>
           </a:ln>
@@ -5447,11 +5447,11 @@
             </a:avLst>
           </a:prstGeom>
           <a:solidFill>
-            <a:srgbClr val="252A31"/>
+            <a:srgbClr val="EDEFF2"/>
           </a:solidFill>
           <a:ln w="9525">
             <a:solidFill>
-              <a:srgbClr val="404854"/>
+              <a:srgbClr val="C5CBD3"/>
             </a:solidFill>
           </a:ln>
           <a:effectLst/>
@@ -5502,7 +5502,7 @@
             <a:r>
               <a:rPr sz="850" b="0">
                 <a:solidFill>
-                  <a:srgbClr val="13C9BA"/>
+                  <a:srgbClr val="007067"/>
                 </a:solidFill>
                 <a:latin typeface="Courier New"/>
               </a:rPr>
@@ -5537,7 +5537,7 @@
             <a:r>
               <a:rPr sz="950" b="0">
                 <a:solidFill>
-                  <a:srgbClr val="F6F7F9"/>
+                  <a:srgbClr val="1C2127"/>
                 </a:solidFill>
                 <a:latin typeface="Calibri"/>
               </a:rPr>
@@ -5572,7 +5572,7 @@
             <a:r>
               <a:rPr sz="950" b="0">
                 <a:solidFill>
-                  <a:srgbClr val="D97757"/>
+                  <a:srgbClr val="A04D2C"/>
                 </a:solidFill>
                 <a:latin typeface="Calibri"/>
               </a:rPr>
@@ -5597,7 +5597,7 @@
           </a:prstGeom>
           <a:ln w="12700">
             <a:solidFill>
-              <a:srgbClr val="8F99A8"/>
+              <a:srgbClr val="738091"/>
             </a:solidFill>
             <a:tailEnd type="triangle" w="sm" len="sm"/>
           </a:ln>
@@ -5633,7 +5633,7 @@
           </a:prstGeom>
           <a:ln w="12700">
             <a:solidFill>
-              <a:srgbClr val="8F99A8"/>
+              <a:srgbClr val="738091"/>
             </a:solidFill>
             <a:tailEnd type="triangle" w="sm" len="sm"/>
           </a:ln>
@@ -5669,7 +5669,7 @@
           </a:prstGeom>
           <a:ln w="12700">
             <a:solidFill>
-              <a:srgbClr val="8F99A8"/>
+              <a:srgbClr val="738091"/>
             </a:solidFill>
             <a:tailEnd type="triangle" w="sm" len="sm"/>
           </a:ln>
@@ -5705,7 +5705,7 @@
           </a:prstGeom>
           <a:ln w="12700">
             <a:solidFill>
-              <a:srgbClr val="8F99A8"/>
+              <a:srgbClr val="738091"/>
             </a:solidFill>
             <a:tailEnd type="triangle" w="sm" len="sm"/>
           </a:ln>
@@ -5741,7 +5741,7 @@
           </a:prstGeom>
           <a:ln w="15875">
             <a:solidFill>
-              <a:srgbClr val="866103"/>
+              <a:srgbClr val="D1980B"/>
             </a:solidFill>
             <a:prstDash val="dash"/>
           </a:ln>
@@ -5777,7 +5777,7 @@
           </a:prstGeom>
           <a:ln w="15875">
             <a:solidFill>
-              <a:srgbClr val="866103"/>
+              <a:srgbClr val="D1980B"/>
             </a:solidFill>
             <a:prstDash val="dash"/>
           </a:ln>
@@ -5813,7 +5813,7 @@
           </a:prstGeom>
           <a:ln w="15875">
             <a:solidFill>
-              <a:srgbClr val="866103"/>
+              <a:srgbClr val="D1980B"/>
             </a:solidFill>
             <a:prstDash val="dash"/>
             <a:tailEnd type="triangle" w="sm" len="sm"/>
@@ -5860,7 +5860,7 @@
             <a:r>
               <a:rPr sz="900" b="0">
                 <a:solidFill>
-                  <a:srgbClr val="F0B726"/>
+                  <a:srgbClr val="866103"/>
                 </a:solidFill>
                 <a:latin typeface="Courier New"/>
               </a:rPr>
@@ -5885,7 +5885,7 @@
           </a:prstGeom>
           <a:ln w="6350">
             <a:solidFill>
-              <a:srgbClr val="383E47"/>
+              <a:srgbClr val="D3D8DE"/>
             </a:solidFill>
           </a:ln>
         </p:spPr>
@@ -5930,7 +5930,7 @@
             <a:r>
               <a:rPr sz="1200" b="1">
                 <a:solidFill>
-                  <a:srgbClr val="D97757"/>
+                  <a:srgbClr val="A04D2C"/>
                 </a:solidFill>
                 <a:latin typeface="Calibri"/>
               </a:rPr>
@@ -5938,53 +5938,88 @@
             </a:r>
             <a:r>
               <a:rPr sz="1200" b="0">
+                <a:solidFill>
+                  <a:srgbClr val="C5CBD3"/>
+                </a:solidFill>
+                <a:latin typeface="Calibri"/>
+              </a:rPr>
+              <a:t>      ·      </a:t>
+            </a:r>
+            <a:r>
+              <a:rPr sz="1200" b="1">
+                <a:solidFill>
+                  <a:srgbClr val="007067"/>
+                </a:solidFill>
+                <a:latin typeface="Calibri"/>
+              </a:rPr>
+              <a:t>deterministic code audits and decides</a:t>
+            </a:r>
+            <a:r>
+              <a:rPr sz="1200" b="0">
+                <a:solidFill>
+                  <a:srgbClr val="C5CBD3"/>
+                </a:solidFill>
+                <a:latin typeface="Calibri"/>
+              </a:rPr>
+              <a:t>      ·      </a:t>
+            </a:r>
+            <a:r>
+              <a:rPr sz="1200" b="1">
+                <a:solidFill>
+                  <a:srgbClr val="866103"/>
+                </a:solidFill>
+                <a:latin typeface="Calibri"/>
+              </a:rPr>
+              <a:t>a person resolves</a:t>
+            </a:r>
+          </a:p>
+        </p:txBody>
+      </p:sp>
+      <p:sp>
+        <p:nvSpPr>
+          <p:cNvPr id="79" name="TextBox 78"/>
+          <p:cNvSpPr txBox="1"/>
+          <p:nvPr/>
+        </p:nvSpPr>
+        <p:spPr>
+          <a:xfrm>
+            <a:off x="548640" y="6217920"/>
+            <a:ext cx="11064240" cy="274320"/>
+          </a:xfrm>
+          <a:prstGeom prst="rect">
+            <a:avLst/>
+          </a:prstGeom>
+          <a:noFill/>
+        </p:spPr>
+        <p:txBody>
+          <a:bodyPr wrap="square" lIns="0" rIns="0" tIns="0" bIns="0" anchor="t">
+            <a:spAutoFit/>
+          </a:bodyPr>
+          <a:lstStyle/>
+          <a:p>
+            <a:pPr algn="l"/>
+            <a:r>
+              <a:rPr sz="1000" b="0">
                 <a:solidFill>
                   <a:srgbClr val="404854"/>
                 </a:solidFill>
                 <a:latin typeface="Calibri"/>
               </a:rPr>
-              <a:t>      ·      </a:t>
-            </a:r>
-            <a:r>
-              <a:rPr sz="1200" b="1">
-                <a:solidFill>
-                  <a:srgbClr val="13C9BA"/>
-                </a:solidFill>
-                <a:latin typeface="Calibri"/>
-              </a:rPr>
-              <a:t>deterministic code audits and decides</a:t>
-            </a:r>
-            <a:r>
-              <a:rPr sz="1200" b="0">
-                <a:solidFill>
-                  <a:srgbClr val="404854"/>
-                </a:solidFill>
-                <a:latin typeface="Calibri"/>
-              </a:rPr>
-              <a:t>      ·      </a:t>
-            </a:r>
-            <a:r>
-              <a:rPr sz="1200" b="1">
-                <a:solidFill>
-                  <a:srgbClr val="F0B726"/>
-                </a:solidFill>
-                <a:latin typeface="Calibri"/>
-              </a:rPr>
-              <a:t>a person resolves</a:t>
-            </a:r>
-          </a:p>
-        </p:txBody>
-      </p:sp>
-      <p:sp>
-        <p:nvSpPr>
-          <p:cNvPr id="79" name="TextBox 78"/>
+              <a:t>Grounding checks, gate status, pairing verdicts, template choice and eval scores are computed in code, never by the model. Fail loud — no silent mock, no silent live, no stale copies.</a:t>
+            </a:r>
+          </a:p>
+        </p:txBody>
+      </p:sp>
+      <p:sp>
+        <p:nvSpPr>
+          <p:cNvPr id="80" name="TextBox 79"/>
           <p:cNvSpPr txBox="1"/>
           <p:nvPr/>
         </p:nvSpPr>
         <p:spPr>
           <a:xfrm>
-            <a:off x="548640" y="6217920"/>
-            <a:ext cx="11064240" cy="274320"/>
+            <a:off x="7253935" y="5943600"/>
+            <a:ext cx="4389120" cy="201168"/>
           </a:xfrm>
           <a:prstGeom prst="rect">
             <a:avLst/>
@@ -5997,46 +6032,11 @@
           </a:bodyPr>
           <a:lstStyle/>
           <a:p>
-            <a:pPr algn="l"/>
-            <a:r>
-              <a:rPr sz="1000" b="0">
-                <a:solidFill>
-                  <a:srgbClr val="C5CBD3"/>
-                </a:solidFill>
-                <a:latin typeface="Calibri"/>
-              </a:rPr>
-              <a:t>Grounding checks, gate status, pairing verdicts, template choice and eval scores are computed in code, never by the model. Fail loud — no silent mock, no silent live, no stale copies.</a:t>
-            </a:r>
-          </a:p>
-        </p:txBody>
-      </p:sp>
-      <p:sp>
-        <p:nvSpPr>
-          <p:cNvPr id="80" name="TextBox 79"/>
-          <p:cNvSpPr txBox="1"/>
-          <p:nvPr/>
-        </p:nvSpPr>
-        <p:spPr>
-          <a:xfrm>
-            <a:off x="7253935" y="5943600"/>
-            <a:ext cx="4389120" cy="201168"/>
-          </a:xfrm>
-          <a:prstGeom prst="rect">
-            <a:avLst/>
-          </a:prstGeom>
-          <a:noFill/>
-        </p:spPr>
-        <p:txBody>
-          <a:bodyPr wrap="square" lIns="0" rIns="0" tIns="0" bIns="0" anchor="t">
-            <a:spAutoFit/>
-          </a:bodyPr>
-          <a:lstStyle/>
-          <a:p>
             <a:pPr algn="r"/>
             <a:r>
               <a:rPr sz="850" b="0">
                 <a:solidFill>
-                  <a:srgbClr val="8F99A8"/>
+                  <a:srgbClr val="738091"/>
                 </a:solidFill>
                 <a:latin typeface="Courier New"/>
               </a:rPr>

</xml_diff>

<commit_message>
context: one-slide architecture v4.1 — fix faint text on white (bold Calibri caps / Consolas ids instead of Courier New, darker gray ramp, 1 pt chip borders)
PowerPoint rendered the thin Courier New labels nearly invisible (screenshot
2026-08-22 9:03 PM). Small labels are now bold Calibri caps, ids bold
Consolas; secondary/muted text darkened to 2f343c / 5f6b7c; connectors and
chip borders heavier.

Co-Authored-By: Claude Fable 5 <noreply@anthropic.com>
</commit_message>
<xml_diff>
--- a/context/FRD_to_STTM_Agent_System_Architecture.pptx
+++ b/context/FRD_to_STTM_Agent_System_Architecture.pptx
@@ -3416,11 +3416,11 @@
           <a:p>
             <a:pPr algn="l"/>
             <a:r>
-              <a:rPr sz="900" b="0" spc="160">
+              <a:rPr sz="900" b="1" spc="140">
                 <a:solidFill>
-                  <a:srgbClr val="738091"/>
+                  <a:srgbClr val="5F6B7C"/>
                 </a:solidFill>
-                <a:latin typeface="Courier New"/>
+                <a:latin typeface="Calibri"/>
               </a:rPr>
               <a:t>HEXAWARE  ·  AMERIHEALTH CARITAS  ·  AI-IN-ENGINEERING  ·  AGENT 01 / 03</a:t>
             </a:r>
@@ -3462,7 +3462,7 @@
             <a:r>
               <a:rPr sz="1600" b="0">
                 <a:solidFill>
-                  <a:srgbClr val="738091"/>
+                  <a:srgbClr val="5F6B7C"/>
                 </a:solidFill>
                 <a:latin typeface="Calibri"/>
               </a:rPr>
@@ -3497,7 +3497,7 @@
             <a:r>
               <a:rPr sz="1200" b="0">
                 <a:solidFill>
-                  <a:srgbClr val="404854"/>
+                  <a:srgbClr val="2F343C"/>
                 </a:solidFill>
                 <a:latin typeface="Calibri"/>
               </a:rPr>
@@ -3515,7 +3515,7 @@
         <p:spPr>
           <a:xfrm>
             <a:off x="548640" y="1536192"/>
-            <a:ext cx="2011679" cy="274320"/>
+            <a:ext cx="1938527" cy="274320"/>
           </a:xfrm>
           <a:prstGeom prst="roundRect">
             <a:avLst>
@@ -3523,7 +3523,7 @@
             </a:avLst>
           </a:prstGeom>
           <a:noFill/>
-          <a:ln w="9525">
+          <a:ln w="12700">
             <a:solidFill>
               <a:srgbClr val="7961DB"/>
             </a:solidFill>
@@ -3559,7 +3559,7 @@
         <p:spPr>
           <a:xfrm>
             <a:off x="548640" y="1600200"/>
-            <a:ext cx="2011679" cy="182880"/>
+            <a:ext cx="1938527" cy="182880"/>
           </a:xfrm>
           <a:prstGeom prst="rect">
             <a:avLst/>
@@ -3574,11 +3574,11 @@
           <a:p>
             <a:pPr algn="ctr"/>
             <a:r>
-              <a:rPr sz="850" b="0" spc="100">
+              <a:rPr sz="850" b="1" spc="100">
                 <a:solidFill>
                   <a:srgbClr val="5642A6"/>
                 </a:solidFill>
-                <a:latin typeface="Courier New"/>
+                <a:latin typeface="Calibri"/>
               </a:rPr>
               <a:t>READ-ONLY SHAREPOINT</a:t>
             </a:r>
@@ -3593,8 +3593,8 @@
         </p:nvSpPr>
         <p:spPr>
           <a:xfrm>
-            <a:off x="2670048" y="1536192"/>
-            <a:ext cx="2432303" cy="274320"/>
+            <a:off x="2596896" y="1536192"/>
+            <a:ext cx="2331720" cy="274320"/>
           </a:xfrm>
           <a:prstGeom prst="roundRect">
             <a:avLst>
@@ -3602,7 +3602,7 @@
             </a:avLst>
           </a:prstGeom>
           <a:noFill/>
-          <a:ln w="9525">
+          <a:ln w="12700">
             <a:solidFill>
               <a:srgbClr val="D97757"/>
             </a:solidFill>
@@ -3637,8 +3637,8 @@
         </p:nvSpPr>
         <p:spPr>
           <a:xfrm>
-            <a:off x="2670048" y="1600200"/>
-            <a:ext cx="2432303" cy="182880"/>
+            <a:off x="2596896" y="1600200"/>
+            <a:ext cx="2331720" cy="182880"/>
           </a:xfrm>
           <a:prstGeom prst="rect">
             <a:avLst/>
@@ -3653,11 +3653,11 @@
           <a:p>
             <a:pPr algn="ctr"/>
             <a:r>
-              <a:rPr sz="850" b="0" spc="100">
+              <a:rPr sz="850" b="1" spc="100">
                 <a:solidFill>
                   <a:srgbClr val="A04D2C"/>
                 </a:solidFill>
-                <a:latin typeface="Courier New"/>
+                <a:latin typeface="Calibri"/>
               </a:rPr>
               <a:t>1 MODEL CALL PER DOCUMENT</a:t>
             </a:r>
@@ -3672,8 +3672,8 @@
         </p:nvSpPr>
         <p:spPr>
           <a:xfrm>
-            <a:off x="5212080" y="1536192"/>
-            <a:ext cx="2432303" cy="274320"/>
+            <a:off x="5038344" y="1536192"/>
+            <a:ext cx="2331720" cy="274320"/>
           </a:xfrm>
           <a:prstGeom prst="roundRect">
             <a:avLst>
@@ -3681,7 +3681,7 @@
             </a:avLst>
           </a:prstGeom>
           <a:noFill/>
-          <a:ln w="9525">
+          <a:ln w="12700">
             <a:solidFill>
               <a:srgbClr val="00A396"/>
             </a:solidFill>
@@ -3716,8 +3716,8 @@
         </p:nvSpPr>
         <p:spPr>
           <a:xfrm>
-            <a:off x="5212080" y="1600200"/>
-            <a:ext cx="2432303" cy="182880"/>
+            <a:off x="5038344" y="1600200"/>
+            <a:ext cx="2331720" cy="182880"/>
           </a:xfrm>
           <a:prstGeom prst="rect">
             <a:avLst/>
@@ -3732,11 +3732,11 @@
           <a:p>
             <a:pPr algn="ctr"/>
             <a:r>
-              <a:rPr sz="850" b="0" spc="100">
+              <a:rPr sz="850" b="1" spc="100">
                 <a:solidFill>
                   <a:srgbClr val="007067"/>
                 </a:solidFill>
-                <a:latin typeface="Courier New"/>
+                <a:latin typeface="Calibri"/>
               </a:rPr>
               <a:t>VERDICTS COMPUTED IN CODE</a:t>
             </a:r>
@@ -3857,11 +3857,11 @@
           <a:p>
             <a:pPr algn="l"/>
             <a:r>
-              <a:rPr sz="900" b="0" spc="140">
+              <a:rPr sz="900" b="1" spc="120">
                 <a:solidFill>
                   <a:srgbClr val="5642A6"/>
                 </a:solidFill>
-                <a:latin typeface="Courier New"/>
+                <a:latin typeface="Consolas"/>
               </a:rPr>
               <a:t>SRC</a:t>
             </a:r>
@@ -3957,7 +3957,7 @@
             <a:r>
               <a:rPr sz="1100" b="0">
                 <a:solidFill>
-                  <a:srgbClr val="404854"/>
+                  <a:srgbClr val="2F343C"/>
                 </a:solidFill>
                 <a:latin typeface="Calibri"/>
               </a:rPr>
@@ -4150,11 +4150,11 @@
           <a:p>
             <a:pPr algn="l"/>
             <a:r>
-              <a:rPr sz="900" b="0" spc="140">
+              <a:rPr sz="900" b="1" spc="120">
                 <a:solidFill>
                   <a:srgbClr val="007067"/>
                 </a:solidFill>
-                <a:latin typeface="Courier New"/>
+                <a:latin typeface="Consolas"/>
               </a:rPr>
               <a:t>00</a:t>
             </a:r>
@@ -4250,7 +4250,7 @@
             <a:r>
               <a:rPr sz="1100" b="0">
                 <a:solidFill>
-                  <a:srgbClr val="404854"/>
+                  <a:srgbClr val="2F343C"/>
                 </a:solidFill>
                 <a:latin typeface="Calibri"/>
               </a:rPr>
@@ -4373,11 +4373,11 @@
           <a:p>
             <a:pPr algn="l"/>
             <a:r>
-              <a:rPr sz="900" b="0" spc="140">
+              <a:rPr sz="900" b="1" spc="120">
                 <a:solidFill>
                   <a:srgbClr val="007067"/>
                 </a:solidFill>
-                <a:latin typeface="Courier New"/>
+                <a:latin typeface="Consolas"/>
               </a:rPr>
               <a:t>01–04</a:t>
             </a:r>
@@ -4449,7 +4449,7 @@
             <a:r>
               <a:rPr sz="1100" b="0">
                 <a:solidFill>
-                  <a:srgbClr val="404854"/>
+                  <a:srgbClr val="2F343C"/>
                 </a:solidFill>
                 <a:latin typeface="Calibri"/>
               </a:rPr>
@@ -4572,11 +4572,11 @@
           <a:p>
             <a:pPr algn="l"/>
             <a:r>
-              <a:rPr sz="900" b="0" spc="140">
+              <a:rPr sz="900" b="1" spc="120">
                 <a:solidFill>
                   <a:srgbClr val="866103"/>
                 </a:solidFill>
-                <a:latin typeface="Courier New"/>
+                <a:latin typeface="Consolas"/>
               </a:rPr>
               <a:t>HITL</a:t>
             </a:r>
@@ -4672,7 +4672,7 @@
             <a:r>
               <a:rPr sz="1100" b="0">
                 <a:solidFill>
-                  <a:srgbClr val="404854"/>
+                  <a:srgbClr val="2F343C"/>
                 </a:solidFill>
                 <a:latin typeface="Calibri"/>
               </a:rPr>
@@ -4795,11 +4795,11 @@
           <a:p>
             <a:pPr algn="l"/>
             <a:r>
-              <a:rPr sz="900" b="0" spc="140">
+              <a:rPr sz="900" b="1" spc="120">
                 <a:solidFill>
                   <a:srgbClr val="5642A6"/>
                 </a:solidFill>
-                <a:latin typeface="Courier New"/>
+                <a:latin typeface="Consolas"/>
               </a:rPr>
               <a:t>OUT</a:t>
             </a:r>
@@ -4895,7 +4895,7 @@
             <a:r>
               <a:rPr sz="1100" b="0">
                 <a:solidFill>
-                  <a:srgbClr val="404854"/>
+                  <a:srgbClr val="2F343C"/>
                 </a:solidFill>
                 <a:latin typeface="Calibri"/>
               </a:rPr>
@@ -5044,11 +5044,11 @@
           <a:p>
             <a:pPr algn="ctr"/>
             <a:r>
-              <a:rPr sz="850" b="0">
+              <a:rPr sz="850" b="1">
                 <a:solidFill>
                   <a:srgbClr val="007067"/>
                 </a:solidFill>
-                <a:latin typeface="Courier New"/>
+                <a:latin typeface="Consolas"/>
               </a:rPr>
               <a:t>01</a:t>
             </a:r>
@@ -5196,11 +5196,11 @@
           <a:p>
             <a:pPr algn="ctr"/>
             <a:r>
-              <a:rPr sz="850" b="0">
+              <a:rPr sz="850" b="1">
                 <a:solidFill>
                   <a:srgbClr val="A04D2C"/>
                 </a:solidFill>
-                <a:latin typeface="Courier New"/>
+                <a:latin typeface="Consolas"/>
               </a:rPr>
               <a:t>02</a:t>
             </a:r>
@@ -5348,11 +5348,11 @@
           <a:p>
             <a:pPr algn="ctr"/>
             <a:r>
-              <a:rPr sz="850" b="0">
+              <a:rPr sz="850" b="1">
                 <a:solidFill>
                   <a:srgbClr val="007067"/>
                 </a:solidFill>
-                <a:latin typeface="Courier New"/>
+                <a:latin typeface="Consolas"/>
               </a:rPr>
               <a:t>03</a:t>
             </a:r>
@@ -5500,11 +5500,11 @@
           <a:p>
             <a:pPr algn="ctr"/>
             <a:r>
-              <a:rPr sz="850" b="0">
+              <a:rPr sz="850" b="1">
                 <a:solidFill>
                   <a:srgbClr val="007067"/>
                 </a:solidFill>
-                <a:latin typeface="Courier New"/>
+                <a:latin typeface="Consolas"/>
               </a:rPr>
               <a:t>04</a:t>
             </a:r>
@@ -5595,9 +5595,9 @@
           <a:prstGeom prst="line">
             <a:avLst/>
           </a:prstGeom>
-          <a:ln w="12700">
+          <a:ln w="15875">
             <a:solidFill>
-              <a:srgbClr val="738091"/>
+              <a:srgbClr val="2F343C"/>
             </a:solidFill>
             <a:tailEnd type="triangle" w="sm" len="sm"/>
           </a:ln>
@@ -5631,9 +5631,9 @@
           <a:prstGeom prst="line">
             <a:avLst/>
           </a:prstGeom>
-          <a:ln w="12700">
+          <a:ln w="15875">
             <a:solidFill>
-              <a:srgbClr val="738091"/>
+              <a:srgbClr val="2F343C"/>
             </a:solidFill>
             <a:tailEnd type="triangle" w="sm" len="sm"/>
           </a:ln>
@@ -5667,9 +5667,9 @@
           <a:prstGeom prst="line">
             <a:avLst/>
           </a:prstGeom>
-          <a:ln w="12700">
+          <a:ln w="15875">
             <a:solidFill>
-              <a:srgbClr val="738091"/>
+              <a:srgbClr val="2F343C"/>
             </a:solidFill>
             <a:tailEnd type="triangle" w="sm" len="sm"/>
           </a:ln>
@@ -5703,9 +5703,9 @@
           <a:prstGeom prst="line">
             <a:avLst/>
           </a:prstGeom>
-          <a:ln w="12700">
+          <a:ln w="15875">
             <a:solidFill>
-              <a:srgbClr val="738091"/>
+              <a:srgbClr val="2F343C"/>
             </a:solidFill>
             <a:tailEnd type="triangle" w="sm" len="sm"/>
           </a:ln>
@@ -5858,11 +5858,11 @@
           <a:p>
             <a:pPr algn="ctr"/>
             <a:r>
-              <a:rPr sz="900" b="0">
+              <a:rPr sz="950" b="1">
                 <a:solidFill>
                   <a:srgbClr val="866103"/>
                 </a:solidFill>
-                <a:latin typeface="Courier New"/>
+                <a:latin typeface="Calibri"/>
               </a:rPr>
               <a:t>the reviewer uploads the approved STTM   →   the next sync pairs it   →   it becomes a template</a:t>
             </a:r>
@@ -6001,7 +6001,7 @@
             <a:r>
               <a:rPr sz="1000" b="0">
                 <a:solidFill>
-                  <a:srgbClr val="404854"/>
+                  <a:srgbClr val="2F343C"/>
                 </a:solidFill>
                 <a:latin typeface="Calibri"/>
               </a:rPr>
@@ -6036,9 +6036,9 @@
             <a:r>
               <a:rPr sz="850" b="0">
                 <a:solidFill>
-                  <a:srgbClr val="738091"/>
+                  <a:srgbClr val="5F6B7C"/>
                 </a:solidFill>
-                <a:latin typeface="Courier New"/>
+                <a:latin typeface="Calibri"/>
               </a:rPr>
               <a:t>staging · 2026-08-22 · verified offline · live deploy pending</a:t>
             </a:r>

</xml_diff>

<commit_message>
context: one-slide architecture v4.2 — legible close-up thumbnails (one FRD requirement; three-column STTM rows), 'pulls from SharePoint · never writes back' wording, rebalanced node widths
The whole-page FRD and full-sheet STTM thumbnails were unreadable at 1.9 in
(PowerPoint screenshots 2026-08-22 9:07 PM). Replaced with close-ups drawn at
thumbnail scale. The SharePoint chip/caption now say what the agent does:
the sync pulls FRDs + STTMs into Databricks; it never writes back.

Co-Authored-By: Claude Fable 5 <noreply@anthropic.com>
</commit_message>
<xml_diff>
--- a/context/FRD_to_STTM_Agent_System_Architecture.pptx
+++ b/context/FRD_to_STTM_Agent_System_Architecture.pptx
@@ -3515,7 +3515,7 @@
         <p:spPr>
           <a:xfrm>
             <a:off x="548640" y="1536192"/>
-            <a:ext cx="1938527" cy="274320"/>
+            <a:ext cx="3589934" cy="274320"/>
           </a:xfrm>
           <a:prstGeom prst="roundRect">
             <a:avLst>
@@ -3559,7 +3559,7 @@
         <p:spPr>
           <a:xfrm>
             <a:off x="548640" y="1600200"/>
-            <a:ext cx="1938527" cy="182880"/>
+            <a:ext cx="3589934" cy="182880"/>
           </a:xfrm>
           <a:prstGeom prst="rect">
             <a:avLst/>
@@ -3580,7 +3580,7 @@
                 </a:solidFill>
                 <a:latin typeface="Calibri"/>
               </a:rPr>
-              <a:t>READ-ONLY SHAREPOINT</a:t>
+              <a:t>PULLS FROM SHAREPOINT · NEVER WRITES BACK</a:t>
             </a:r>
           </a:p>
         </p:txBody>
@@ -3593,7 +3593,7 @@
         </p:nvSpPr>
         <p:spPr>
           <a:xfrm>
-            <a:off x="2596896" y="1536192"/>
+            <a:off x="4248302" y="1536192"/>
             <a:ext cx="2331720" cy="274320"/>
           </a:xfrm>
           <a:prstGeom prst="roundRect">
@@ -3637,7 +3637,7 @@
         </p:nvSpPr>
         <p:spPr>
           <a:xfrm>
-            <a:off x="2596896" y="1600200"/>
+            <a:off x="4248302" y="1600200"/>
             <a:ext cx="2331720" cy="182880"/>
           </a:xfrm>
           <a:prstGeom prst="rect">
@@ -3672,7 +3672,7 @@
         </p:nvSpPr>
         <p:spPr>
           <a:xfrm>
-            <a:off x="5038344" y="1536192"/>
+            <a:off x="6689750" y="1536192"/>
             <a:ext cx="2331720" cy="274320"/>
           </a:xfrm>
           <a:prstGeom prst="roundRect">
@@ -3716,7 +3716,7 @@
         </p:nvSpPr>
         <p:spPr>
           <a:xfrm>
-            <a:off x="5038344" y="1600200"/>
+            <a:off x="6689750" y="1600200"/>
             <a:ext cx="2331720" cy="182880"/>
           </a:xfrm>
           <a:prstGeom prst="rect">
@@ -3752,7 +3752,7 @@
         <p:spPr>
           <a:xfrm>
             <a:off x="548640" y="2011680"/>
-            <a:ext cx="2011680" cy="2788920"/>
+            <a:ext cx="1874519" cy="2788920"/>
           </a:xfrm>
           <a:prstGeom prst="roundRect">
             <a:avLst>
@@ -3877,7 +3877,7 @@
         <p:spPr>
           <a:xfrm>
             <a:off x="768096" y="2432304"/>
-            <a:ext cx="1645920" cy="310896"/>
+            <a:ext cx="1508760" cy="310896"/>
           </a:xfrm>
           <a:prstGeom prst="rect">
             <a:avLst/>
@@ -3919,7 +3919,7 @@
         </p:blipFill>
         <p:spPr>
           <a:xfrm>
-            <a:off x="2084832" y="2157984"/>
+            <a:off x="1947672" y="2157984"/>
             <a:ext cx="274320" cy="274320"/>
           </a:xfrm>
           <a:prstGeom prst="rect">
@@ -3936,7 +3936,7 @@
         <p:spPr>
           <a:xfrm>
             <a:off x="768096" y="2816352"/>
-            <a:ext cx="1591056" cy="1097280"/>
+            <a:ext cx="1453895" cy="1097280"/>
           </a:xfrm>
           <a:prstGeom prst="rect">
             <a:avLst/>
@@ -3961,7 +3961,7 @@
                 </a:solidFill>
                 <a:latin typeface="Calibri"/>
               </a:rPr>
-              <a:t>System of record. FRDs in, approved STTMs back. The agent only ever reads it.</a:t>
+              <a:t>System of record. The sync pulls FRDs and STTMs into Databricks and never writes back.</a:t>
             </a:r>
           </a:p>
         </p:txBody>
@@ -3974,8 +3974,8 @@
         </p:nvSpPr>
         <p:spPr>
           <a:xfrm>
-            <a:off x="694944" y="3758183"/>
-            <a:ext cx="1719072" cy="896112"/>
+            <a:off x="694944" y="3849624"/>
+            <a:ext cx="1581911" cy="804672"/>
           </a:xfrm>
           <a:prstGeom prst="roundRect">
             <a:avLst>
@@ -4028,8 +4028,8 @@
         </p:blipFill>
         <p:spPr>
           <a:xfrm>
-            <a:off x="885952" y="3776472"/>
-            <a:ext cx="1337055" cy="859536"/>
+            <a:off x="739140" y="3867912"/>
+            <a:ext cx="1493519" cy="768095"/>
           </a:xfrm>
           <a:prstGeom prst="rect">
             <a:avLst/>
@@ -4044,8 +4044,8 @@
         </p:nvSpPr>
         <p:spPr>
           <a:xfrm>
-            <a:off x="2834640" y="2011680"/>
-            <a:ext cx="1874519" cy="2788920"/>
+            <a:off x="2697480" y="2011680"/>
+            <a:ext cx="1783080" cy="2788920"/>
           </a:xfrm>
           <a:prstGeom prst="roundRect">
             <a:avLst>
@@ -4090,7 +4090,7 @@
         </p:nvSpPr>
         <p:spPr>
           <a:xfrm>
-            <a:off x="3022092" y="2235708"/>
+            <a:off x="2884932" y="2235708"/>
             <a:ext cx="100584" cy="100584"/>
           </a:xfrm>
           <a:prstGeom prst="ellipse">
@@ -4134,7 +4134,7 @@
         </p:nvSpPr>
         <p:spPr>
           <a:xfrm>
-            <a:off x="3236976" y="2185416"/>
+            <a:off x="3099816" y="2185416"/>
             <a:ext cx="914400" cy="219456"/>
           </a:xfrm>
           <a:prstGeom prst="rect">
@@ -4169,8 +4169,8 @@
         </p:nvSpPr>
         <p:spPr>
           <a:xfrm>
-            <a:off x="3054096" y="2432304"/>
-            <a:ext cx="1508760" cy="310896"/>
+            <a:off x="2916936" y="2432304"/>
+            <a:ext cx="1417319" cy="310896"/>
           </a:xfrm>
           <a:prstGeom prst="rect">
             <a:avLst/>
@@ -4212,7 +4212,7 @@
         </p:blipFill>
         <p:spPr>
           <a:xfrm>
-            <a:off x="4233672" y="2157984"/>
+            <a:off x="4005072" y="2157984"/>
             <a:ext cx="274320" cy="274320"/>
           </a:xfrm>
           <a:prstGeom prst="rect">
@@ -4228,8 +4228,8 @@
         </p:nvSpPr>
         <p:spPr>
           <a:xfrm>
-            <a:off x="3054096" y="2816352"/>
-            <a:ext cx="1453895" cy="1097280"/>
+            <a:off x="2916936" y="2816352"/>
+            <a:ext cx="1362456" cy="1097280"/>
           </a:xfrm>
           <a:prstGeom prst="rect">
             <a:avLst/>
@@ -4267,8 +4267,8 @@
         </p:nvSpPr>
         <p:spPr>
           <a:xfrm>
-            <a:off x="4983480" y="2011680"/>
-            <a:ext cx="2697480" cy="2788920"/>
+            <a:off x="4754880" y="2011680"/>
+            <a:ext cx="2560320" cy="2788920"/>
           </a:xfrm>
           <a:prstGeom prst="roundRect">
             <a:avLst>
@@ -4313,7 +4313,7 @@
         </p:nvSpPr>
         <p:spPr>
           <a:xfrm>
-            <a:off x="5170932" y="2235708"/>
+            <a:off x="4942332" y="2235708"/>
             <a:ext cx="100584" cy="100584"/>
           </a:xfrm>
           <a:prstGeom prst="ellipse">
@@ -4357,7 +4357,7 @@
         </p:nvSpPr>
         <p:spPr>
           <a:xfrm>
-            <a:off x="5385816" y="2185416"/>
+            <a:off x="5157216" y="2185416"/>
             <a:ext cx="914400" cy="219456"/>
           </a:xfrm>
           <a:prstGeom prst="rect">
@@ -4392,8 +4392,8 @@
         </p:nvSpPr>
         <p:spPr>
           <a:xfrm>
-            <a:off x="5202936" y="2432304"/>
-            <a:ext cx="2331720" cy="310896"/>
+            <a:off x="4974336" y="2432304"/>
+            <a:ext cx="2194560" cy="310896"/>
           </a:xfrm>
           <a:prstGeom prst="rect">
             <a:avLst/>
@@ -4427,8 +4427,8 @@
         </p:nvSpPr>
         <p:spPr>
           <a:xfrm>
-            <a:off x="5202936" y="2816352"/>
-            <a:ext cx="2276856" cy="1097280"/>
+            <a:off x="4974336" y="2816352"/>
+            <a:ext cx="2139696" cy="1097280"/>
           </a:xfrm>
           <a:prstGeom prst="rect">
             <a:avLst/>
@@ -4466,8 +4466,8 @@
         </p:nvSpPr>
         <p:spPr>
           <a:xfrm>
-            <a:off x="7955279" y="2011680"/>
-            <a:ext cx="1783080" cy="2788920"/>
+            <a:off x="7589520" y="2011680"/>
+            <a:ext cx="1691640" cy="2788920"/>
           </a:xfrm>
           <a:prstGeom prst="roundRect">
             <a:avLst>
@@ -4512,7 +4512,7 @@
         </p:nvSpPr>
         <p:spPr>
           <a:xfrm>
-            <a:off x="8142731" y="2235708"/>
+            <a:off x="7776972" y="2235708"/>
             <a:ext cx="100584" cy="100584"/>
           </a:xfrm>
           <a:prstGeom prst="ellipse">
@@ -4556,7 +4556,7 @@
         </p:nvSpPr>
         <p:spPr>
           <a:xfrm>
-            <a:off x="8357615" y="2185416"/>
+            <a:off x="7991856" y="2185416"/>
             <a:ext cx="914400" cy="219456"/>
           </a:xfrm>
           <a:prstGeom prst="rect">
@@ -4591,8 +4591,8 @@
         </p:nvSpPr>
         <p:spPr>
           <a:xfrm>
-            <a:off x="8174736" y="2432304"/>
-            <a:ext cx="1417319" cy="310896"/>
+            <a:off x="7808976" y="2432304"/>
+            <a:ext cx="1325880" cy="310896"/>
           </a:xfrm>
           <a:prstGeom prst="rect">
             <a:avLst/>
@@ -4634,7 +4634,7 @@
         </p:blipFill>
         <p:spPr>
           <a:xfrm>
-            <a:off x="9262872" y="2157984"/>
+            <a:off x="8805672" y="2157984"/>
             <a:ext cx="274320" cy="274320"/>
           </a:xfrm>
           <a:prstGeom prst="rect">
@@ -4650,8 +4650,8 @@
         </p:nvSpPr>
         <p:spPr>
           <a:xfrm>
-            <a:off x="8174736" y="2816352"/>
-            <a:ext cx="1362456" cy="1097280"/>
+            <a:off x="7808976" y="2816352"/>
+            <a:ext cx="1271016" cy="1097280"/>
           </a:xfrm>
           <a:prstGeom prst="rect">
             <a:avLst/>
@@ -4689,8 +4689,8 @@
         </p:nvSpPr>
         <p:spPr>
           <a:xfrm>
-            <a:off x="10012680" y="2011680"/>
-            <a:ext cx="1627632" cy="2788920"/>
+            <a:off x="9555480" y="2011680"/>
+            <a:ext cx="2084831" cy="2788920"/>
           </a:xfrm>
           <a:prstGeom prst="roundRect">
             <a:avLst>
@@ -4735,7 +4735,7 @@
         </p:nvSpPr>
         <p:spPr>
           <a:xfrm>
-            <a:off x="10200132" y="2235708"/>
+            <a:off x="9742932" y="2235708"/>
             <a:ext cx="100584" cy="100584"/>
           </a:xfrm>
           <a:prstGeom prst="ellipse">
@@ -4779,7 +4779,7 @@
         </p:nvSpPr>
         <p:spPr>
           <a:xfrm>
-            <a:off x="10415015" y="2185416"/>
+            <a:off x="9957815" y="2185416"/>
             <a:ext cx="914400" cy="219456"/>
           </a:xfrm>
           <a:prstGeom prst="rect">
@@ -4814,8 +4814,8 @@
         </p:nvSpPr>
         <p:spPr>
           <a:xfrm>
-            <a:off x="10232136" y="2432304"/>
-            <a:ext cx="1261872" cy="310896"/>
+            <a:off x="9774936" y="2432304"/>
+            <a:ext cx="1719072" cy="310896"/>
           </a:xfrm>
           <a:prstGeom prst="rect">
             <a:avLst/>
@@ -4873,8 +4873,8 @@
         </p:nvSpPr>
         <p:spPr>
           <a:xfrm>
-            <a:off x="10232136" y="2816352"/>
-            <a:ext cx="1207008" cy="1097280"/>
+            <a:off x="9774936" y="2816352"/>
+            <a:ext cx="1664207" cy="1097280"/>
           </a:xfrm>
           <a:prstGeom prst="rect">
             <a:avLst/>
@@ -4912,8 +4912,8 @@
         </p:nvSpPr>
         <p:spPr>
           <a:xfrm>
-            <a:off x="10158984" y="3758183"/>
-            <a:ext cx="1335024" cy="896112"/>
+            <a:off x="9701784" y="3849624"/>
+            <a:ext cx="1792223" cy="804672"/>
           </a:xfrm>
           <a:prstGeom prst="roundRect">
             <a:avLst>
@@ -4966,8 +4966,8 @@
         </p:blipFill>
         <p:spPr>
           <a:xfrm>
-            <a:off x="10177272" y="3788881"/>
-            <a:ext cx="1298448" cy="834716"/>
+            <a:off x="10019759" y="3867912"/>
+            <a:ext cx="1156273" cy="768096"/>
           </a:xfrm>
           <a:prstGeom prst="rect">
             <a:avLst/>
@@ -4982,8 +4982,8 @@
         </p:nvSpPr>
         <p:spPr>
           <a:xfrm>
-            <a:off x="5202936" y="3904487"/>
-            <a:ext cx="496062" cy="457200"/>
+            <a:off x="4974336" y="3904487"/>
+            <a:ext cx="461771" cy="457200"/>
           </a:xfrm>
           <a:prstGeom prst="roundRect">
             <a:avLst>
@@ -5028,8 +5028,8 @@
         </p:nvSpPr>
         <p:spPr>
           <a:xfrm>
-            <a:off x="5202936" y="3968496"/>
-            <a:ext cx="496062" cy="164592"/>
+            <a:off x="4974336" y="3968496"/>
+            <a:ext cx="461771" cy="164592"/>
           </a:xfrm>
           <a:prstGeom prst="rect">
             <a:avLst/>
@@ -5063,8 +5063,8 @@
         </p:nvSpPr>
         <p:spPr>
           <a:xfrm>
-            <a:off x="5202936" y="4123944"/>
-            <a:ext cx="496062" cy="201168"/>
+            <a:off x="4974336" y="4123944"/>
+            <a:ext cx="461771" cy="201168"/>
           </a:xfrm>
           <a:prstGeom prst="rect">
             <a:avLst/>
@@ -5079,7 +5079,7 @@
           <a:p>
             <a:pPr algn="ctr"/>
             <a:r>
-              <a:rPr sz="950" b="0">
+              <a:rPr sz="900" b="0">
                 <a:solidFill>
                   <a:srgbClr val="1C2127"/>
                 </a:solidFill>
@@ -5098,7 +5098,7 @@
         </p:nvCxnSpPr>
         <p:spPr>
           <a:xfrm>
-            <a:off x="5708142" y="4133087"/>
+            <a:off x="5445252" y="4133087"/>
             <a:ext cx="73152" cy="0"/>
           </a:xfrm>
           <a:prstGeom prst="line">
@@ -5134,8 +5134,8 @@
         </p:nvSpPr>
         <p:spPr>
           <a:xfrm>
-            <a:off x="5790438" y="3904487"/>
-            <a:ext cx="496062" cy="457200"/>
+            <a:off x="5527548" y="3904487"/>
+            <a:ext cx="461771" cy="457200"/>
           </a:xfrm>
           <a:prstGeom prst="roundRect">
             <a:avLst>
@@ -5180,8 +5180,8 @@
         </p:nvSpPr>
         <p:spPr>
           <a:xfrm>
-            <a:off x="5790438" y="3968496"/>
-            <a:ext cx="496062" cy="164592"/>
+            <a:off x="5527548" y="3968496"/>
+            <a:ext cx="461771" cy="164592"/>
           </a:xfrm>
           <a:prstGeom prst="rect">
             <a:avLst/>
@@ -5215,8 +5215,8 @@
         </p:nvSpPr>
         <p:spPr>
           <a:xfrm>
-            <a:off x="5790438" y="4123944"/>
-            <a:ext cx="496062" cy="201168"/>
+            <a:off x="5527548" y="4123944"/>
+            <a:ext cx="461771" cy="201168"/>
           </a:xfrm>
           <a:prstGeom prst="rect">
             <a:avLst/>
@@ -5231,7 +5231,7 @@
           <a:p>
             <a:pPr algn="ctr"/>
             <a:r>
-              <a:rPr sz="950" b="1">
+              <a:rPr sz="900" b="1">
                 <a:solidFill>
                   <a:srgbClr val="A04D2C"/>
                 </a:solidFill>
@@ -5250,7 +5250,7 @@
         </p:nvCxnSpPr>
         <p:spPr>
           <a:xfrm>
-            <a:off x="6295644" y="4133087"/>
+            <a:off x="5998464" y="4133087"/>
             <a:ext cx="73152" cy="0"/>
           </a:xfrm>
           <a:prstGeom prst="line">
@@ -5286,8 +5286,8 @@
         </p:nvSpPr>
         <p:spPr>
           <a:xfrm>
-            <a:off x="6377940" y="3904487"/>
-            <a:ext cx="496062" cy="457200"/>
+            <a:off x="6080760" y="3904487"/>
+            <a:ext cx="461771" cy="457200"/>
           </a:xfrm>
           <a:prstGeom prst="roundRect">
             <a:avLst>
@@ -5332,8 +5332,8 @@
         </p:nvSpPr>
         <p:spPr>
           <a:xfrm>
-            <a:off x="6377940" y="3968496"/>
-            <a:ext cx="496062" cy="164592"/>
+            <a:off x="6080760" y="3968496"/>
+            <a:ext cx="461771" cy="164592"/>
           </a:xfrm>
           <a:prstGeom prst="rect">
             <a:avLst/>
@@ -5367,8 +5367,8 @@
         </p:nvSpPr>
         <p:spPr>
           <a:xfrm>
-            <a:off x="6377940" y="4123944"/>
-            <a:ext cx="496062" cy="201168"/>
+            <a:off x="6080760" y="4123944"/>
+            <a:ext cx="461771" cy="201168"/>
           </a:xfrm>
           <a:prstGeom prst="rect">
             <a:avLst/>
@@ -5383,7 +5383,7 @@
           <a:p>
             <a:pPr algn="ctr"/>
             <a:r>
-              <a:rPr sz="950" b="0">
+              <a:rPr sz="900" b="0">
                 <a:solidFill>
                   <a:srgbClr val="1C2127"/>
                 </a:solidFill>
@@ -5402,7 +5402,7 @@
         </p:nvCxnSpPr>
         <p:spPr>
           <a:xfrm>
-            <a:off x="6883146" y="4133087"/>
+            <a:off x="6551676" y="4133087"/>
             <a:ext cx="73152" cy="0"/>
           </a:xfrm>
           <a:prstGeom prst="line">
@@ -5438,8 +5438,8 @@
         </p:nvSpPr>
         <p:spPr>
           <a:xfrm>
-            <a:off x="6965442" y="3904487"/>
-            <a:ext cx="496062" cy="457200"/>
+            <a:off x="6633972" y="3904487"/>
+            <a:ext cx="461771" cy="457200"/>
           </a:xfrm>
           <a:prstGeom prst="roundRect">
             <a:avLst>
@@ -5484,8 +5484,8 @@
         </p:nvSpPr>
         <p:spPr>
           <a:xfrm>
-            <a:off x="6965442" y="3968496"/>
-            <a:ext cx="496062" cy="164592"/>
+            <a:off x="6633972" y="3968496"/>
+            <a:ext cx="461771" cy="164592"/>
           </a:xfrm>
           <a:prstGeom prst="rect">
             <a:avLst/>
@@ -5519,8 +5519,8 @@
         </p:nvSpPr>
         <p:spPr>
           <a:xfrm>
-            <a:off x="6965442" y="4123944"/>
-            <a:ext cx="496062" cy="201168"/>
+            <a:off x="6633972" y="4123944"/>
+            <a:ext cx="461771" cy="201168"/>
           </a:xfrm>
           <a:prstGeom prst="rect">
             <a:avLst/>
@@ -5535,7 +5535,7 @@
           <a:p>
             <a:pPr algn="ctr"/>
             <a:r>
-              <a:rPr sz="950" b="0">
+              <a:rPr sz="900" b="0">
                 <a:solidFill>
                   <a:srgbClr val="1C2127"/>
                 </a:solidFill>
@@ -5554,8 +5554,8 @@
         </p:nvSpPr>
         <p:spPr>
           <a:xfrm>
-            <a:off x="5202936" y="4453127"/>
-            <a:ext cx="2258568" cy="219456"/>
+            <a:off x="4974336" y="4453127"/>
+            <a:ext cx="2121408" cy="219456"/>
           </a:xfrm>
           <a:prstGeom prst="rect">
             <a:avLst/>
@@ -5589,7 +5589,7 @@
         </p:nvCxnSpPr>
         <p:spPr>
           <a:xfrm>
-            <a:off x="2578608" y="2560320"/>
+            <a:off x="2441448" y="2560320"/>
             <a:ext cx="237744" cy="0"/>
           </a:xfrm>
           <a:prstGeom prst="line">
@@ -5625,7 +5625,7 @@
         </p:nvCxnSpPr>
         <p:spPr>
           <a:xfrm>
-            <a:off x="4727448" y="2560320"/>
+            <a:off x="4498848" y="2560320"/>
             <a:ext cx="237744" cy="0"/>
           </a:xfrm>
           <a:prstGeom prst="line">
@@ -5661,7 +5661,7 @@
         </p:nvCxnSpPr>
         <p:spPr>
           <a:xfrm>
-            <a:off x="7699248" y="2560320"/>
+            <a:off x="7333488" y="2560320"/>
             <a:ext cx="237744" cy="0"/>
           </a:xfrm>
           <a:prstGeom prst="line">
@@ -5697,8 +5697,8 @@
         </p:nvCxnSpPr>
         <p:spPr>
           <a:xfrm>
-            <a:off x="9756647" y="2560320"/>
-            <a:ext cx="237745" cy="0"/>
+            <a:off x="9299448" y="2560320"/>
+            <a:ext cx="237744" cy="0"/>
           </a:xfrm>
           <a:prstGeom prst="line">
             <a:avLst/>
@@ -5733,7 +5733,7 @@
         </p:nvCxnSpPr>
         <p:spPr>
           <a:xfrm>
-            <a:off x="8595359" y="4800600"/>
+            <a:off x="8229600" y="4800600"/>
             <a:ext cx="0" cy="237744"/>
           </a:xfrm>
           <a:prstGeom prst="line">
@@ -5770,7 +5770,7 @@
         <p:spPr>
           <a:xfrm flipH="1">
             <a:off x="1188719" y="5038344"/>
-            <a:ext cx="7406640" cy="0"/>
+            <a:ext cx="7040881" cy="0"/>
           </a:xfrm>
           <a:prstGeom prst="line">
             <a:avLst/>

</xml_diff>

<commit_message>
context: one-slide architecture v5 — top-down technology layers with official logos; inputs/outputs called out
SharePoint (FRD .docx, approved STTM .xlsx, Entra ID/Graph read) -> Databricks
(Unity Catalog volumes + Delta; Jobs pipeline 01-04 with Claude on 02; Apps
review UI on FastAPI + React) -> Human review (approved STTM loops back to
SharePoint) + Outputs (STTM .xlsx, contract.json -> CodeGen, Code Review).
Logos: Wikimedia Commons + unitycatalog GitHub, trimmed, in
scripts/deck_assets/logos (sources in ONEPAGER_DESIGN.md). Validated; QA'd.

Co-Authored-By: Claude Fable 5 <noreply@anthropic.com>
</commit_message>
<xml_diff>
--- a/context/FRD_to_STTM_Agent_System_Architecture.pptx
+++ b/context/FRD_to_STTM_Agent_System_Architecture.pptx
@@ -3400,7 +3400,7 @@
         </p:nvSpPr>
         <p:spPr>
           <a:xfrm>
-            <a:off x="548640" y="420624"/>
+            <a:off x="548640" y="347472"/>
             <a:ext cx="8229600" cy="219456"/>
           </a:xfrm>
           <a:prstGeom prst="rect">
@@ -3435,8 +3435,8 @@
         </p:nvSpPr>
         <p:spPr>
           <a:xfrm>
-            <a:off x="548640" y="658368"/>
-            <a:ext cx="8686800" cy="548640"/>
+            <a:off x="548640" y="548640"/>
+            <a:ext cx="8686800" cy="502920"/>
           </a:xfrm>
           <a:prstGeom prst="rect">
             <a:avLst/>
@@ -3451,7 +3451,7 @@
           <a:p>
             <a:pPr algn="l"/>
             <a:r>
-              <a:rPr sz="3000" b="1">
+              <a:rPr sz="2800" b="1">
                 <a:solidFill>
                   <a:srgbClr val="111418"/>
                 </a:solidFill>
@@ -3460,7 +3460,7 @@
               <a:t>FRD → STTM Agent</a:t>
             </a:r>
             <a:r>
-              <a:rPr sz="1600" b="0">
+              <a:rPr sz="1500" b="0">
                 <a:solidFill>
                   <a:srgbClr val="5F6B7C"/>
                 </a:solidFill>
@@ -3479,8 +3479,8 @@
         </p:nvSpPr>
         <p:spPr>
           <a:xfrm>
-            <a:off x="548640" y="1170432"/>
-            <a:ext cx="11064240" cy="274320"/>
+            <a:off x="548640" y="1024128"/>
+            <a:ext cx="11064240" cy="237744"/>
           </a:xfrm>
           <a:prstGeom prst="rect">
             <a:avLst/>
@@ -3495,13 +3495,13 @@
           <a:p>
             <a:pPr algn="l"/>
             <a:r>
-              <a:rPr sz="1200" b="0">
+              <a:rPr sz="1150" b="0">
                 <a:solidFill>
                   <a:srgbClr val="2F343C"/>
                 </a:solidFill>
                 <a:latin typeface="Calibri"/>
               </a:rPr>
-              <a:t>An approved requirements document becomes an audited source-to-target mapping — every fact checked against the source text, every ambiguity routed to a person.</a:t>
+              <a:t>Top to bottom: the technologies the agent runs on, and what flows between them — FRD in, audited STTM and contract out, a person in the loop.</a:t>
             </a:r>
           </a:p>
         </p:txBody>
@@ -3514,249 +3514,12 @@
         </p:nvSpPr>
         <p:spPr>
           <a:xfrm>
-            <a:off x="548640" y="1536192"/>
-            <a:ext cx="3589934" cy="274320"/>
+            <a:off x="548640" y="1371600"/>
+            <a:ext cx="11094415" cy="1024128"/>
           </a:xfrm>
           <a:prstGeom prst="roundRect">
             <a:avLst>
-              <a:gd name="adj" fmla="val 50000"/>
-            </a:avLst>
-          </a:prstGeom>
-          <a:noFill/>
-          <a:ln w="12700">
-            <a:solidFill>
-              <a:srgbClr val="7961DB"/>
-            </a:solidFill>
-          </a:ln>
-          <a:effectLst/>
-        </p:spPr>
-        <p:style>
-          <a:lnRef idx="1">
-            <a:schemeClr val="accent1"/>
-          </a:lnRef>
-          <a:fillRef idx="3">
-            <a:schemeClr val="accent1"/>
-          </a:fillRef>
-          <a:effectRef idx="2">
-            <a:schemeClr val="accent1"/>
-          </a:effectRef>
-          <a:fontRef idx="minor">
-            <a:schemeClr val="lt1"/>
-          </a:fontRef>
-        </p:style>
-        <p:txBody>
-          <a:bodyPr rtlCol="0" anchor="ctr"/>
-          <a:lstStyle/>
-          <a:p/>
-        </p:txBody>
-      </p:sp>
-      <p:sp>
-        <p:nvSpPr>
-          <p:cNvPr id="15" name="TextBox 14"/>
-          <p:cNvSpPr txBox="1"/>
-          <p:nvPr/>
-        </p:nvSpPr>
-        <p:spPr>
-          <a:xfrm>
-            <a:off x="548640" y="1600200"/>
-            <a:ext cx="3589934" cy="182880"/>
-          </a:xfrm>
-          <a:prstGeom prst="rect">
-            <a:avLst/>
-          </a:prstGeom>
-          <a:noFill/>
-        </p:spPr>
-        <p:txBody>
-          <a:bodyPr wrap="square" lIns="0" rIns="0" tIns="0" bIns="0" anchor="t">
-            <a:spAutoFit/>
-          </a:bodyPr>
-          <a:lstStyle/>
-          <a:p>
-            <a:pPr algn="ctr"/>
-            <a:r>
-              <a:rPr sz="850" b="1" spc="100">
-                <a:solidFill>
-                  <a:srgbClr val="5642A6"/>
-                </a:solidFill>
-                <a:latin typeface="Calibri"/>
-              </a:rPr>
-              <a:t>PULLS FROM SHAREPOINT · NEVER WRITES BACK</a:t>
-            </a:r>
-          </a:p>
-        </p:txBody>
-      </p:sp>
-      <p:sp>
-        <p:nvSpPr>
-          <p:cNvPr id="16" name="Rounded Rectangle 15"/>
-          <p:cNvSpPr/>
-          <p:nvPr/>
-        </p:nvSpPr>
-        <p:spPr>
-          <a:xfrm>
-            <a:off x="4248302" y="1536192"/>
-            <a:ext cx="2331720" cy="274320"/>
-          </a:xfrm>
-          <a:prstGeom prst="roundRect">
-            <a:avLst>
-              <a:gd name="adj" fmla="val 50000"/>
-            </a:avLst>
-          </a:prstGeom>
-          <a:noFill/>
-          <a:ln w="12700">
-            <a:solidFill>
-              <a:srgbClr val="D97757"/>
-            </a:solidFill>
-          </a:ln>
-          <a:effectLst/>
-        </p:spPr>
-        <p:style>
-          <a:lnRef idx="1">
-            <a:schemeClr val="accent1"/>
-          </a:lnRef>
-          <a:fillRef idx="3">
-            <a:schemeClr val="accent1"/>
-          </a:fillRef>
-          <a:effectRef idx="2">
-            <a:schemeClr val="accent1"/>
-          </a:effectRef>
-          <a:fontRef idx="minor">
-            <a:schemeClr val="lt1"/>
-          </a:fontRef>
-        </p:style>
-        <p:txBody>
-          <a:bodyPr rtlCol="0" anchor="ctr"/>
-          <a:lstStyle/>
-          <a:p/>
-        </p:txBody>
-      </p:sp>
-      <p:sp>
-        <p:nvSpPr>
-          <p:cNvPr id="17" name="TextBox 16"/>
-          <p:cNvSpPr txBox="1"/>
-          <p:nvPr/>
-        </p:nvSpPr>
-        <p:spPr>
-          <a:xfrm>
-            <a:off x="4248302" y="1600200"/>
-            <a:ext cx="2331720" cy="182880"/>
-          </a:xfrm>
-          <a:prstGeom prst="rect">
-            <a:avLst/>
-          </a:prstGeom>
-          <a:noFill/>
-        </p:spPr>
-        <p:txBody>
-          <a:bodyPr wrap="square" lIns="0" rIns="0" tIns="0" bIns="0" anchor="t">
-            <a:spAutoFit/>
-          </a:bodyPr>
-          <a:lstStyle/>
-          <a:p>
-            <a:pPr algn="ctr"/>
-            <a:r>
-              <a:rPr sz="850" b="1" spc="100">
-                <a:solidFill>
-                  <a:srgbClr val="A04D2C"/>
-                </a:solidFill>
-                <a:latin typeface="Calibri"/>
-              </a:rPr>
-              <a:t>1 MODEL CALL PER DOCUMENT</a:t>
-            </a:r>
-          </a:p>
-        </p:txBody>
-      </p:sp>
-      <p:sp>
-        <p:nvSpPr>
-          <p:cNvPr id="18" name="Rounded Rectangle 17"/>
-          <p:cNvSpPr/>
-          <p:nvPr/>
-        </p:nvSpPr>
-        <p:spPr>
-          <a:xfrm>
-            <a:off x="6689750" y="1536192"/>
-            <a:ext cx="2331720" cy="274320"/>
-          </a:xfrm>
-          <a:prstGeom prst="roundRect">
-            <a:avLst>
-              <a:gd name="adj" fmla="val 50000"/>
-            </a:avLst>
-          </a:prstGeom>
-          <a:noFill/>
-          <a:ln w="12700">
-            <a:solidFill>
-              <a:srgbClr val="00A396"/>
-            </a:solidFill>
-          </a:ln>
-          <a:effectLst/>
-        </p:spPr>
-        <p:style>
-          <a:lnRef idx="1">
-            <a:schemeClr val="accent1"/>
-          </a:lnRef>
-          <a:fillRef idx="3">
-            <a:schemeClr val="accent1"/>
-          </a:fillRef>
-          <a:effectRef idx="2">
-            <a:schemeClr val="accent1"/>
-          </a:effectRef>
-          <a:fontRef idx="minor">
-            <a:schemeClr val="lt1"/>
-          </a:fontRef>
-        </p:style>
-        <p:txBody>
-          <a:bodyPr rtlCol="0" anchor="ctr"/>
-          <a:lstStyle/>
-          <a:p/>
-        </p:txBody>
-      </p:sp>
-      <p:sp>
-        <p:nvSpPr>
-          <p:cNvPr id="19" name="TextBox 18"/>
-          <p:cNvSpPr txBox="1"/>
-          <p:nvPr/>
-        </p:nvSpPr>
-        <p:spPr>
-          <a:xfrm>
-            <a:off x="6689750" y="1600200"/>
-            <a:ext cx="2331720" cy="182880"/>
-          </a:xfrm>
-          <a:prstGeom prst="rect">
-            <a:avLst/>
-          </a:prstGeom>
-          <a:noFill/>
-        </p:spPr>
-        <p:txBody>
-          <a:bodyPr wrap="square" lIns="0" rIns="0" tIns="0" bIns="0" anchor="t">
-            <a:spAutoFit/>
-          </a:bodyPr>
-          <a:lstStyle/>
-          <a:p>
-            <a:pPr algn="ctr"/>
-            <a:r>
-              <a:rPr sz="850" b="1" spc="100">
-                <a:solidFill>
-                  <a:srgbClr val="007067"/>
-                </a:solidFill>
-                <a:latin typeface="Calibri"/>
-              </a:rPr>
-              <a:t>VERDICTS COMPUTED IN CODE</a:t>
-            </a:r>
-          </a:p>
-        </p:txBody>
-      </p:sp>
-      <p:sp>
-        <p:nvSpPr>
-          <p:cNvPr id="20" name="Rounded Rectangle 19"/>
-          <p:cNvSpPr/>
-          <p:nvPr/>
-        </p:nvSpPr>
-        <p:spPr>
-          <a:xfrm>
-            <a:off x="548640" y="2011680"/>
-            <a:ext cx="1874519" cy="2788920"/>
-          </a:xfrm>
-          <a:prstGeom prst="roundRect">
-            <a:avLst>
-              <a:gd name="adj" fmla="val 3500"/>
+              <a:gd name="adj" fmla="val 2500"/>
             </a:avLst>
           </a:prstGeom>
           <a:solidFill>
@@ -3791,58 +3554,14 @@
       </p:sp>
       <p:sp>
         <p:nvSpPr>
-          <p:cNvPr id="21" name="Oval 20"/>
-          <p:cNvSpPr/>
-          <p:nvPr/>
-        </p:nvSpPr>
-        <p:spPr>
-          <a:xfrm>
-            <a:off x="736092" y="2235708"/>
-            <a:ext cx="100584" cy="100584"/>
-          </a:xfrm>
-          <a:prstGeom prst="ellipse">
-            <a:avLst/>
-          </a:prstGeom>
-          <a:solidFill>
-            <a:srgbClr val="7961DB"/>
-          </a:solidFill>
-          <a:ln>
-            <a:noFill/>
-          </a:ln>
-          <a:effectLst/>
-        </p:spPr>
-        <p:style>
-          <a:lnRef idx="1">
-            <a:schemeClr val="accent1"/>
-          </a:lnRef>
-          <a:fillRef idx="3">
-            <a:schemeClr val="accent1"/>
-          </a:fillRef>
-          <a:effectRef idx="2">
-            <a:schemeClr val="accent1"/>
-          </a:effectRef>
-          <a:fontRef idx="minor">
-            <a:schemeClr val="lt1"/>
-          </a:fontRef>
-        </p:style>
-        <p:txBody>
-          <a:bodyPr rtlCol="0" anchor="ctr"/>
-          <a:lstStyle/>
-          <a:p>
-            <a:pPr algn="ctr"/>
-          </a:p>
-        </p:txBody>
-      </p:sp>
-      <p:sp>
-        <p:nvSpPr>
-          <p:cNvPr id="22" name="TextBox 21"/>
+          <p:cNvPr id="15" name="TextBox 14"/>
           <p:cNvSpPr txBox="1"/>
           <p:nvPr/>
         </p:nvSpPr>
         <p:spPr>
           <a:xfrm>
-            <a:off x="950976" y="2185416"/>
-            <a:ext cx="914400" cy="219456"/>
+            <a:off x="777240" y="1481328"/>
+            <a:ext cx="3657600" cy="201168"/>
           </a:xfrm>
           <a:prstGeom prst="rect">
             <a:avLst/>
@@ -3857,55 +3576,20 @@
           <a:p>
             <a:pPr algn="l"/>
             <a:r>
-              <a:rPr sz="900" b="1" spc="120">
+              <a:rPr sz="900" b="1" spc="140">
                 <a:solidFill>
                   <a:srgbClr val="5642A6"/>
-                </a:solidFill>
-                <a:latin typeface="Consolas"/>
-              </a:rPr>
-              <a:t>SRC</a:t>
-            </a:r>
-          </a:p>
-        </p:txBody>
-      </p:sp>
-      <p:sp>
-        <p:nvSpPr>
-          <p:cNvPr id="23" name="TextBox 22"/>
-          <p:cNvSpPr txBox="1"/>
-          <p:nvPr/>
-        </p:nvSpPr>
-        <p:spPr>
-          <a:xfrm>
-            <a:off x="768096" y="2432304"/>
-            <a:ext cx="1508760" cy="310896"/>
-          </a:xfrm>
-          <a:prstGeom prst="rect">
-            <a:avLst/>
-          </a:prstGeom>
-          <a:noFill/>
-        </p:spPr>
-        <p:txBody>
-          <a:bodyPr wrap="square" lIns="0" rIns="0" tIns="0" bIns="0" anchor="t">
-            <a:spAutoFit/>
-          </a:bodyPr>
-          <a:lstStyle/>
-          <a:p>
-            <a:pPr algn="l"/>
-            <a:r>
-              <a:rPr sz="1450" b="1">
-                <a:solidFill>
-                  <a:srgbClr val="1C2127"/>
                 </a:solidFill>
                 <a:latin typeface="Calibri"/>
               </a:rPr>
-              <a:t>SharePoint</a:t>
+              <a:t>SYSTEM OF RECORD</a:t>
             </a:r>
           </a:p>
         </p:txBody>
       </p:sp>
       <p:pic>
         <p:nvPicPr>
-          <p:cNvPr id="24" name="Picture 23" descr="folder.png"/>
+          <p:cNvPr id="16" name="Picture 15" descr="sharepoint.png"/>
           <p:cNvPicPr>
             <a:picLocks noChangeAspect="1"/>
           </p:cNvPicPr>
@@ -3919,8 +3603,8 @@
         </p:blipFill>
         <p:spPr>
           <a:xfrm>
-            <a:off x="1947672" y="2157984"/>
-            <a:ext cx="274320" cy="274320"/>
+            <a:off x="777240" y="1743789"/>
+            <a:ext cx="548640" cy="535781"/>
           </a:xfrm>
           <a:prstGeom prst="rect">
             <a:avLst/>
@@ -3929,14 +3613,14 @@
       </p:pic>
       <p:sp>
         <p:nvSpPr>
-          <p:cNvPr id="25" name="TextBox 24"/>
+          <p:cNvPr id="17" name="TextBox 16"/>
           <p:cNvSpPr txBox="1"/>
           <p:nvPr/>
         </p:nvSpPr>
         <p:spPr>
           <a:xfrm>
-            <a:off x="768096" y="2816352"/>
-            <a:ext cx="1453895" cy="1097280"/>
+            <a:off x="1463040" y="1719072"/>
+            <a:ext cx="3108960" cy="274320"/>
           </a:xfrm>
           <a:prstGeom prst="rect">
             <a:avLst/>
@@ -3949,37 +3633,68 @@
           </a:bodyPr>
           <a:lstStyle/>
           <a:p>
-            <a:pPr algn="l">
-              <a:lnSpc>
-                <a:spcPct val="112000"/>
-              </a:lnSpc>
-            </a:pPr>
-            <a:r>
-              <a:rPr sz="1100" b="0">
-                <a:solidFill>
-                  <a:srgbClr val="2F343C"/>
+            <a:pPr algn="l"/>
+            <a:r>
+              <a:rPr sz="1400" b="1">
+                <a:solidFill>
+                  <a:srgbClr val="1C2127"/>
                 </a:solidFill>
                 <a:latin typeface="Calibri"/>
               </a:rPr>
-              <a:t>System of record. The sync pulls FRDs and STTMs into Databricks and never writes back.</a:t>
-            </a:r>
-          </a:p>
-        </p:txBody>
-      </p:sp>
-      <p:sp>
-        <p:nvSpPr>
-          <p:cNvPr id="26" name="Rounded Rectangle 25"/>
+              <a:t>Microsoft SharePoint</a:t>
+            </a:r>
+          </a:p>
+        </p:txBody>
+      </p:sp>
+      <p:sp>
+        <p:nvSpPr>
+          <p:cNvPr id="18" name="TextBox 17"/>
+          <p:cNvSpPr txBox="1"/>
+          <p:nvPr/>
+        </p:nvSpPr>
+        <p:spPr>
+          <a:xfrm>
+            <a:off x="1463040" y="2011680"/>
+            <a:ext cx="3200400" cy="365760"/>
+          </a:xfrm>
+          <a:prstGeom prst="rect">
+            <a:avLst/>
+          </a:prstGeom>
+          <a:noFill/>
+        </p:spPr>
+        <p:txBody>
+          <a:bodyPr wrap="square" lIns="0" rIns="0" tIns="0" bIns="0" anchor="t">
+            <a:spAutoFit/>
+          </a:bodyPr>
+          <a:lstStyle/>
+          <a:p>
+            <a:pPr algn="l"/>
+            <a:r>
+              <a:rPr sz="1000" b="0">
+                <a:solidFill>
+                  <a:srgbClr val="2F343C"/>
+                </a:solidFill>
+                <a:latin typeface="Calibri"/>
+              </a:rPr>
+              <a:t>The client's document library — the only place anything is authored or approved.</a:t>
+            </a:r>
+          </a:p>
+        </p:txBody>
+      </p:sp>
+      <p:sp>
+        <p:nvSpPr>
+          <p:cNvPr id="19" name="Rounded Rectangle 18"/>
           <p:cNvSpPr/>
           <p:nvPr/>
         </p:nvSpPr>
         <p:spPr>
           <a:xfrm>
-            <a:off x="694944" y="3849624"/>
-            <a:ext cx="1581911" cy="804672"/>
+            <a:off x="4983479" y="1673352"/>
+            <a:ext cx="2331720" cy="566928"/>
           </a:xfrm>
           <a:prstGeom prst="roundRect">
             <a:avLst>
-              <a:gd name="adj" fmla="val 3000"/>
+              <a:gd name="adj" fmla="val 8000"/>
             </a:avLst>
           </a:prstGeom>
           <a:solidFill>
@@ -4014,7 +3729,7 @@
       </p:sp>
       <p:pic>
         <p:nvPicPr>
-          <p:cNvPr id="27" name="Picture 26" descr="frd_page.png"/>
+          <p:cNvPr id="20" name="Picture 19" descr="word.png"/>
           <p:cNvPicPr>
             <a:picLocks noChangeAspect="1"/>
           </p:cNvPicPr>
@@ -4028,8 +3743,8 @@
         </p:blipFill>
         <p:spPr>
           <a:xfrm>
-            <a:off x="739140" y="3867912"/>
-            <a:ext cx="1493519" cy="768095"/>
+            <a:off x="5093207" y="1795295"/>
+            <a:ext cx="347472" cy="323040"/>
           </a:xfrm>
           <a:prstGeom prst="rect">
             <a:avLst/>
@@ -4038,18 +3753,394 @@
       </p:pic>
       <p:sp>
         <p:nvSpPr>
-          <p:cNvPr id="28" name="Rounded Rectangle 27"/>
+          <p:cNvPr id="21" name="TextBox 20"/>
+          <p:cNvSpPr txBox="1"/>
+          <p:nvPr/>
+        </p:nvSpPr>
+        <p:spPr>
+          <a:xfrm>
+            <a:off x="5532119" y="1746504"/>
+            <a:ext cx="1691639" cy="219456"/>
+          </a:xfrm>
+          <a:prstGeom prst="rect">
+            <a:avLst/>
+          </a:prstGeom>
+          <a:noFill/>
+        </p:spPr>
+        <p:txBody>
+          <a:bodyPr wrap="square" lIns="0" rIns="0" tIns="0" bIns="0" anchor="t">
+            <a:spAutoFit/>
+          </a:bodyPr>
+          <a:lstStyle/>
+          <a:p>
+            <a:pPr algn="l"/>
+            <a:r>
+              <a:rPr sz="1050" b="1">
+                <a:solidFill>
+                  <a:srgbClr val="1C2127"/>
+                </a:solidFill>
+                <a:latin typeface="Calibri"/>
+              </a:rPr>
+              <a:t>FRD  ·  .docx</a:t>
+            </a:r>
+          </a:p>
+        </p:txBody>
+      </p:sp>
+      <p:sp>
+        <p:nvSpPr>
+          <p:cNvPr id="22" name="TextBox 21"/>
+          <p:cNvSpPr txBox="1"/>
+          <p:nvPr/>
+        </p:nvSpPr>
+        <p:spPr>
+          <a:xfrm>
+            <a:off x="5532119" y="1965960"/>
+            <a:ext cx="1691639" cy="237744"/>
+          </a:xfrm>
+          <a:prstGeom prst="rect">
+            <a:avLst/>
+          </a:prstGeom>
+          <a:noFill/>
+        </p:spPr>
+        <p:txBody>
+          <a:bodyPr wrap="square" lIns="0" rIns="0" tIns="0" bIns="0" anchor="t">
+            <a:spAutoFit/>
+          </a:bodyPr>
+          <a:lstStyle/>
+          <a:p>
+            <a:pPr algn="l"/>
+            <a:r>
+              <a:rPr sz="850" b="0">
+                <a:solidFill>
+                  <a:srgbClr val="2F343C"/>
+                </a:solidFill>
+                <a:latin typeface="Calibri"/>
+              </a:rPr>
+              <a:t>input — approved requirements</a:t>
+            </a:r>
+          </a:p>
+        </p:txBody>
+      </p:sp>
+      <p:sp>
+        <p:nvSpPr>
+          <p:cNvPr id="23" name="Rounded Rectangle 22"/>
           <p:cNvSpPr/>
           <p:nvPr/>
         </p:nvSpPr>
         <p:spPr>
           <a:xfrm>
-            <a:off x="2697480" y="2011680"/>
-            <a:ext cx="1783080" cy="2788920"/>
+            <a:off x="7498079" y="1673352"/>
+            <a:ext cx="2331720" cy="566928"/>
           </a:xfrm>
           <a:prstGeom prst="roundRect">
             <a:avLst>
-              <a:gd name="adj" fmla="val 3500"/>
+              <a:gd name="adj" fmla="val 8000"/>
+            </a:avLst>
+          </a:prstGeom>
+          <a:solidFill>
+            <a:srgbClr val="EDEFF2"/>
+          </a:solidFill>
+          <a:ln w="9525">
+            <a:solidFill>
+              <a:srgbClr val="C5CBD3"/>
+            </a:solidFill>
+          </a:ln>
+          <a:effectLst/>
+        </p:spPr>
+        <p:style>
+          <a:lnRef idx="1">
+            <a:schemeClr val="accent1"/>
+          </a:lnRef>
+          <a:fillRef idx="3">
+            <a:schemeClr val="accent1"/>
+          </a:fillRef>
+          <a:effectRef idx="2">
+            <a:schemeClr val="accent1"/>
+          </a:effectRef>
+          <a:fontRef idx="minor">
+            <a:schemeClr val="lt1"/>
+          </a:fontRef>
+        </p:style>
+        <p:txBody>
+          <a:bodyPr rtlCol="0" anchor="ctr"/>
+          <a:lstStyle/>
+          <a:p/>
+        </p:txBody>
+      </p:sp>
+      <p:pic>
+        <p:nvPicPr>
+          <p:cNvPr id="24" name="Picture 23" descr="excel.png"/>
+          <p:cNvPicPr>
+            <a:picLocks noChangeAspect="1"/>
+          </p:cNvPicPr>
+          <p:nvPr/>
+        </p:nvPicPr>
+        <p:blipFill>
+          <a:blip r:embed="rId5"/>
+          <a:stretch>
+            <a:fillRect/>
+          </a:stretch>
+        </p:blipFill>
+        <p:spPr>
+          <a:xfrm>
+            <a:off x="7607807" y="1795295"/>
+            <a:ext cx="347472" cy="323040"/>
+          </a:xfrm>
+          <a:prstGeom prst="rect">
+            <a:avLst/>
+          </a:prstGeom>
+        </p:spPr>
+      </p:pic>
+      <p:sp>
+        <p:nvSpPr>
+          <p:cNvPr id="25" name="TextBox 24"/>
+          <p:cNvSpPr txBox="1"/>
+          <p:nvPr/>
+        </p:nvSpPr>
+        <p:spPr>
+          <a:xfrm>
+            <a:off x="8046719" y="1746504"/>
+            <a:ext cx="1691639" cy="219456"/>
+          </a:xfrm>
+          <a:prstGeom prst="rect">
+            <a:avLst/>
+          </a:prstGeom>
+          <a:noFill/>
+        </p:spPr>
+        <p:txBody>
+          <a:bodyPr wrap="square" lIns="0" rIns="0" tIns="0" bIns="0" anchor="t">
+            <a:spAutoFit/>
+          </a:bodyPr>
+          <a:lstStyle/>
+          <a:p>
+            <a:pPr algn="l"/>
+            <a:r>
+              <a:rPr sz="1050" b="1">
+                <a:solidFill>
+                  <a:srgbClr val="1C2127"/>
+                </a:solidFill>
+                <a:latin typeface="Calibri"/>
+              </a:rPr>
+              <a:t>Approved STTM  ·  .xlsx</a:t>
+            </a:r>
+          </a:p>
+        </p:txBody>
+      </p:sp>
+      <p:sp>
+        <p:nvSpPr>
+          <p:cNvPr id="26" name="TextBox 25"/>
+          <p:cNvSpPr txBox="1"/>
+          <p:nvPr/>
+        </p:nvSpPr>
+        <p:spPr>
+          <a:xfrm>
+            <a:off x="8046719" y="1965960"/>
+            <a:ext cx="1691639" cy="237744"/>
+          </a:xfrm>
+          <a:prstGeom prst="rect">
+            <a:avLst/>
+          </a:prstGeom>
+          <a:noFill/>
+        </p:spPr>
+        <p:txBody>
+          <a:bodyPr wrap="square" lIns="0" rIns="0" tIns="0" bIns="0" anchor="t">
+            <a:spAutoFit/>
+          </a:bodyPr>
+          <a:lstStyle/>
+          <a:p>
+            <a:pPr algn="l"/>
+            <a:r>
+              <a:rPr sz="850" b="0">
+                <a:solidFill>
+                  <a:srgbClr val="2F343C"/>
+                </a:solidFill>
+                <a:latin typeface="Calibri"/>
+              </a:rPr>
+              <a:t>input — becomes a template</a:t>
+            </a:r>
+          </a:p>
+        </p:txBody>
+      </p:sp>
+      <p:pic>
+        <p:nvPicPr>
+          <p:cNvPr id="27" name="Picture 26" descr="entra.png"/>
+          <p:cNvPicPr>
+            <a:picLocks noChangeAspect="1"/>
+          </p:cNvPicPr>
+          <p:nvPr/>
+        </p:nvPicPr>
+        <p:blipFill>
+          <a:blip r:embed="rId6"/>
+          <a:stretch>
+            <a:fillRect/>
+          </a:stretch>
+        </p:blipFill>
+        <p:spPr>
+          <a:xfrm>
+            <a:off x="10104119" y="1762363"/>
+            <a:ext cx="457200" cy="407193"/>
+          </a:xfrm>
+          <a:prstGeom prst="rect">
+            <a:avLst/>
+          </a:prstGeom>
+        </p:spPr>
+      </p:pic>
+      <p:sp>
+        <p:nvSpPr>
+          <p:cNvPr id="28" name="TextBox 27"/>
+          <p:cNvSpPr txBox="1"/>
+          <p:nvPr/>
+        </p:nvSpPr>
+        <p:spPr>
+          <a:xfrm>
+            <a:off x="10652760" y="1691640"/>
+            <a:ext cx="1005840" cy="548640"/>
+          </a:xfrm>
+          <a:prstGeom prst="rect">
+            <a:avLst/>
+          </a:prstGeom>
+          <a:noFill/>
+        </p:spPr>
+        <p:txBody>
+          <a:bodyPr wrap="square" lIns="0" rIns="0" tIns="0" bIns="0" anchor="t">
+            <a:spAutoFit/>
+          </a:bodyPr>
+          <a:lstStyle/>
+          <a:p>
+            <a:pPr algn="l">
+              <a:lnSpc>
+                <a:spcPct val="100000"/>
+              </a:lnSpc>
+            </a:pPr>
+            <a:r>
+              <a:rPr sz="850" b="1">
+                <a:solidFill>
+                  <a:srgbClr val="1C2127"/>
+                </a:solidFill>
+                <a:latin typeface="Calibri"/>
+              </a:rPr>
+              <a:t>Entra ID app</a:t>
+            </a:r>
+          </a:p>
+          <a:p>
+            <a:pPr algn="l">
+              <a:lnSpc>
+                <a:spcPct val="100000"/>
+              </a:lnSpc>
+            </a:pPr>
+            <a:r>
+              <a:rPr sz="850" b="0">
+                <a:solidFill>
+                  <a:srgbClr val="2F343C"/>
+                </a:solidFill>
+                <a:latin typeface="Calibri"/>
+              </a:rPr>
+              <a:t>Microsoft Graph</a:t>
+            </a:r>
+          </a:p>
+          <a:p>
+            <a:pPr algn="l">
+              <a:lnSpc>
+                <a:spcPct val="100000"/>
+              </a:lnSpc>
+            </a:pPr>
+            <a:r>
+              <a:rPr sz="850" b="0">
+                <a:solidFill>
+                  <a:srgbClr val="2F343C"/>
+                </a:solidFill>
+                <a:latin typeface="Calibri"/>
+              </a:rPr>
+              <a:t>Sites.Selected · read</a:t>
+            </a:r>
+          </a:p>
+        </p:txBody>
+      </p:sp>
+      <p:cxnSp>
+        <p:nvCxnSpPr>
+          <p:cNvPr id="29" name="Connector 28"/>
+          <p:cNvCxnSpPr/>
+          <p:nvPr/>
+        </p:nvCxnSpPr>
+        <p:spPr>
+          <a:xfrm>
+            <a:off x="4389120" y="2395728"/>
+            <a:ext cx="0" cy="393192"/>
+          </a:xfrm>
+          <a:prstGeom prst="line">
+            <a:avLst/>
+          </a:prstGeom>
+          <a:ln w="19050">
+            <a:solidFill>
+              <a:srgbClr val="2F343C"/>
+            </a:solidFill>
+            <a:tailEnd type="triangle" w="sm" len="sm"/>
+          </a:ln>
+        </p:spPr>
+        <p:style>
+          <a:lnRef idx="2">
+            <a:schemeClr val="accent1"/>
+          </a:lnRef>
+          <a:fillRef idx="0">
+            <a:schemeClr val="accent1"/>
+          </a:fillRef>
+          <a:effectRef idx="1">
+            <a:schemeClr val="accent1"/>
+          </a:effectRef>
+          <a:fontRef idx="minor">
+            <a:schemeClr val="tx1"/>
+          </a:fontRef>
+        </p:style>
+      </p:cxnSp>
+      <p:sp>
+        <p:nvSpPr>
+          <p:cNvPr id="30" name="TextBox 29"/>
+          <p:cNvSpPr txBox="1"/>
+          <p:nvPr/>
+        </p:nvSpPr>
+        <p:spPr>
+          <a:xfrm>
+            <a:off x="4517136" y="2491740"/>
+            <a:ext cx="5486400" cy="201168"/>
+          </a:xfrm>
+          <a:prstGeom prst="rect">
+            <a:avLst/>
+          </a:prstGeom>
+          <a:noFill/>
+        </p:spPr>
+        <p:txBody>
+          <a:bodyPr wrap="square" lIns="0" rIns="0" tIns="0" bIns="0" anchor="t">
+            <a:spAutoFit/>
+          </a:bodyPr>
+          <a:lstStyle/>
+          <a:p>
+            <a:pPr algn="l"/>
+            <a:r>
+              <a:rPr sz="950" b="1">
+                <a:solidFill>
+                  <a:srgbClr val="2F343C"/>
+                </a:solidFill>
+                <a:latin typeface="Calibri"/>
+              </a:rPr>
+              <a:t>00  scheduled sync — every 15 min, incremental · pulls FRDs and STTMs down · never writes back</a:t>
+            </a:r>
+          </a:p>
+        </p:txBody>
+      </p:sp>
+      <p:sp>
+        <p:nvSpPr>
+          <p:cNvPr id="31" name="Rounded Rectangle 30"/>
+          <p:cNvSpPr/>
+          <p:nvPr/>
+        </p:nvSpPr>
+        <p:spPr>
+          <a:xfrm>
+            <a:off x="548640" y="2788920"/>
+            <a:ext cx="11094415" cy="2395728"/>
+          </a:xfrm>
+          <a:prstGeom prst="roundRect">
+            <a:avLst>
+              <a:gd name="adj" fmla="val 2500"/>
             </a:avLst>
           </a:prstGeom>
           <a:solidFill>
@@ -4084,58 +4175,14 @@
       </p:sp>
       <p:sp>
         <p:nvSpPr>
-          <p:cNvPr id="29" name="Oval 28"/>
-          <p:cNvSpPr/>
-          <p:nvPr/>
-        </p:nvSpPr>
-        <p:spPr>
-          <a:xfrm>
-            <a:off x="2884932" y="2235708"/>
-            <a:ext cx="100584" cy="100584"/>
-          </a:xfrm>
-          <a:prstGeom prst="ellipse">
-            <a:avLst/>
-          </a:prstGeom>
-          <a:solidFill>
-            <a:srgbClr val="00A396"/>
-          </a:solidFill>
-          <a:ln>
-            <a:noFill/>
-          </a:ln>
-          <a:effectLst/>
-        </p:spPr>
-        <p:style>
-          <a:lnRef idx="1">
-            <a:schemeClr val="accent1"/>
-          </a:lnRef>
-          <a:fillRef idx="3">
-            <a:schemeClr val="accent1"/>
-          </a:fillRef>
-          <a:effectRef idx="2">
-            <a:schemeClr val="accent1"/>
-          </a:effectRef>
-          <a:fontRef idx="minor">
-            <a:schemeClr val="lt1"/>
-          </a:fontRef>
-        </p:style>
-        <p:txBody>
-          <a:bodyPr rtlCol="0" anchor="ctr"/>
-          <a:lstStyle/>
-          <a:p>
-            <a:pPr algn="ctr"/>
-          </a:p>
-        </p:txBody>
-      </p:sp>
-      <p:sp>
-        <p:nvSpPr>
-          <p:cNvPr id="30" name="TextBox 29"/>
+          <p:cNvPr id="32" name="TextBox 31"/>
           <p:cNvSpPr txBox="1"/>
           <p:nvPr/>
         </p:nvSpPr>
         <p:spPr>
           <a:xfrm>
-            <a:off x="3099816" y="2185416"/>
-            <a:ext cx="914400" cy="219456"/>
+            <a:off x="777240" y="2898648"/>
+            <a:ext cx="3657600" cy="201168"/>
           </a:xfrm>
           <a:prstGeom prst="rect">
             <a:avLst/>
@@ -4150,700 +4197,20 @@
           <a:p>
             <a:pPr algn="l"/>
             <a:r>
-              <a:rPr sz="900" b="1" spc="120">
+              <a:rPr sz="900" b="1" spc="140">
                 <a:solidFill>
                   <a:srgbClr val="007067"/>
-                </a:solidFill>
-                <a:latin typeface="Consolas"/>
-              </a:rPr>
-              <a:t>00</a:t>
-            </a:r>
-          </a:p>
-        </p:txBody>
-      </p:sp>
-      <p:sp>
-        <p:nvSpPr>
-          <p:cNvPr id="31" name="TextBox 30"/>
-          <p:cNvSpPr txBox="1"/>
-          <p:nvPr/>
-        </p:nvSpPr>
-        <p:spPr>
-          <a:xfrm>
-            <a:off x="2916936" y="2432304"/>
-            <a:ext cx="1417319" cy="310896"/>
-          </a:xfrm>
-          <a:prstGeom prst="rect">
-            <a:avLst/>
-          </a:prstGeom>
-          <a:noFill/>
-        </p:spPr>
-        <p:txBody>
-          <a:bodyPr wrap="square" lIns="0" rIns="0" tIns="0" bIns="0" anchor="t">
-            <a:spAutoFit/>
-          </a:bodyPr>
-          <a:lstStyle/>
-          <a:p>
-            <a:pPr algn="l"/>
-            <a:r>
-              <a:rPr sz="1450" b="1">
-                <a:solidFill>
-                  <a:srgbClr val="1C2127"/>
                 </a:solidFill>
                 <a:latin typeface="Calibri"/>
               </a:rPr>
-              <a:t>Scheduled sync</a:t>
+              <a:t>DATA PLATFORM</a:t>
             </a:r>
           </a:p>
         </p:txBody>
       </p:sp>
       <p:pic>
         <p:nvPicPr>
-          <p:cNvPr id="32" name="Picture 31" descr="refresh.png"/>
-          <p:cNvPicPr>
-            <a:picLocks noChangeAspect="1"/>
-          </p:cNvPicPr>
-          <p:nvPr/>
-        </p:nvPicPr>
-        <p:blipFill>
-          <a:blip r:embed="rId5"/>
-          <a:stretch>
-            <a:fillRect/>
-          </a:stretch>
-        </p:blipFill>
-        <p:spPr>
-          <a:xfrm>
-            <a:off x="4005072" y="2157984"/>
-            <a:ext cx="274320" cy="274320"/>
-          </a:xfrm>
-          <a:prstGeom prst="rect">
-            <a:avLst/>
-          </a:prstGeom>
-        </p:spPr>
-      </p:pic>
-      <p:sp>
-        <p:nvSpPr>
-          <p:cNvPr id="33" name="TextBox 32"/>
-          <p:cNvSpPr txBox="1"/>
-          <p:nvPr/>
-        </p:nvSpPr>
-        <p:spPr>
-          <a:xfrm>
-            <a:off x="2916936" y="2816352"/>
-            <a:ext cx="1362456" cy="1097280"/>
-          </a:xfrm>
-          <a:prstGeom prst="rect">
-            <a:avLst/>
-          </a:prstGeom>
-          <a:noFill/>
-        </p:spPr>
-        <p:txBody>
-          <a:bodyPr wrap="square" lIns="0" rIns="0" tIns="0" bIns="0" anchor="t">
-            <a:spAutoFit/>
-          </a:bodyPr>
-          <a:lstStyle/>
-          <a:p>
-            <a:pPr algn="l">
-              <a:lnSpc>
-                <a:spcPct val="112000"/>
-              </a:lnSpc>
-            </a:pPr>
-            <a:r>
-              <a:rPr sz="1100" b="0">
-                <a:solidFill>
-                  <a:srgbClr val="2F343C"/>
-                </a:solidFill>
-                <a:latin typeface="Calibri"/>
-              </a:rPr>
-              <a:t>Every 15 minutes, incremental. Pairs each FRD with its STTM and indexes the corpus in Unity Catalog. Zero model calls.</a:t>
-            </a:r>
-          </a:p>
-        </p:txBody>
-      </p:sp>
-      <p:sp>
-        <p:nvSpPr>
-          <p:cNvPr id="34" name="Rounded Rectangle 33"/>
-          <p:cNvSpPr/>
-          <p:nvPr/>
-        </p:nvSpPr>
-        <p:spPr>
-          <a:xfrm>
-            <a:off x="4754880" y="2011680"/>
-            <a:ext cx="2560320" cy="2788920"/>
-          </a:xfrm>
-          <a:prstGeom prst="roundRect">
-            <a:avLst>
-              <a:gd name="adj" fmla="val 3500"/>
-            </a:avLst>
-          </a:prstGeom>
-          <a:solidFill>
-            <a:srgbClr val="F6F7F9"/>
-          </a:solidFill>
-          <a:ln w="9525">
-            <a:solidFill>
-              <a:srgbClr val="D3D8DE"/>
-            </a:solidFill>
-          </a:ln>
-          <a:effectLst/>
-        </p:spPr>
-        <p:style>
-          <a:lnRef idx="1">
-            <a:schemeClr val="accent1"/>
-          </a:lnRef>
-          <a:fillRef idx="3">
-            <a:schemeClr val="accent1"/>
-          </a:fillRef>
-          <a:effectRef idx="2">
-            <a:schemeClr val="accent1"/>
-          </a:effectRef>
-          <a:fontRef idx="minor">
-            <a:schemeClr val="lt1"/>
-          </a:fontRef>
-        </p:style>
-        <p:txBody>
-          <a:bodyPr rtlCol="0" anchor="ctr"/>
-          <a:lstStyle/>
-          <a:p/>
-        </p:txBody>
-      </p:sp>
-      <p:sp>
-        <p:nvSpPr>
-          <p:cNvPr id="35" name="Oval 34"/>
-          <p:cNvSpPr/>
-          <p:nvPr/>
-        </p:nvSpPr>
-        <p:spPr>
-          <a:xfrm>
-            <a:off x="4942332" y="2235708"/>
-            <a:ext cx="100584" cy="100584"/>
-          </a:xfrm>
-          <a:prstGeom prst="ellipse">
-            <a:avLst/>
-          </a:prstGeom>
-          <a:solidFill>
-            <a:srgbClr val="00A396"/>
-          </a:solidFill>
-          <a:ln>
-            <a:noFill/>
-          </a:ln>
-          <a:effectLst/>
-        </p:spPr>
-        <p:style>
-          <a:lnRef idx="1">
-            <a:schemeClr val="accent1"/>
-          </a:lnRef>
-          <a:fillRef idx="3">
-            <a:schemeClr val="accent1"/>
-          </a:fillRef>
-          <a:effectRef idx="2">
-            <a:schemeClr val="accent1"/>
-          </a:effectRef>
-          <a:fontRef idx="minor">
-            <a:schemeClr val="lt1"/>
-          </a:fontRef>
-        </p:style>
-        <p:txBody>
-          <a:bodyPr rtlCol="0" anchor="ctr"/>
-          <a:lstStyle/>
-          <a:p>
-            <a:pPr algn="ctr"/>
-          </a:p>
-        </p:txBody>
-      </p:sp>
-      <p:sp>
-        <p:nvSpPr>
-          <p:cNvPr id="36" name="TextBox 35"/>
-          <p:cNvSpPr txBox="1"/>
-          <p:nvPr/>
-        </p:nvSpPr>
-        <p:spPr>
-          <a:xfrm>
-            <a:off x="5157216" y="2185416"/>
-            <a:ext cx="914400" cy="219456"/>
-          </a:xfrm>
-          <a:prstGeom prst="rect">
-            <a:avLst/>
-          </a:prstGeom>
-          <a:noFill/>
-        </p:spPr>
-        <p:txBody>
-          <a:bodyPr wrap="square" lIns="0" rIns="0" tIns="0" bIns="0" anchor="t">
-            <a:spAutoFit/>
-          </a:bodyPr>
-          <a:lstStyle/>
-          <a:p>
-            <a:pPr algn="l"/>
-            <a:r>
-              <a:rPr sz="900" b="1" spc="120">
-                <a:solidFill>
-                  <a:srgbClr val="007067"/>
-                </a:solidFill>
-                <a:latin typeface="Consolas"/>
-              </a:rPr>
-              <a:t>01–04</a:t>
-            </a:r>
-          </a:p>
-        </p:txBody>
-      </p:sp>
-      <p:sp>
-        <p:nvSpPr>
-          <p:cNvPr id="37" name="TextBox 36"/>
-          <p:cNvSpPr txBox="1"/>
-          <p:nvPr/>
-        </p:nvSpPr>
-        <p:spPr>
-          <a:xfrm>
-            <a:off x="4974336" y="2432304"/>
-            <a:ext cx="2194560" cy="310896"/>
-          </a:xfrm>
-          <a:prstGeom prst="rect">
-            <a:avLst/>
-          </a:prstGeom>
-          <a:noFill/>
-        </p:spPr>
-        <p:txBody>
-          <a:bodyPr wrap="square" lIns="0" rIns="0" tIns="0" bIns="0" anchor="t">
-            <a:spAutoFit/>
-          </a:bodyPr>
-          <a:lstStyle/>
-          <a:p>
-            <a:pPr algn="l"/>
-            <a:r>
-              <a:rPr sz="1450" b="1">
-                <a:solidFill>
-                  <a:srgbClr val="1C2127"/>
-                </a:solidFill>
-                <a:latin typeface="Calibri"/>
-              </a:rPr>
-              <a:t>Generation job</a:t>
-            </a:r>
-          </a:p>
-        </p:txBody>
-      </p:sp>
-      <p:sp>
-        <p:nvSpPr>
-          <p:cNvPr id="38" name="TextBox 37"/>
-          <p:cNvSpPr txBox="1"/>
-          <p:nvPr/>
-        </p:nvSpPr>
-        <p:spPr>
-          <a:xfrm>
-            <a:off x="4974336" y="2816352"/>
-            <a:ext cx="2139696" cy="1097280"/>
-          </a:xfrm>
-          <a:prstGeom prst="rect">
-            <a:avLst/>
-          </a:prstGeom>
-          <a:noFill/>
-        </p:spPr>
-        <p:txBody>
-          <a:bodyPr wrap="square" lIns="0" rIns="0" tIns="0" bIns="0" anchor="t">
-            <a:spAutoFit/>
-          </a:bodyPr>
-          <a:lstStyle/>
-          <a:p>
-            <a:pPr algn="l">
-              <a:lnSpc>
-                <a:spcPct val="112000"/>
-              </a:lnSpc>
-            </a:pPr>
-            <a:r>
-              <a:rPr sz="1100" b="0">
-                <a:solidFill>
-                  <a:srgbClr val="2F343C"/>
-                </a:solidFill>
-                <a:latin typeface="Calibri"/>
-              </a:rPr>
-              <a:t>Four stages on Databricks. Extract is the single Claude call; parsing, grounding audit, gate and render are code.</a:t>
-            </a:r>
-          </a:p>
-        </p:txBody>
-      </p:sp>
-      <p:sp>
-        <p:nvSpPr>
-          <p:cNvPr id="39" name="Rounded Rectangle 38"/>
-          <p:cNvSpPr/>
-          <p:nvPr/>
-        </p:nvSpPr>
-        <p:spPr>
-          <a:xfrm>
-            <a:off x="7589520" y="2011680"/>
-            <a:ext cx="1691640" cy="2788920"/>
-          </a:xfrm>
-          <a:prstGeom prst="roundRect">
-            <a:avLst>
-              <a:gd name="adj" fmla="val 3500"/>
-            </a:avLst>
-          </a:prstGeom>
-          <a:solidFill>
-            <a:srgbClr val="F6F7F9"/>
-          </a:solidFill>
-          <a:ln w="9525">
-            <a:solidFill>
-              <a:srgbClr val="D3D8DE"/>
-            </a:solidFill>
-          </a:ln>
-          <a:effectLst/>
-        </p:spPr>
-        <p:style>
-          <a:lnRef idx="1">
-            <a:schemeClr val="accent1"/>
-          </a:lnRef>
-          <a:fillRef idx="3">
-            <a:schemeClr val="accent1"/>
-          </a:fillRef>
-          <a:effectRef idx="2">
-            <a:schemeClr val="accent1"/>
-          </a:effectRef>
-          <a:fontRef idx="minor">
-            <a:schemeClr val="lt1"/>
-          </a:fontRef>
-        </p:style>
-        <p:txBody>
-          <a:bodyPr rtlCol="0" anchor="ctr"/>
-          <a:lstStyle/>
-          <a:p/>
-        </p:txBody>
-      </p:sp>
-      <p:sp>
-        <p:nvSpPr>
-          <p:cNvPr id="40" name="Oval 39"/>
-          <p:cNvSpPr/>
-          <p:nvPr/>
-        </p:nvSpPr>
-        <p:spPr>
-          <a:xfrm>
-            <a:off x="7776972" y="2235708"/>
-            <a:ext cx="100584" cy="100584"/>
-          </a:xfrm>
-          <a:prstGeom prst="ellipse">
-            <a:avLst/>
-          </a:prstGeom>
-          <a:solidFill>
-            <a:srgbClr val="D1980B"/>
-          </a:solidFill>
-          <a:ln>
-            <a:noFill/>
-          </a:ln>
-          <a:effectLst/>
-        </p:spPr>
-        <p:style>
-          <a:lnRef idx="1">
-            <a:schemeClr val="accent1"/>
-          </a:lnRef>
-          <a:fillRef idx="3">
-            <a:schemeClr val="accent1"/>
-          </a:fillRef>
-          <a:effectRef idx="2">
-            <a:schemeClr val="accent1"/>
-          </a:effectRef>
-          <a:fontRef idx="minor">
-            <a:schemeClr val="lt1"/>
-          </a:fontRef>
-        </p:style>
-        <p:txBody>
-          <a:bodyPr rtlCol="0" anchor="ctr"/>
-          <a:lstStyle/>
-          <a:p>
-            <a:pPr algn="ctr"/>
-          </a:p>
-        </p:txBody>
-      </p:sp>
-      <p:sp>
-        <p:nvSpPr>
-          <p:cNvPr id="41" name="TextBox 40"/>
-          <p:cNvSpPr txBox="1"/>
-          <p:nvPr/>
-        </p:nvSpPr>
-        <p:spPr>
-          <a:xfrm>
-            <a:off x="7991856" y="2185416"/>
-            <a:ext cx="914400" cy="219456"/>
-          </a:xfrm>
-          <a:prstGeom prst="rect">
-            <a:avLst/>
-          </a:prstGeom>
-          <a:noFill/>
-        </p:spPr>
-        <p:txBody>
-          <a:bodyPr wrap="square" lIns="0" rIns="0" tIns="0" bIns="0" anchor="t">
-            <a:spAutoFit/>
-          </a:bodyPr>
-          <a:lstStyle/>
-          <a:p>
-            <a:pPr algn="l"/>
-            <a:r>
-              <a:rPr sz="900" b="1" spc="120">
-                <a:solidFill>
-                  <a:srgbClr val="866103"/>
-                </a:solidFill>
-                <a:latin typeface="Consolas"/>
-              </a:rPr>
-              <a:t>HITL</a:t>
-            </a:r>
-          </a:p>
-        </p:txBody>
-      </p:sp>
-      <p:sp>
-        <p:nvSpPr>
-          <p:cNvPr id="42" name="TextBox 41"/>
-          <p:cNvSpPr txBox="1"/>
-          <p:nvPr/>
-        </p:nvSpPr>
-        <p:spPr>
-          <a:xfrm>
-            <a:off x="7808976" y="2432304"/>
-            <a:ext cx="1325880" cy="310896"/>
-          </a:xfrm>
-          <a:prstGeom prst="rect">
-            <a:avLst/>
-          </a:prstGeom>
-          <a:noFill/>
-        </p:spPr>
-        <p:txBody>
-          <a:bodyPr wrap="square" lIns="0" rIns="0" tIns="0" bIns="0" anchor="t">
-            <a:spAutoFit/>
-          </a:bodyPr>
-          <a:lstStyle/>
-          <a:p>
-            <a:pPr algn="l"/>
-            <a:r>
-              <a:rPr sz="1450" b="1">
-                <a:solidFill>
-                  <a:srgbClr val="1C2127"/>
-                </a:solidFill>
-                <a:latin typeface="Calibri"/>
-              </a:rPr>
-              <a:t>Review app</a:t>
-            </a:r>
-          </a:p>
-        </p:txBody>
-      </p:sp>
-      <p:pic>
-        <p:nvPicPr>
-          <p:cNvPr id="43" name="Picture 42" descr="user.png"/>
-          <p:cNvPicPr>
-            <a:picLocks noChangeAspect="1"/>
-          </p:cNvPicPr>
-          <p:nvPr/>
-        </p:nvPicPr>
-        <p:blipFill>
-          <a:blip r:embed="rId6"/>
-          <a:stretch>
-            <a:fillRect/>
-          </a:stretch>
-        </p:blipFill>
-        <p:spPr>
-          <a:xfrm>
-            <a:off x="8805672" y="2157984"/>
-            <a:ext cx="274320" cy="274320"/>
-          </a:xfrm>
-          <a:prstGeom prst="rect">
-            <a:avLst/>
-          </a:prstGeom>
-        </p:spPr>
-      </p:pic>
-      <p:sp>
-        <p:nvSpPr>
-          <p:cNvPr id="44" name="TextBox 43"/>
-          <p:cNvSpPr txBox="1"/>
-          <p:nvPr/>
-        </p:nvSpPr>
-        <p:spPr>
-          <a:xfrm>
-            <a:off x="7808976" y="2816352"/>
-            <a:ext cx="1271016" cy="1097280"/>
-          </a:xfrm>
-          <a:prstGeom prst="rect">
-            <a:avLst/>
-          </a:prstGeom>
-          <a:noFill/>
-        </p:spPr>
-        <p:txBody>
-          <a:bodyPr wrap="square" lIns="0" rIns="0" tIns="0" bIns="0" anchor="t">
-            <a:spAutoFit/>
-          </a:bodyPr>
-          <a:lstStyle/>
-          <a:p>
-            <a:pPr algn="l">
-              <a:lnSpc>
-                <a:spcPct val="112000"/>
-              </a:lnSpc>
-            </a:pPr>
-            <a:r>
-              <a:rPr sz="1100" b="0">
-                <a:solidFill>
-                  <a:srgbClr val="2F343C"/>
-                </a:solidFill>
-                <a:latin typeface="Calibri"/>
-              </a:rPr>
-              <a:t>Pick an FRD, run, answer what the agent could not settle, re-render — then upload the approved STTM yourself.</a:t>
-            </a:r>
-          </a:p>
-        </p:txBody>
-      </p:sp>
-      <p:sp>
-        <p:nvSpPr>
-          <p:cNvPr id="45" name="Rounded Rectangle 44"/>
-          <p:cNvSpPr/>
-          <p:nvPr/>
-        </p:nvSpPr>
-        <p:spPr>
-          <a:xfrm>
-            <a:off x="9555480" y="2011680"/>
-            <a:ext cx="2084831" cy="2788920"/>
-          </a:xfrm>
-          <a:prstGeom prst="roundRect">
-            <a:avLst>
-              <a:gd name="adj" fmla="val 3500"/>
-            </a:avLst>
-          </a:prstGeom>
-          <a:solidFill>
-            <a:srgbClr val="F6F7F9"/>
-          </a:solidFill>
-          <a:ln w="9525">
-            <a:solidFill>
-              <a:srgbClr val="D3D8DE"/>
-            </a:solidFill>
-          </a:ln>
-          <a:effectLst/>
-        </p:spPr>
-        <p:style>
-          <a:lnRef idx="1">
-            <a:schemeClr val="accent1"/>
-          </a:lnRef>
-          <a:fillRef idx="3">
-            <a:schemeClr val="accent1"/>
-          </a:fillRef>
-          <a:effectRef idx="2">
-            <a:schemeClr val="accent1"/>
-          </a:effectRef>
-          <a:fontRef idx="minor">
-            <a:schemeClr val="lt1"/>
-          </a:fontRef>
-        </p:style>
-        <p:txBody>
-          <a:bodyPr rtlCol="0" anchor="ctr"/>
-          <a:lstStyle/>
-          <a:p/>
-        </p:txBody>
-      </p:sp>
-      <p:sp>
-        <p:nvSpPr>
-          <p:cNvPr id="46" name="Oval 45"/>
-          <p:cNvSpPr/>
-          <p:nvPr/>
-        </p:nvSpPr>
-        <p:spPr>
-          <a:xfrm>
-            <a:off x="9742932" y="2235708"/>
-            <a:ext cx="100584" cy="100584"/>
-          </a:xfrm>
-          <a:prstGeom prst="ellipse">
-            <a:avLst/>
-          </a:prstGeom>
-          <a:solidFill>
-            <a:srgbClr val="7961DB"/>
-          </a:solidFill>
-          <a:ln>
-            <a:noFill/>
-          </a:ln>
-          <a:effectLst/>
-        </p:spPr>
-        <p:style>
-          <a:lnRef idx="1">
-            <a:schemeClr val="accent1"/>
-          </a:lnRef>
-          <a:fillRef idx="3">
-            <a:schemeClr val="accent1"/>
-          </a:fillRef>
-          <a:effectRef idx="2">
-            <a:schemeClr val="accent1"/>
-          </a:effectRef>
-          <a:fontRef idx="minor">
-            <a:schemeClr val="lt1"/>
-          </a:fontRef>
-        </p:style>
-        <p:txBody>
-          <a:bodyPr rtlCol="0" anchor="ctr"/>
-          <a:lstStyle/>
-          <a:p>
-            <a:pPr algn="ctr"/>
-          </a:p>
-        </p:txBody>
-      </p:sp>
-      <p:sp>
-        <p:nvSpPr>
-          <p:cNvPr id="47" name="TextBox 46"/>
-          <p:cNvSpPr txBox="1"/>
-          <p:nvPr/>
-        </p:nvSpPr>
-        <p:spPr>
-          <a:xfrm>
-            <a:off x="9957815" y="2185416"/>
-            <a:ext cx="914400" cy="219456"/>
-          </a:xfrm>
-          <a:prstGeom prst="rect">
-            <a:avLst/>
-          </a:prstGeom>
-          <a:noFill/>
-        </p:spPr>
-        <p:txBody>
-          <a:bodyPr wrap="square" lIns="0" rIns="0" tIns="0" bIns="0" anchor="t">
-            <a:spAutoFit/>
-          </a:bodyPr>
-          <a:lstStyle/>
-          <a:p>
-            <a:pPr algn="l"/>
-            <a:r>
-              <a:rPr sz="900" b="1" spc="120">
-                <a:solidFill>
-                  <a:srgbClr val="5642A6"/>
-                </a:solidFill>
-                <a:latin typeface="Consolas"/>
-              </a:rPr>
-              <a:t>OUT</a:t>
-            </a:r>
-          </a:p>
-        </p:txBody>
-      </p:sp>
-      <p:sp>
-        <p:nvSpPr>
-          <p:cNvPr id="48" name="TextBox 47"/>
-          <p:cNvSpPr txBox="1"/>
-          <p:nvPr/>
-        </p:nvSpPr>
-        <p:spPr>
-          <a:xfrm>
-            <a:off x="9774936" y="2432304"/>
-            <a:ext cx="1719072" cy="310896"/>
-          </a:xfrm>
-          <a:prstGeom prst="rect">
-            <a:avLst/>
-          </a:prstGeom>
-          <a:noFill/>
-        </p:spPr>
-        <p:txBody>
-          <a:bodyPr wrap="square" lIns="0" rIns="0" tIns="0" bIns="0" anchor="t">
-            <a:spAutoFit/>
-          </a:bodyPr>
-          <a:lstStyle/>
-          <a:p>
-            <a:pPr algn="l"/>
-            <a:r>
-              <a:rPr sz="1450" b="1">
-                <a:solidFill>
-                  <a:srgbClr val="1C2127"/>
-                </a:solidFill>
-                <a:latin typeface="Calibri"/>
-              </a:rPr>
-              <a:t>Outputs</a:t>
-            </a:r>
-          </a:p>
-        </p:txBody>
-      </p:sp>
-      <p:pic>
-        <p:nvPicPr>
-          <p:cNvPr id="49" name="Picture 48" descr="code.png"/>
+          <p:cNvPr id="33" name="Picture 32" descr="databricks.png"/>
           <p:cNvPicPr>
             <a:picLocks noChangeAspect="1"/>
           </p:cNvPicPr>
@@ -4857,8 +4224,8 @@
         </p:blipFill>
         <p:spPr>
           <a:xfrm>
-            <a:off x="11164824" y="2157984"/>
-            <a:ext cx="274320" cy="274320"/>
+            <a:off x="1112402" y="3099815"/>
+            <a:ext cx="655554" cy="365760"/>
           </a:xfrm>
           <a:prstGeom prst="rect">
             <a:avLst/>
@@ -4867,14 +4234,14 @@
       </p:pic>
       <p:sp>
         <p:nvSpPr>
-          <p:cNvPr id="50" name="TextBox 49"/>
+          <p:cNvPr id="34" name="TextBox 33"/>
           <p:cNvSpPr txBox="1"/>
           <p:nvPr/>
         </p:nvSpPr>
         <p:spPr>
           <a:xfrm>
-            <a:off x="9774936" y="2816352"/>
-            <a:ext cx="1664207" cy="1097280"/>
+            <a:off x="2240280" y="3118103"/>
+            <a:ext cx="5943600" cy="274320"/>
           </a:xfrm>
           <a:prstGeom prst="rect">
             <a:avLst/>
@@ -4887,37 +4254,42 @@
           </a:bodyPr>
           <a:lstStyle/>
           <a:p>
-            <a:pPr algn="l">
-              <a:lnSpc>
-                <a:spcPct val="112000"/>
-              </a:lnSpc>
-            </a:pPr>
-            <a:r>
-              <a:rPr sz="1100" b="0">
-                <a:solidFill>
-                  <a:srgbClr val="2F343C"/>
+            <a:pPr algn="l"/>
+            <a:r>
+              <a:rPr sz="1200" b="1">
+                <a:solidFill>
+                  <a:srgbClr val="1C2127"/>
                 </a:solidFill>
                 <a:latin typeface="Calibri"/>
               </a:rPr>
-              <a:t>STTM workbook + feed contract → CodeGen and Code Review agents.</a:t>
-            </a:r>
-          </a:p>
-        </p:txBody>
-      </p:sp>
-      <p:sp>
-        <p:nvSpPr>
-          <p:cNvPr id="51" name="Rounded Rectangle 50"/>
+              <a:t>Databricks</a:t>
+            </a:r>
+            <a:r>
+              <a:rPr sz="1000" b="0">
+                <a:solidFill>
+                  <a:srgbClr val="2F343C"/>
+                </a:solidFill>
+                <a:latin typeface="Calibri"/>
+              </a:rPr>
+              <a:t>   — Jobs run the pipeline, Apps serve the reviewer, Unity Catalog holds every file and table.</a:t>
+            </a:r>
+          </a:p>
+        </p:txBody>
+      </p:sp>
+      <p:sp>
+        <p:nvSpPr>
+          <p:cNvPr id="35" name="Rounded Rectangle 34"/>
           <p:cNvSpPr/>
           <p:nvPr/>
         </p:nvSpPr>
         <p:spPr>
           <a:xfrm>
-            <a:off x="9701784" y="3849624"/>
-            <a:ext cx="1792223" cy="804672"/>
+            <a:off x="777240" y="3566160"/>
+            <a:ext cx="3063240" cy="1463040"/>
           </a:xfrm>
           <a:prstGeom prst="roundRect">
             <a:avLst>
-              <a:gd name="adj" fmla="val 3000"/>
+              <a:gd name="adj" fmla="val 4000"/>
             </a:avLst>
           </a:prstGeom>
           <a:solidFill>
@@ -4952,7 +4324,7 @@
       </p:sp>
       <p:pic>
         <p:nvPicPr>
-          <p:cNvPr id="52" name="Picture 51" descr="sttm_sheet.png"/>
+          <p:cNvPr id="36" name="Picture 35" descr="unitycatalog.png"/>
           <p:cNvPicPr>
             <a:picLocks noChangeAspect="1"/>
           </p:cNvPicPr>
@@ -4966,8 +4338,8 @@
         </p:blipFill>
         <p:spPr>
           <a:xfrm>
-            <a:off x="10019759" y="3867912"/>
-            <a:ext cx="1156273" cy="768096"/>
+            <a:off x="988278" y="3712463"/>
+            <a:ext cx="1232987" cy="420623"/>
           </a:xfrm>
           <a:prstGeom prst="rect">
             <a:avLst/>
@@ -4976,18 +4348,107 @@
       </p:pic>
       <p:sp>
         <p:nvSpPr>
-          <p:cNvPr id="53" name="Rounded Rectangle 52"/>
+          <p:cNvPr id="37" name="TextBox 36"/>
+          <p:cNvSpPr txBox="1"/>
+          <p:nvPr/>
+        </p:nvSpPr>
+        <p:spPr>
+          <a:xfrm>
+            <a:off x="941832" y="4224528"/>
+            <a:ext cx="2734056" cy="731520"/>
+          </a:xfrm>
+          <a:prstGeom prst="rect">
+            <a:avLst/>
+          </a:prstGeom>
+          <a:noFill/>
+        </p:spPr>
+        <p:txBody>
+          <a:bodyPr wrap="square" lIns="0" rIns="0" tIns="0" bIns="0" anchor="t">
+            <a:spAutoFit/>
+          </a:bodyPr>
+          <a:lstStyle/>
+          <a:p>
+            <a:pPr algn="l">
+              <a:lnSpc>
+                <a:spcPct val="106000"/>
+              </a:lnSpc>
+            </a:pPr>
+            <a:r>
+              <a:rPr sz="950" b="1">
+                <a:solidFill>
+                  <a:srgbClr val="1C2127"/>
+                </a:solidFill>
+                <a:latin typeface="Calibri"/>
+              </a:rPr>
+              <a:t>Volumes</a:t>
+            </a:r>
+            <a:r>
+              <a:rPr sz="950" b="0">
+                <a:solidFill>
+                  <a:srgbClr val="2F343C"/>
+                </a:solidFill>
+                <a:latin typeface="Calibri"/>
+              </a:rPr>
+              <a:t>  —  FRDs, approved STTMs, the corpus index, every run's artifacts</a:t>
+            </a:r>
+          </a:p>
+          <a:p>
+            <a:pPr algn="l">
+              <a:lnSpc>
+                <a:spcPct val="106000"/>
+              </a:lnSpc>
+            </a:pPr>
+            <a:r>
+              <a:rPr sz="850" b="1">
+                <a:solidFill>
+                  <a:srgbClr val="007067"/>
+                </a:solidFill>
+                <a:latin typeface="Consolas"/>
+              </a:rPr>
+              <a:t>frd_raw · sttm_reference · sttm_out</a:t>
+            </a:r>
+          </a:p>
+          <a:p>
+            <a:pPr algn="l">
+              <a:lnSpc>
+                <a:spcPct val="106000"/>
+              </a:lnSpc>
+            </a:pPr>
+            <a:r>
+              <a:rPr sz="950" b="1">
+                <a:solidFill>
+                  <a:srgbClr val="1C2127"/>
+                </a:solidFill>
+                <a:latin typeface="Calibri"/>
+              </a:rPr>
+              <a:t>Delta tables</a:t>
+            </a:r>
+            <a:r>
+              <a:rPr sz="950" b="0">
+                <a:solidFill>
+                  <a:srgbClr val="2F343C"/>
+                </a:solidFill>
+                <a:latin typeface="Calibri"/>
+              </a:rPr>
+              <a:t>  —  run history and contracts</a:t>
+            </a:r>
+          </a:p>
+        </p:txBody>
+      </p:sp>
+      <p:sp>
+        <p:nvSpPr>
+          <p:cNvPr id="38" name="Rounded Rectangle 37"/>
           <p:cNvSpPr/>
           <p:nvPr/>
         </p:nvSpPr>
         <p:spPr>
           <a:xfrm>
-            <a:off x="4974336" y="3904487"/>
-            <a:ext cx="461771" cy="457200"/>
+            <a:off x="4023360" y="3566160"/>
+            <a:ext cx="4892040" cy="1463040"/>
           </a:xfrm>
           <a:prstGeom prst="roundRect">
             <a:avLst>
-              <a:gd name="adj" fmla="val 10000"/>
+              <a:gd name="adj" fmla="val 4000"/>
             </a:avLst>
           </a:prstGeom>
           <a:solidFill>
@@ -5022,14 +4483,14 @@
       </p:sp>
       <p:sp>
         <p:nvSpPr>
-          <p:cNvPr id="54" name="TextBox 53"/>
+          <p:cNvPr id="39" name="TextBox 38"/>
           <p:cNvSpPr txBox="1"/>
           <p:nvPr/>
         </p:nvSpPr>
         <p:spPr>
           <a:xfrm>
-            <a:off x="4974336" y="3968496"/>
-            <a:ext cx="461771" cy="164592"/>
+            <a:off x="4187952" y="3675887"/>
+            <a:ext cx="4562855" cy="237744"/>
           </a:xfrm>
           <a:prstGeom prst="rect">
             <a:avLst/>
@@ -5042,7 +4503,97 @@
           </a:bodyPr>
           <a:lstStyle/>
           <a:p>
-            <a:pPr algn="ctr"/>
+            <a:pPr algn="l"/>
+            <a:r>
+              <a:rPr sz="1200" b="1">
+                <a:solidFill>
+                  <a:srgbClr val="1C2127"/>
+                </a:solidFill>
+                <a:latin typeface="Calibri"/>
+              </a:rPr>
+              <a:t>Generation job</a:t>
+            </a:r>
+            <a:r>
+              <a:rPr sz="950" b="0">
+                <a:solidFill>
+                  <a:srgbClr val="2F343C"/>
+                </a:solidFill>
+                <a:latin typeface="Calibri"/>
+              </a:rPr>
+              <a:t>   Databricks Jobs · serverless · stages 01–04</a:t>
+            </a:r>
+          </a:p>
+        </p:txBody>
+      </p:sp>
+      <p:sp>
+        <p:nvSpPr>
+          <p:cNvPr id="40" name="Rounded Rectangle 39"/>
+          <p:cNvSpPr/>
+          <p:nvPr/>
+        </p:nvSpPr>
+        <p:spPr>
+          <a:xfrm>
+            <a:off x="4187952" y="4005072"/>
+            <a:ext cx="1072134" cy="640080"/>
+          </a:xfrm>
+          <a:prstGeom prst="roundRect">
+            <a:avLst>
+              <a:gd name="adj" fmla="val 8000"/>
+            </a:avLst>
+          </a:prstGeom>
+          <a:solidFill>
+            <a:srgbClr val="F6F7F9"/>
+          </a:solidFill>
+          <a:ln w="9525">
+            <a:solidFill>
+              <a:srgbClr val="C5CBD3"/>
+            </a:solidFill>
+          </a:ln>
+          <a:effectLst/>
+        </p:spPr>
+        <p:style>
+          <a:lnRef idx="1">
+            <a:schemeClr val="accent1"/>
+          </a:lnRef>
+          <a:fillRef idx="3">
+            <a:schemeClr val="accent1"/>
+          </a:fillRef>
+          <a:effectRef idx="2">
+            <a:schemeClr val="accent1"/>
+          </a:effectRef>
+          <a:fontRef idx="minor">
+            <a:schemeClr val="lt1"/>
+          </a:fontRef>
+        </p:style>
+        <p:txBody>
+          <a:bodyPr rtlCol="0" anchor="ctr"/>
+          <a:lstStyle/>
+          <a:p/>
+        </p:txBody>
+      </p:sp>
+      <p:sp>
+        <p:nvSpPr>
+          <p:cNvPr id="41" name="TextBox 40"/>
+          <p:cNvSpPr txBox="1"/>
+          <p:nvPr/>
+        </p:nvSpPr>
+        <p:spPr>
+          <a:xfrm>
+            <a:off x="4279392" y="4069080"/>
+            <a:ext cx="889253" cy="164592"/>
+          </a:xfrm>
+          <a:prstGeom prst="rect">
+            <a:avLst/>
+          </a:prstGeom>
+          <a:noFill/>
+        </p:spPr>
+        <p:txBody>
+          <a:bodyPr wrap="square" lIns="0" rIns="0" tIns="0" bIns="0" anchor="t">
+            <a:spAutoFit/>
+          </a:bodyPr>
+          <a:lstStyle/>
+          <a:p>
+            <a:pPr algn="l"/>
             <a:r>
               <a:rPr sz="850" b="1">
                 <a:solidFill>
@@ -5057,14 +4608,14 @@
       </p:sp>
       <p:sp>
         <p:nvSpPr>
-          <p:cNvPr id="55" name="TextBox 54"/>
+          <p:cNvPr id="42" name="TextBox 41"/>
           <p:cNvSpPr txBox="1"/>
           <p:nvPr/>
         </p:nvSpPr>
         <p:spPr>
           <a:xfrm>
-            <a:off x="4974336" y="4123944"/>
-            <a:ext cx="461771" cy="201168"/>
+            <a:off x="4279392" y="4233672"/>
+            <a:ext cx="889253" cy="201168"/>
           </a:xfrm>
           <a:prstGeom prst="rect">
             <a:avLst/>
@@ -5077,9 +4628,9 @@
           </a:bodyPr>
           <a:lstStyle/>
           <a:p>
-            <a:pPr algn="ctr"/>
-            <a:r>
-              <a:rPr sz="900" b="0">
+            <a:pPr algn="l"/>
+            <a:r>
+              <a:rPr sz="1000" b="1">
                 <a:solidFill>
                   <a:srgbClr val="1C2127"/>
                 </a:solidFill>
@@ -5090,15 +4641,50 @@
           </a:p>
         </p:txBody>
       </p:sp>
+      <p:sp>
+        <p:nvSpPr>
+          <p:cNvPr id="43" name="TextBox 42"/>
+          <p:cNvSpPr txBox="1"/>
+          <p:nvPr/>
+        </p:nvSpPr>
+        <p:spPr>
+          <a:xfrm>
+            <a:off x="4279392" y="4434840"/>
+            <a:ext cx="889253" cy="182880"/>
+          </a:xfrm>
+          <a:prstGeom prst="rect">
+            <a:avLst/>
+          </a:prstGeom>
+          <a:noFill/>
+        </p:spPr>
+        <p:txBody>
+          <a:bodyPr wrap="square" lIns="0" rIns="0" tIns="0" bIns="0" anchor="t">
+            <a:spAutoFit/>
+          </a:bodyPr>
+          <a:lstStyle/>
+          <a:p>
+            <a:pPr algn="l"/>
+            <a:r>
+              <a:rPr sz="800" b="0">
+                <a:solidFill>
+                  <a:srgbClr val="2F343C"/>
+                </a:solidFill>
+                <a:latin typeface="Calibri"/>
+              </a:rPr>
+              <a:t>docx → markdown</a:t>
+            </a:r>
+          </a:p>
+        </p:txBody>
+      </p:sp>
       <p:cxnSp>
         <p:nvCxnSpPr>
-          <p:cNvPr id="56" name="Connector 55"/>
+          <p:cNvPr id="44" name="Connector 43"/>
           <p:cNvCxnSpPr/>
           <p:nvPr/>
         </p:nvCxnSpPr>
         <p:spPr>
           <a:xfrm>
-            <a:off x="5445252" y="4133087"/>
+            <a:off x="5269229" y="4334256"/>
             <a:ext cx="73152" cy="0"/>
           </a:xfrm>
           <a:prstGeom prst="line">
@@ -5106,7 +4692,7 @@
           </a:prstGeom>
           <a:ln w="9525">
             <a:solidFill>
-              <a:srgbClr val="C5CBD3"/>
+              <a:srgbClr val="5F6B7C"/>
             </a:solidFill>
             <a:tailEnd type="triangle" w="sm" len="sm"/>
           </a:ln>
@@ -5128,18 +4714,18 @@
       </p:cxnSp>
       <p:sp>
         <p:nvSpPr>
-          <p:cNvPr id="57" name="Rounded Rectangle 56"/>
+          <p:cNvPr id="45" name="Rounded Rectangle 44"/>
           <p:cNvSpPr/>
           <p:nvPr/>
         </p:nvSpPr>
         <p:spPr>
           <a:xfrm>
-            <a:off x="5527548" y="3904487"/>
-            <a:ext cx="461771" cy="457200"/>
+            <a:off x="5351526" y="4005072"/>
+            <a:ext cx="1072134" cy="640080"/>
           </a:xfrm>
           <a:prstGeom prst="roundRect">
             <a:avLst>
-              <a:gd name="adj" fmla="val 10000"/>
+              <a:gd name="adj" fmla="val 8000"/>
             </a:avLst>
           </a:prstGeom>
           <a:solidFill>
@@ -5174,14 +4760,14 @@
       </p:sp>
       <p:sp>
         <p:nvSpPr>
-          <p:cNvPr id="58" name="TextBox 57"/>
+          <p:cNvPr id="46" name="TextBox 45"/>
           <p:cNvSpPr txBox="1"/>
           <p:nvPr/>
         </p:nvSpPr>
         <p:spPr>
           <a:xfrm>
-            <a:off x="5527548" y="3968496"/>
-            <a:ext cx="461771" cy="164592"/>
+            <a:off x="5442966" y="4069080"/>
+            <a:ext cx="889253" cy="164592"/>
           </a:xfrm>
           <a:prstGeom prst="rect">
             <a:avLst/>
@@ -5194,7 +4780,7 @@
           </a:bodyPr>
           <a:lstStyle/>
           <a:p>
-            <a:pPr algn="ctr"/>
+            <a:pPr algn="l"/>
             <a:r>
               <a:rPr sz="850" b="1">
                 <a:solidFill>
@@ -5209,14 +4795,14 @@
       </p:sp>
       <p:sp>
         <p:nvSpPr>
-          <p:cNvPr id="59" name="TextBox 58"/>
+          <p:cNvPr id="47" name="TextBox 46"/>
           <p:cNvSpPr txBox="1"/>
           <p:nvPr/>
         </p:nvSpPr>
         <p:spPr>
           <a:xfrm>
-            <a:off x="5527548" y="4123944"/>
-            <a:ext cx="461771" cy="201168"/>
+            <a:off x="5442966" y="4233672"/>
+            <a:ext cx="889253" cy="201168"/>
           </a:xfrm>
           <a:prstGeom prst="rect">
             <a:avLst/>
@@ -5229,9 +4815,9 @@
           </a:bodyPr>
           <a:lstStyle/>
           <a:p>
-            <a:pPr algn="ctr"/>
-            <a:r>
-              <a:rPr sz="900" b="1">
+            <a:pPr algn="l"/>
+            <a:r>
+              <a:rPr sz="1000" b="1">
                 <a:solidFill>
                   <a:srgbClr val="A04D2C"/>
                 </a:solidFill>
@@ -5242,15 +4828,50 @@
           </a:p>
         </p:txBody>
       </p:sp>
+      <p:sp>
+        <p:nvSpPr>
+          <p:cNvPr id="48" name="TextBox 47"/>
+          <p:cNvSpPr txBox="1"/>
+          <p:nvPr/>
+        </p:nvSpPr>
+        <p:spPr>
+          <a:xfrm>
+            <a:off x="5442966" y="4434840"/>
+            <a:ext cx="889253" cy="182880"/>
+          </a:xfrm>
+          <a:prstGeom prst="rect">
+            <a:avLst/>
+          </a:prstGeom>
+          <a:noFill/>
+        </p:spPr>
+        <p:txBody>
+          <a:bodyPr wrap="square" lIns="0" rIns="0" tIns="0" bIns="0" anchor="t">
+            <a:spAutoFit/>
+          </a:bodyPr>
+          <a:lstStyle/>
+          <a:p>
+            <a:pPr algn="l"/>
+            <a:r>
+              <a:rPr sz="800" b="0">
+                <a:solidFill>
+                  <a:srgbClr val="A04D2C"/>
+                </a:solidFill>
+                <a:latin typeface="Calibri"/>
+              </a:rPr>
+              <a:t>the one model call</a:t>
+            </a:r>
+          </a:p>
+        </p:txBody>
+      </p:sp>
       <p:cxnSp>
         <p:nvCxnSpPr>
-          <p:cNvPr id="60" name="Connector 59"/>
+          <p:cNvPr id="49" name="Connector 48"/>
           <p:cNvCxnSpPr/>
           <p:nvPr/>
         </p:nvCxnSpPr>
         <p:spPr>
           <a:xfrm>
-            <a:off x="5998464" y="4133087"/>
+            <a:off x="6432804" y="4334256"/>
             <a:ext cx="73152" cy="0"/>
           </a:xfrm>
           <a:prstGeom prst="line">
@@ -5258,7 +4879,7 @@
           </a:prstGeom>
           <a:ln w="9525">
             <a:solidFill>
-              <a:srgbClr val="C5CBD3"/>
+              <a:srgbClr val="5F6B7C"/>
             </a:solidFill>
             <a:tailEnd type="triangle" w="sm" len="sm"/>
           </a:ln>
@@ -5280,18 +4901,415 @@
       </p:cxnSp>
       <p:sp>
         <p:nvSpPr>
+          <p:cNvPr id="50" name="Rounded Rectangle 49"/>
+          <p:cNvSpPr/>
+          <p:nvPr/>
+        </p:nvSpPr>
+        <p:spPr>
+          <a:xfrm>
+            <a:off x="6515100" y="4005072"/>
+            <a:ext cx="1072134" cy="640080"/>
+          </a:xfrm>
+          <a:prstGeom prst="roundRect">
+            <a:avLst>
+              <a:gd name="adj" fmla="val 8000"/>
+            </a:avLst>
+          </a:prstGeom>
+          <a:solidFill>
+            <a:srgbClr val="F6F7F9"/>
+          </a:solidFill>
+          <a:ln w="9525">
+            <a:solidFill>
+              <a:srgbClr val="C5CBD3"/>
+            </a:solidFill>
+          </a:ln>
+          <a:effectLst/>
+        </p:spPr>
+        <p:style>
+          <a:lnRef idx="1">
+            <a:schemeClr val="accent1"/>
+          </a:lnRef>
+          <a:fillRef idx="3">
+            <a:schemeClr val="accent1"/>
+          </a:fillRef>
+          <a:effectRef idx="2">
+            <a:schemeClr val="accent1"/>
+          </a:effectRef>
+          <a:fontRef idx="minor">
+            <a:schemeClr val="lt1"/>
+          </a:fontRef>
+        </p:style>
+        <p:txBody>
+          <a:bodyPr rtlCol="0" anchor="ctr"/>
+          <a:lstStyle/>
+          <a:p/>
+        </p:txBody>
+      </p:sp>
+      <p:sp>
+        <p:nvSpPr>
+          <p:cNvPr id="51" name="TextBox 50"/>
+          <p:cNvSpPr txBox="1"/>
+          <p:nvPr/>
+        </p:nvSpPr>
+        <p:spPr>
+          <a:xfrm>
+            <a:off x="6606540" y="4069080"/>
+            <a:ext cx="889253" cy="164592"/>
+          </a:xfrm>
+          <a:prstGeom prst="rect">
+            <a:avLst/>
+          </a:prstGeom>
+          <a:noFill/>
+        </p:spPr>
+        <p:txBody>
+          <a:bodyPr wrap="square" lIns="0" rIns="0" tIns="0" bIns="0" anchor="t">
+            <a:spAutoFit/>
+          </a:bodyPr>
+          <a:lstStyle/>
+          <a:p>
+            <a:pPr algn="l"/>
+            <a:r>
+              <a:rPr sz="850" b="1">
+                <a:solidFill>
+                  <a:srgbClr val="007067"/>
+                </a:solidFill>
+                <a:latin typeface="Consolas"/>
+              </a:rPr>
+              <a:t>03</a:t>
+            </a:r>
+          </a:p>
+        </p:txBody>
+      </p:sp>
+      <p:sp>
+        <p:nvSpPr>
+          <p:cNvPr id="52" name="TextBox 51"/>
+          <p:cNvSpPr txBox="1"/>
+          <p:nvPr/>
+        </p:nvSpPr>
+        <p:spPr>
+          <a:xfrm>
+            <a:off x="6606540" y="4233672"/>
+            <a:ext cx="889253" cy="201168"/>
+          </a:xfrm>
+          <a:prstGeom prst="rect">
+            <a:avLst/>
+          </a:prstGeom>
+          <a:noFill/>
+        </p:spPr>
+        <p:txBody>
+          <a:bodyPr wrap="square" lIns="0" rIns="0" tIns="0" bIns="0" anchor="t">
+            <a:spAutoFit/>
+          </a:bodyPr>
+          <a:lstStyle/>
+          <a:p>
+            <a:pPr algn="l"/>
+            <a:r>
+              <a:rPr sz="1000" b="1">
+                <a:solidFill>
+                  <a:srgbClr val="1C2127"/>
+                </a:solidFill>
+                <a:latin typeface="Calibri"/>
+              </a:rPr>
+              <a:t>Audit · gate</a:t>
+            </a:r>
+          </a:p>
+        </p:txBody>
+      </p:sp>
+      <p:sp>
+        <p:nvSpPr>
+          <p:cNvPr id="53" name="TextBox 52"/>
+          <p:cNvSpPr txBox="1"/>
+          <p:nvPr/>
+        </p:nvSpPr>
+        <p:spPr>
+          <a:xfrm>
+            <a:off x="6606540" y="4434840"/>
+            <a:ext cx="889253" cy="182880"/>
+          </a:xfrm>
+          <a:prstGeom prst="rect">
+            <a:avLst/>
+          </a:prstGeom>
+          <a:noFill/>
+        </p:spPr>
+        <p:txBody>
+          <a:bodyPr wrap="square" lIns="0" rIns="0" tIns="0" bIns="0" anchor="t">
+            <a:spAutoFit/>
+          </a:bodyPr>
+          <a:lstStyle/>
+          <a:p>
+            <a:pPr algn="l"/>
+            <a:r>
+              <a:rPr sz="800" b="0">
+                <a:solidFill>
+                  <a:srgbClr val="2F343C"/>
+                </a:solidFill>
+                <a:latin typeface="Calibri"/>
+              </a:rPr>
+              <a:t>verbatim grounding</a:t>
+            </a:r>
+          </a:p>
+        </p:txBody>
+      </p:sp>
+      <p:cxnSp>
+        <p:nvCxnSpPr>
+          <p:cNvPr id="54" name="Connector 53"/>
+          <p:cNvCxnSpPr/>
+          <p:nvPr/>
+        </p:nvCxnSpPr>
+        <p:spPr>
+          <a:xfrm>
+            <a:off x="7596377" y="4334256"/>
+            <a:ext cx="73152" cy="0"/>
+          </a:xfrm>
+          <a:prstGeom prst="line">
+            <a:avLst/>
+          </a:prstGeom>
+          <a:ln w="9525">
+            <a:solidFill>
+              <a:srgbClr val="5F6B7C"/>
+            </a:solidFill>
+            <a:tailEnd type="triangle" w="sm" len="sm"/>
+          </a:ln>
+        </p:spPr>
+        <p:style>
+          <a:lnRef idx="2">
+            <a:schemeClr val="accent1"/>
+          </a:lnRef>
+          <a:fillRef idx="0">
+            <a:schemeClr val="accent1"/>
+          </a:fillRef>
+          <a:effectRef idx="1">
+            <a:schemeClr val="accent1"/>
+          </a:effectRef>
+          <a:fontRef idx="minor">
+            <a:schemeClr val="tx1"/>
+          </a:fontRef>
+        </p:style>
+      </p:cxnSp>
+      <p:sp>
+        <p:nvSpPr>
+          <p:cNvPr id="55" name="Rounded Rectangle 54"/>
+          <p:cNvSpPr/>
+          <p:nvPr/>
+        </p:nvSpPr>
+        <p:spPr>
+          <a:xfrm>
+            <a:off x="7678674" y="4005072"/>
+            <a:ext cx="1072134" cy="640080"/>
+          </a:xfrm>
+          <a:prstGeom prst="roundRect">
+            <a:avLst>
+              <a:gd name="adj" fmla="val 8000"/>
+            </a:avLst>
+          </a:prstGeom>
+          <a:solidFill>
+            <a:srgbClr val="F6F7F9"/>
+          </a:solidFill>
+          <a:ln w="9525">
+            <a:solidFill>
+              <a:srgbClr val="C5CBD3"/>
+            </a:solidFill>
+          </a:ln>
+          <a:effectLst/>
+        </p:spPr>
+        <p:style>
+          <a:lnRef idx="1">
+            <a:schemeClr val="accent1"/>
+          </a:lnRef>
+          <a:fillRef idx="3">
+            <a:schemeClr val="accent1"/>
+          </a:fillRef>
+          <a:effectRef idx="2">
+            <a:schemeClr val="accent1"/>
+          </a:effectRef>
+          <a:fontRef idx="minor">
+            <a:schemeClr val="lt1"/>
+          </a:fontRef>
+        </p:style>
+        <p:txBody>
+          <a:bodyPr rtlCol="0" anchor="ctr"/>
+          <a:lstStyle/>
+          <a:p/>
+        </p:txBody>
+      </p:sp>
+      <p:sp>
+        <p:nvSpPr>
+          <p:cNvPr id="56" name="TextBox 55"/>
+          <p:cNvSpPr txBox="1"/>
+          <p:nvPr/>
+        </p:nvSpPr>
+        <p:spPr>
+          <a:xfrm>
+            <a:off x="7770114" y="4069080"/>
+            <a:ext cx="889253" cy="164592"/>
+          </a:xfrm>
+          <a:prstGeom prst="rect">
+            <a:avLst/>
+          </a:prstGeom>
+          <a:noFill/>
+        </p:spPr>
+        <p:txBody>
+          <a:bodyPr wrap="square" lIns="0" rIns="0" tIns="0" bIns="0" anchor="t">
+            <a:spAutoFit/>
+          </a:bodyPr>
+          <a:lstStyle/>
+          <a:p>
+            <a:pPr algn="l"/>
+            <a:r>
+              <a:rPr sz="850" b="1">
+                <a:solidFill>
+                  <a:srgbClr val="007067"/>
+                </a:solidFill>
+                <a:latin typeface="Consolas"/>
+              </a:rPr>
+              <a:t>04</a:t>
+            </a:r>
+          </a:p>
+        </p:txBody>
+      </p:sp>
+      <p:sp>
+        <p:nvSpPr>
+          <p:cNvPr id="57" name="TextBox 56"/>
+          <p:cNvSpPr txBox="1"/>
+          <p:nvPr/>
+        </p:nvSpPr>
+        <p:spPr>
+          <a:xfrm>
+            <a:off x="7770114" y="4233672"/>
+            <a:ext cx="889253" cy="201168"/>
+          </a:xfrm>
+          <a:prstGeom prst="rect">
+            <a:avLst/>
+          </a:prstGeom>
+          <a:noFill/>
+        </p:spPr>
+        <p:txBody>
+          <a:bodyPr wrap="square" lIns="0" rIns="0" tIns="0" bIns="0" anchor="t">
+            <a:spAutoFit/>
+          </a:bodyPr>
+          <a:lstStyle/>
+          <a:p>
+            <a:pPr algn="l"/>
+            <a:r>
+              <a:rPr sz="1000" b="1">
+                <a:solidFill>
+                  <a:srgbClr val="1C2127"/>
+                </a:solidFill>
+                <a:latin typeface="Calibri"/>
+              </a:rPr>
+              <a:t>Render</a:t>
+            </a:r>
+          </a:p>
+        </p:txBody>
+      </p:sp>
+      <p:sp>
+        <p:nvSpPr>
+          <p:cNvPr id="58" name="TextBox 57"/>
+          <p:cNvSpPr txBox="1"/>
+          <p:nvPr/>
+        </p:nvSpPr>
+        <p:spPr>
+          <a:xfrm>
+            <a:off x="7770114" y="4434840"/>
+            <a:ext cx="889253" cy="182880"/>
+          </a:xfrm>
+          <a:prstGeom prst="rect">
+            <a:avLst/>
+          </a:prstGeom>
+          <a:noFill/>
+        </p:spPr>
+        <p:txBody>
+          <a:bodyPr wrap="square" lIns="0" rIns="0" tIns="0" bIns="0" anchor="t">
+            <a:spAutoFit/>
+          </a:bodyPr>
+          <a:lstStyle/>
+          <a:p>
+            <a:pPr algn="l"/>
+            <a:r>
+              <a:rPr sz="800" b="0">
+                <a:solidFill>
+                  <a:srgbClr val="2F343C"/>
+                </a:solidFill>
+                <a:latin typeface="Calibri"/>
+              </a:rPr>
+              <a:t>STTM + contract</a:t>
+            </a:r>
+          </a:p>
+        </p:txBody>
+      </p:sp>
+      <p:pic>
+        <p:nvPicPr>
+          <p:cNvPr id="59" name="Picture 58" descr="claude.png"/>
+          <p:cNvPicPr>
+            <a:picLocks noChangeAspect="1"/>
+          </p:cNvPicPr>
+          <p:nvPr/>
+        </p:nvPicPr>
+        <p:blipFill>
+          <a:blip r:embed="rId9"/>
+          <a:stretch>
+            <a:fillRect/>
+          </a:stretch>
+        </p:blipFill>
+        <p:spPr>
+          <a:xfrm>
+            <a:off x="4187952" y="4757576"/>
+            <a:ext cx="868680" cy="186630"/>
+          </a:xfrm>
+          <a:prstGeom prst="rect">
+            <a:avLst/>
+          </a:prstGeom>
+        </p:spPr>
+      </p:pic>
+      <p:sp>
+        <p:nvSpPr>
+          <p:cNvPr id="60" name="TextBox 59"/>
+          <p:cNvSpPr txBox="1"/>
+          <p:nvPr/>
+        </p:nvSpPr>
+        <p:spPr>
+          <a:xfrm>
+            <a:off x="5138928" y="4736592"/>
+            <a:ext cx="3611879" cy="237744"/>
+          </a:xfrm>
+          <a:prstGeom prst="rect">
+            <a:avLst/>
+          </a:prstGeom>
+          <a:noFill/>
+        </p:spPr>
+        <p:txBody>
+          <a:bodyPr wrap="square" lIns="0" rIns="0" tIns="0" bIns="0" anchor="t">
+            <a:spAutoFit/>
+          </a:bodyPr>
+          <a:lstStyle/>
+          <a:p>
+            <a:pPr algn="l"/>
+            <a:r>
+              <a:rPr sz="850" b="0">
+                <a:solidFill>
+                  <a:srgbClr val="2F343C"/>
+                </a:solidFill>
+                <a:latin typeface="Calibri"/>
+              </a:rPr>
+              <a:t>Anthropic API — one call per document, in stage 02; everything else is deterministic code.</a:t>
+            </a:r>
+          </a:p>
+        </p:txBody>
+      </p:sp>
+      <p:sp>
+        <p:nvSpPr>
           <p:cNvPr id="61" name="Rounded Rectangle 60"/>
           <p:cNvSpPr/>
           <p:nvPr/>
         </p:nvSpPr>
         <p:spPr>
           <a:xfrm>
-            <a:off x="6080760" y="3904487"/>
-            <a:ext cx="461771" cy="457200"/>
+            <a:off x="9098280" y="3566160"/>
+            <a:ext cx="2316175" cy="1463040"/>
           </a:xfrm>
           <a:prstGeom prst="roundRect">
             <a:avLst>
-              <a:gd name="adj" fmla="val 10000"/>
+              <a:gd name="adj" fmla="val 4000"/>
             </a:avLst>
           </a:prstGeom>
           <a:solidFill>
@@ -5332,8 +5350,8 @@
         </p:nvSpPr>
         <p:spPr>
           <a:xfrm>
-            <a:off x="6080760" y="3968496"/>
-            <a:ext cx="461771" cy="164592"/>
+            <a:off x="9262872" y="3675887"/>
+            <a:ext cx="1986991" cy="237744"/>
           </a:xfrm>
           <a:prstGeom prst="rect">
             <a:avLst/>
@@ -5346,29 +5364,86 @@
           </a:bodyPr>
           <a:lstStyle/>
           <a:p>
-            <a:pPr algn="ctr"/>
-            <a:r>
-              <a:rPr sz="850" b="1">
-                <a:solidFill>
-                  <a:srgbClr val="007067"/>
-                </a:solidFill>
-                <a:latin typeface="Consolas"/>
+            <a:pPr algn="l"/>
+            <a:r>
+              <a:rPr sz="1200" b="1">
+                <a:solidFill>
+                  <a:srgbClr val="1C2127"/>
+                </a:solidFill>
+                <a:latin typeface="Calibri"/>
               </a:rPr>
-              <a:t>03</a:t>
-            </a:r>
-          </a:p>
-        </p:txBody>
-      </p:sp>
-      <p:sp>
-        <p:nvSpPr>
-          <p:cNvPr id="63" name="TextBox 62"/>
+              <a:t>Review app</a:t>
+            </a:r>
+            <a:r>
+              <a:rPr sz="950" b="0">
+                <a:solidFill>
+                  <a:srgbClr val="2F343C"/>
+                </a:solidFill>
+                <a:latin typeface="Calibri"/>
+              </a:rPr>
+              <a:t>   Databricks Apps</a:t>
+            </a:r>
+          </a:p>
+        </p:txBody>
+      </p:sp>
+      <p:pic>
+        <p:nvPicPr>
+          <p:cNvPr id="63" name="Picture 62" descr="fastapi.png"/>
+          <p:cNvPicPr>
+            <a:picLocks noChangeAspect="1"/>
+          </p:cNvPicPr>
+          <p:nvPr/>
+        </p:nvPicPr>
+        <p:blipFill>
+          <a:blip r:embed="rId10"/>
+          <a:stretch>
+            <a:fillRect/>
+          </a:stretch>
+        </p:blipFill>
+        <p:spPr>
+          <a:xfrm>
+            <a:off x="9262872" y="4028976"/>
+            <a:ext cx="777240" cy="144214"/>
+          </a:xfrm>
+          <a:prstGeom prst="rect">
+            <a:avLst/>
+          </a:prstGeom>
+        </p:spPr>
+      </p:pic>
+      <p:pic>
+        <p:nvPicPr>
+          <p:cNvPr id="64" name="Picture 63" descr="react.png"/>
+          <p:cNvPicPr>
+            <a:picLocks noChangeAspect="1"/>
+          </p:cNvPicPr>
+          <p:nvPr/>
+        </p:nvPicPr>
+        <p:blipFill>
+          <a:blip r:embed="rId11"/>
+          <a:stretch>
+            <a:fillRect/>
+          </a:stretch>
+        </p:blipFill>
+        <p:spPr>
+          <a:xfrm>
+            <a:off x="10122408" y="3982497"/>
+            <a:ext cx="256032" cy="228028"/>
+          </a:xfrm>
+          <a:prstGeom prst="rect">
+            <a:avLst/>
+          </a:prstGeom>
+        </p:spPr>
+      </p:pic>
+      <p:sp>
+        <p:nvSpPr>
+          <p:cNvPr id="65" name="TextBox 64"/>
           <p:cNvSpPr txBox="1"/>
           <p:nvPr/>
         </p:nvSpPr>
         <p:spPr>
           <a:xfrm>
-            <a:off x="6080760" y="4123944"/>
-            <a:ext cx="461771" cy="201168"/>
+            <a:off x="9262872" y="4297680"/>
+            <a:ext cx="1986991" cy="640080"/>
           </a:xfrm>
           <a:prstGeom prst="rect">
             <a:avLst/>
@@ -5381,36 +5456,40 @@
           </a:bodyPr>
           <a:lstStyle/>
           <a:p>
-            <a:pPr algn="ctr"/>
-            <a:r>
-              <a:rPr sz="900" b="0">
-                <a:solidFill>
-                  <a:srgbClr val="1C2127"/>
+            <a:pPr algn="l">
+              <a:lnSpc>
+                <a:spcPct val="108000"/>
+              </a:lnSpc>
+            </a:pPr>
+            <a:r>
+              <a:rPr sz="950" b="0">
+                <a:solidFill>
+                  <a:srgbClr val="2F343C"/>
                 </a:solidFill>
                 <a:latin typeface="Calibri"/>
               </a:rPr>
-              <a:t>Audit</a:t>
+              <a:t>Pick an FRD · run (confirm-gated) · answer what the agent could not settle · re-render · download.</a:t>
             </a:r>
           </a:p>
         </p:txBody>
       </p:sp>
       <p:cxnSp>
         <p:nvCxnSpPr>
-          <p:cNvPr id="64" name="Connector 63"/>
+          <p:cNvPr id="66" name="Connector 65"/>
           <p:cNvCxnSpPr/>
           <p:nvPr/>
         </p:nvCxnSpPr>
         <p:spPr>
           <a:xfrm>
-            <a:off x="6551676" y="4133087"/>
-            <a:ext cx="73152" cy="0"/>
+            <a:off x="4389120" y="5184648"/>
+            <a:ext cx="0" cy="356616"/>
           </a:xfrm>
           <a:prstGeom prst="line">
             <a:avLst/>
           </a:prstGeom>
-          <a:ln w="9525">
+          <a:ln w="19050">
             <a:solidFill>
-              <a:srgbClr val="C5CBD3"/>
+              <a:srgbClr val="2F343C"/>
             </a:solidFill>
             <a:tailEnd type="triangle" w="sm" len="sm"/>
           </a:ln>
@@ -5432,26 +5511,61 @@
       </p:cxnSp>
       <p:sp>
         <p:nvSpPr>
-          <p:cNvPr id="65" name="Rounded Rectangle 64"/>
+          <p:cNvPr id="67" name="TextBox 66"/>
+          <p:cNvSpPr txBox="1"/>
+          <p:nvPr/>
+        </p:nvSpPr>
+        <p:spPr>
+          <a:xfrm>
+            <a:off x="4517136" y="5262372"/>
+            <a:ext cx="5486400" cy="201168"/>
+          </a:xfrm>
+          <a:prstGeom prst="rect">
+            <a:avLst/>
+          </a:prstGeom>
+          <a:noFill/>
+        </p:spPr>
+        <p:txBody>
+          <a:bodyPr wrap="square" lIns="0" rIns="0" tIns="0" bIns="0" anchor="t">
+            <a:spAutoFit/>
+          </a:bodyPr>
+          <a:lstStyle/>
+          <a:p>
+            <a:pPr algn="l"/>
+            <a:r>
+              <a:rPr sz="950" b="1">
+                <a:solidFill>
+                  <a:srgbClr val="2F343C"/>
+                </a:solidFill>
+                <a:latin typeface="Calibri"/>
+              </a:rPr>
+              <a:t>draft STTM  .xlsx  +  feed contract  .json   →   to a person</a:t>
+            </a:r>
+          </a:p>
+        </p:txBody>
+      </p:sp>
+      <p:sp>
+        <p:nvSpPr>
+          <p:cNvPr id="68" name="Rounded Rectangle 67"/>
           <p:cNvSpPr/>
           <p:nvPr/>
         </p:nvSpPr>
         <p:spPr>
           <a:xfrm>
-            <a:off x="6633972" y="3904487"/>
-            <a:ext cx="461771" cy="457200"/>
+            <a:off x="548640" y="5541264"/>
+            <a:ext cx="5212080" cy="841248"/>
           </a:xfrm>
           <a:prstGeom prst="roundRect">
             <a:avLst>
-              <a:gd name="adj" fmla="val 10000"/>
+              <a:gd name="adj" fmla="val 2500"/>
             </a:avLst>
           </a:prstGeom>
           <a:solidFill>
-            <a:srgbClr val="EDEFF2"/>
+            <a:srgbClr val="F6F7F9"/>
           </a:solidFill>
-          <a:ln w="9525">
+          <a:ln w="12700">
             <a:solidFill>
-              <a:srgbClr val="C5CBD3"/>
+              <a:srgbClr val="D1980B"/>
             </a:solidFill>
           </a:ln>
           <a:effectLst/>
@@ -5478,14 +5592,14 @@
       </p:sp>
       <p:sp>
         <p:nvSpPr>
-          <p:cNvPr id="66" name="TextBox 65"/>
+          <p:cNvPr id="69" name="TextBox 68"/>
           <p:cNvSpPr txBox="1"/>
           <p:nvPr/>
         </p:nvSpPr>
         <p:spPr>
           <a:xfrm>
-            <a:off x="6633972" y="3968496"/>
-            <a:ext cx="461771" cy="164592"/>
+            <a:off x="777240" y="5632703"/>
+            <a:ext cx="3657600" cy="201168"/>
           </a:xfrm>
           <a:prstGeom prst="rect">
             <a:avLst/>
@@ -5498,29 +5612,53 @@
           </a:bodyPr>
           <a:lstStyle/>
           <a:p>
-            <a:pPr algn="ctr"/>
-            <a:r>
-              <a:rPr sz="850" b="1">
-                <a:solidFill>
-                  <a:srgbClr val="007067"/>
-                </a:solidFill>
-                <a:latin typeface="Consolas"/>
+            <a:pPr algn="l"/>
+            <a:r>
+              <a:rPr sz="900" b="1" spc="140">
+                <a:solidFill>
+                  <a:srgbClr val="866103"/>
+                </a:solidFill>
+                <a:latin typeface="Calibri"/>
               </a:rPr>
-              <a:t>04</a:t>
-            </a:r>
-          </a:p>
-        </p:txBody>
-      </p:sp>
-      <p:sp>
-        <p:nvSpPr>
-          <p:cNvPr id="67" name="TextBox 66"/>
+              <a:t>HUMAN REVIEW</a:t>
+            </a:r>
+          </a:p>
+        </p:txBody>
+      </p:sp>
+      <p:pic>
+        <p:nvPicPr>
+          <p:cNvPr id="70" name="Picture 69" descr="user.png"/>
+          <p:cNvPicPr>
+            <a:picLocks noChangeAspect="1"/>
+          </p:cNvPicPr>
+          <p:nvPr/>
+        </p:nvPicPr>
+        <p:blipFill>
+          <a:blip r:embed="rId12"/>
+          <a:stretch>
+            <a:fillRect/>
+          </a:stretch>
+        </p:blipFill>
+        <p:spPr>
+          <a:xfrm>
+            <a:off x="777240" y="5907024"/>
+            <a:ext cx="384048" cy="384048"/>
+          </a:xfrm>
+          <a:prstGeom prst="rect">
+            <a:avLst/>
+          </a:prstGeom>
+        </p:spPr>
+      </p:pic>
+      <p:sp>
+        <p:nvSpPr>
+          <p:cNvPr id="71" name="TextBox 70"/>
           <p:cNvSpPr txBox="1"/>
           <p:nvPr/>
         </p:nvSpPr>
         <p:spPr>
           <a:xfrm>
-            <a:off x="6633972" y="4123944"/>
-            <a:ext cx="461771" cy="201168"/>
+            <a:off x="1325880" y="5870448"/>
+            <a:ext cx="4251960" cy="502920"/>
           </a:xfrm>
           <a:prstGeom prst="rect">
             <a:avLst/>
@@ -5533,29 +5671,79 @@
           </a:bodyPr>
           <a:lstStyle/>
           <a:p>
-            <a:pPr algn="ctr"/>
-            <a:r>
-              <a:rPr sz="900" b="0">
-                <a:solidFill>
-                  <a:srgbClr val="1C2127"/>
+            <a:pPr algn="l">
+              <a:lnSpc>
+                <a:spcPct val="105000"/>
+              </a:lnSpc>
+            </a:pPr>
+            <a:r>
+              <a:rPr sz="1000" b="0">
+                <a:solidFill>
+                  <a:srgbClr val="2F343C"/>
                 </a:solidFill>
                 <a:latin typeface="Calibri"/>
               </a:rPr>
-              <a:t>Render</a:t>
-            </a:r>
-          </a:p>
-        </p:txBody>
-      </p:sp>
-      <p:sp>
-        <p:nvSpPr>
-          <p:cNvPr id="68" name="TextBox 67"/>
+              <a:t>The reviewer approves the STTM (edits in Excel if needed) and uploads it to SharePoint themselves. The next sync pairs it — it becomes a template.</a:t>
+            </a:r>
+          </a:p>
+        </p:txBody>
+      </p:sp>
+      <p:sp>
+        <p:nvSpPr>
+          <p:cNvPr id="72" name="Rounded Rectangle 71"/>
+          <p:cNvSpPr/>
+          <p:nvPr/>
+        </p:nvSpPr>
+        <p:spPr>
+          <a:xfrm>
+            <a:off x="5989320" y="5541264"/>
+            <a:ext cx="5653735" cy="841248"/>
+          </a:xfrm>
+          <a:prstGeom prst="roundRect">
+            <a:avLst>
+              <a:gd name="adj" fmla="val 2500"/>
+            </a:avLst>
+          </a:prstGeom>
+          <a:solidFill>
+            <a:srgbClr val="F6F7F9"/>
+          </a:solidFill>
+          <a:ln w="12700">
+            <a:solidFill>
+              <a:srgbClr val="7961DB"/>
+            </a:solidFill>
+          </a:ln>
+          <a:effectLst/>
+        </p:spPr>
+        <p:style>
+          <a:lnRef idx="1">
+            <a:schemeClr val="accent1"/>
+          </a:lnRef>
+          <a:fillRef idx="3">
+            <a:schemeClr val="accent1"/>
+          </a:fillRef>
+          <a:effectRef idx="2">
+            <a:schemeClr val="accent1"/>
+          </a:effectRef>
+          <a:fontRef idx="minor">
+            <a:schemeClr val="lt1"/>
+          </a:fontRef>
+        </p:style>
+        <p:txBody>
+          <a:bodyPr rtlCol="0" anchor="ctr"/>
+          <a:lstStyle/>
+          <a:p/>
+        </p:txBody>
+      </p:sp>
+      <p:sp>
+        <p:nvSpPr>
+          <p:cNvPr id="73" name="TextBox 72"/>
           <p:cNvSpPr txBox="1"/>
           <p:nvPr/>
         </p:nvSpPr>
         <p:spPr>
           <a:xfrm>
-            <a:off x="4974336" y="4453127"/>
-            <a:ext cx="2121408" cy="219456"/>
+            <a:off x="6217920" y="5632703"/>
+            <a:ext cx="3657600" cy="201168"/>
           </a:xfrm>
           <a:prstGeom prst="rect">
             <a:avLst/>
@@ -5568,38 +5756,287 @@
           </a:bodyPr>
           <a:lstStyle/>
           <a:p>
-            <a:pPr algn="ctr"/>
-            <a:r>
-              <a:rPr sz="950" b="0">
-                <a:solidFill>
-                  <a:srgbClr val="A04D2C"/>
+            <a:pPr algn="l"/>
+            <a:r>
+              <a:rPr sz="900" b="1" spc="140">
+                <a:solidFill>
+                  <a:srgbClr val="5642A6"/>
                 </a:solidFill>
                 <a:latin typeface="Calibri"/>
               </a:rPr>
-              <a:t>02 is the only model call</a:t>
+              <a:t>OUTPUTS · DOWNSTREAM</a:t>
+            </a:r>
+          </a:p>
+        </p:txBody>
+      </p:sp>
+      <p:pic>
+        <p:nvPicPr>
+          <p:cNvPr id="74" name="Picture 73" descr="excel.png"/>
+          <p:cNvPicPr>
+            <a:picLocks noChangeAspect="1"/>
+          </p:cNvPicPr>
+          <p:nvPr/>
+        </p:nvPicPr>
+        <p:blipFill>
+          <a:blip r:embed="rId5"/>
+          <a:stretch>
+            <a:fillRect/>
+          </a:stretch>
+        </p:blipFill>
+        <p:spPr>
+          <a:xfrm>
+            <a:off x="6217920" y="5937527"/>
+            <a:ext cx="347472" cy="323040"/>
+          </a:xfrm>
+          <a:prstGeom prst="rect">
+            <a:avLst/>
+          </a:prstGeom>
+        </p:spPr>
+      </p:pic>
+      <p:sp>
+        <p:nvSpPr>
+          <p:cNvPr id="75" name="TextBox 74"/>
+          <p:cNvSpPr txBox="1"/>
+          <p:nvPr/>
+        </p:nvSpPr>
+        <p:spPr>
+          <a:xfrm>
+            <a:off x="6647688" y="5879592"/>
+            <a:ext cx="1554480" cy="457200"/>
+          </a:xfrm>
+          <a:prstGeom prst="rect">
+            <a:avLst/>
+          </a:prstGeom>
+          <a:noFill/>
+        </p:spPr>
+        <p:txBody>
+          <a:bodyPr wrap="square" lIns="0" rIns="0" tIns="0" bIns="0" anchor="t">
+            <a:spAutoFit/>
+          </a:bodyPr>
+          <a:lstStyle/>
+          <a:p>
+            <a:pPr algn="l">
+              <a:lnSpc>
+                <a:spcPct val="100000"/>
+              </a:lnSpc>
+            </a:pPr>
+            <a:r>
+              <a:rPr sz="950" b="1">
+                <a:solidFill>
+                  <a:srgbClr val="1C2127"/>
+                </a:solidFill>
+                <a:latin typeface="Calibri"/>
+              </a:rPr>
+              <a:t>STTM workbook</a:t>
+            </a:r>
+          </a:p>
+          <a:p>
+            <a:pPr algn="l">
+              <a:lnSpc>
+                <a:spcPct val="100000"/>
+              </a:lnSpc>
+            </a:pPr>
+            <a:r>
+              <a:rPr sz="950" b="0">
+                <a:solidFill>
+                  <a:srgbClr val="2F343C"/>
+                </a:solidFill>
+                <a:latin typeface="Calibri"/>
+              </a:rPr>
+              <a:t>.xlsx · client dialect</a:t>
+            </a:r>
+          </a:p>
+        </p:txBody>
+      </p:sp>
+      <p:pic>
+        <p:nvPicPr>
+          <p:cNvPr id="76" name="Picture 75" descr="json.png"/>
+          <p:cNvPicPr>
+            <a:picLocks noChangeAspect="1"/>
+          </p:cNvPicPr>
+          <p:nvPr/>
+        </p:nvPicPr>
+        <p:blipFill>
+          <a:blip r:embed="rId13"/>
+          <a:stretch>
+            <a:fillRect/>
+          </a:stretch>
+        </p:blipFill>
+        <p:spPr>
+          <a:xfrm>
+            <a:off x="8046720" y="5925312"/>
+            <a:ext cx="329184" cy="329184"/>
+          </a:xfrm>
+          <a:prstGeom prst="rect">
+            <a:avLst/>
+          </a:prstGeom>
+        </p:spPr>
+      </p:pic>
+      <p:sp>
+        <p:nvSpPr>
+          <p:cNvPr id="77" name="TextBox 76"/>
+          <p:cNvSpPr txBox="1"/>
+          <p:nvPr/>
+        </p:nvSpPr>
+        <p:spPr>
+          <a:xfrm>
+            <a:off x="8458200" y="5879592"/>
+            <a:ext cx="1600200" cy="457200"/>
+          </a:xfrm>
+          <a:prstGeom prst="rect">
+            <a:avLst/>
+          </a:prstGeom>
+          <a:noFill/>
+        </p:spPr>
+        <p:txBody>
+          <a:bodyPr wrap="square" lIns="0" rIns="0" tIns="0" bIns="0" anchor="t">
+            <a:spAutoFit/>
+          </a:bodyPr>
+          <a:lstStyle/>
+          <a:p>
+            <a:pPr algn="l">
+              <a:lnSpc>
+                <a:spcPct val="100000"/>
+              </a:lnSpc>
+            </a:pPr>
+            <a:r>
+              <a:rPr sz="950" b="1">
+                <a:solidFill>
+                  <a:srgbClr val="1C2127"/>
+                </a:solidFill>
+                <a:latin typeface="Calibri"/>
+              </a:rPr>
+              <a:t>Feed contract</a:t>
+            </a:r>
+          </a:p>
+          <a:p>
+            <a:pPr algn="l">
+              <a:lnSpc>
+                <a:spcPct val="100000"/>
+              </a:lnSpc>
+            </a:pPr>
+            <a:r>
+              <a:rPr sz="950" b="0">
+                <a:solidFill>
+                  <a:srgbClr val="2F343C"/>
+                </a:solidFill>
+                <a:latin typeface="Calibri"/>
+              </a:rPr>
+              <a:t>contract.json · machine-readable</a:t>
             </a:r>
           </a:p>
         </p:txBody>
       </p:sp>
       <p:cxnSp>
         <p:nvCxnSpPr>
-          <p:cNvPr id="69" name="Connector 68"/>
+          <p:cNvPr id="78" name="Connector 77"/>
           <p:cNvCxnSpPr/>
           <p:nvPr/>
         </p:nvCxnSpPr>
         <p:spPr>
           <a:xfrm>
-            <a:off x="2441448" y="2560320"/>
-            <a:ext cx="237744" cy="0"/>
+            <a:off x="10058400" y="6089903"/>
+            <a:ext cx="228600" cy="0"/>
           </a:xfrm>
           <a:prstGeom prst="line">
             <a:avLst/>
           </a:prstGeom>
           <a:ln w="15875">
             <a:solidFill>
-              <a:srgbClr val="2F343C"/>
+              <a:srgbClr val="7961DB"/>
             </a:solidFill>
             <a:tailEnd type="triangle" w="sm" len="sm"/>
+          </a:ln>
+        </p:spPr>
+        <p:style>
+          <a:lnRef idx="2">
+            <a:schemeClr val="accent1"/>
+          </a:lnRef>
+          <a:fillRef idx="0">
+            <a:schemeClr val="accent1"/>
+          </a:fillRef>
+          <a:effectRef idx="1">
+            <a:schemeClr val="accent1"/>
+          </a:effectRef>
+          <a:fontRef idx="minor">
+            <a:schemeClr val="tx1"/>
+          </a:fontRef>
+        </p:style>
+      </p:cxnSp>
+      <p:sp>
+        <p:nvSpPr>
+          <p:cNvPr id="79" name="TextBox 78"/>
+          <p:cNvSpPr txBox="1"/>
+          <p:nvPr/>
+        </p:nvSpPr>
+        <p:spPr>
+          <a:xfrm>
+            <a:off x="10378440" y="5879592"/>
+            <a:ext cx="1173175" cy="502920"/>
+          </a:xfrm>
+          <a:prstGeom prst="rect">
+            <a:avLst/>
+          </a:prstGeom>
+          <a:noFill/>
+        </p:spPr>
+        <p:txBody>
+          <a:bodyPr wrap="square" lIns="0" rIns="0" tIns="0" bIns="0" anchor="t">
+            <a:spAutoFit/>
+          </a:bodyPr>
+          <a:lstStyle/>
+          <a:p>
+            <a:pPr algn="l">
+              <a:lnSpc>
+                <a:spcPct val="100000"/>
+              </a:lnSpc>
+            </a:pPr>
+            <a:r>
+              <a:rPr sz="950" b="1">
+                <a:solidFill>
+                  <a:srgbClr val="5642A6"/>
+                </a:solidFill>
+                <a:latin typeface="Calibri"/>
+              </a:rPr>
+              <a:t>CodeGen agent</a:t>
+            </a:r>
+          </a:p>
+          <a:p>
+            <a:pPr algn="l">
+              <a:lnSpc>
+                <a:spcPct val="100000"/>
+              </a:lnSpc>
+            </a:pPr>
+            <a:r>
+              <a:rPr sz="950" b="1">
+                <a:solidFill>
+                  <a:srgbClr val="5642A6"/>
+                </a:solidFill>
+                <a:latin typeface="Calibri"/>
+              </a:rPr>
+              <a:t>Code Review agent</a:t>
+            </a:r>
+          </a:p>
+        </p:txBody>
+      </p:sp>
+      <p:cxnSp>
+        <p:nvCxnSpPr>
+          <p:cNvPr id="80" name="Connector 79"/>
+          <p:cNvCxnSpPr/>
+          <p:nvPr/>
+        </p:nvCxnSpPr>
+        <p:spPr>
+          <a:xfrm flipV="1">
+            <a:off x="1371600" y="5376672"/>
+            <a:ext cx="0" cy="164592"/>
+          </a:xfrm>
+          <a:prstGeom prst="line">
+            <a:avLst/>
+          </a:prstGeom>
+          <a:ln w="15875">
+            <a:solidFill>
+              <a:srgbClr val="D1980B"/>
+            </a:solidFill>
+            <a:prstDash val="dash"/>
           </a:ln>
         </p:spPr>
         <p:style>
@@ -5619,23 +6056,23 @@
       </p:cxnSp>
       <p:cxnSp>
         <p:nvCxnSpPr>
-          <p:cNvPr id="70" name="Connector 69"/>
+          <p:cNvPr id="81" name="Connector 80"/>
           <p:cNvCxnSpPr/>
           <p:nvPr/>
         </p:nvCxnSpPr>
         <p:spPr>
-          <a:xfrm>
-            <a:off x="4498848" y="2560320"/>
-            <a:ext cx="237744" cy="0"/>
+          <a:xfrm flipH="1">
+            <a:off x="347472" y="5376672"/>
+            <a:ext cx="1024128" cy="0"/>
           </a:xfrm>
           <a:prstGeom prst="line">
             <a:avLst/>
           </a:prstGeom>
           <a:ln w="15875">
             <a:solidFill>
-              <a:srgbClr val="2F343C"/>
+              <a:srgbClr val="D1980B"/>
             </a:solidFill>
-            <a:tailEnd type="triangle" w="sm" len="sm"/>
+            <a:prstDash val="dash"/>
           </a:ln>
         </p:spPr>
         <p:style>
@@ -5655,23 +6092,23 @@
       </p:cxnSp>
       <p:cxnSp>
         <p:nvCxnSpPr>
-          <p:cNvPr id="71" name="Connector 70"/>
+          <p:cNvPr id="82" name="Connector 81"/>
           <p:cNvCxnSpPr/>
           <p:nvPr/>
         </p:nvCxnSpPr>
         <p:spPr>
-          <a:xfrm>
-            <a:off x="7333488" y="2560320"/>
-            <a:ext cx="237744" cy="0"/>
+          <a:xfrm flipV="1">
+            <a:off x="347472" y="1883664"/>
+            <a:ext cx="0" cy="3493008"/>
           </a:xfrm>
           <a:prstGeom prst="line">
             <a:avLst/>
           </a:prstGeom>
           <a:ln w="15875">
             <a:solidFill>
-              <a:srgbClr val="2F343C"/>
+              <a:srgbClr val="D1980B"/>
             </a:solidFill>
-            <a:tailEnd type="triangle" w="sm" len="sm"/>
+            <a:prstDash val="dash"/>
           </a:ln>
         </p:spPr>
         <p:style>
@@ -5691,122 +6128,14 @@
       </p:cxnSp>
       <p:cxnSp>
         <p:nvCxnSpPr>
-          <p:cNvPr id="72" name="Connector 71"/>
+          <p:cNvPr id="83" name="Connector 82"/>
           <p:cNvCxnSpPr/>
           <p:nvPr/>
         </p:nvCxnSpPr>
         <p:spPr>
           <a:xfrm>
-            <a:off x="9299448" y="2560320"/>
-            <a:ext cx="237744" cy="0"/>
-          </a:xfrm>
-          <a:prstGeom prst="line">
-            <a:avLst/>
-          </a:prstGeom>
-          <a:ln w="15875">
-            <a:solidFill>
-              <a:srgbClr val="2F343C"/>
-            </a:solidFill>
-            <a:tailEnd type="triangle" w="sm" len="sm"/>
-          </a:ln>
-        </p:spPr>
-        <p:style>
-          <a:lnRef idx="2">
-            <a:schemeClr val="accent1"/>
-          </a:lnRef>
-          <a:fillRef idx="0">
-            <a:schemeClr val="accent1"/>
-          </a:fillRef>
-          <a:effectRef idx="1">
-            <a:schemeClr val="accent1"/>
-          </a:effectRef>
-          <a:fontRef idx="minor">
-            <a:schemeClr val="tx1"/>
-          </a:fontRef>
-        </p:style>
-      </p:cxnSp>
-      <p:cxnSp>
-        <p:nvCxnSpPr>
-          <p:cNvPr id="73" name="Connector 72"/>
-          <p:cNvCxnSpPr/>
-          <p:nvPr/>
-        </p:nvCxnSpPr>
-        <p:spPr>
-          <a:xfrm>
-            <a:off x="8229600" y="4800600"/>
-            <a:ext cx="0" cy="237744"/>
-          </a:xfrm>
-          <a:prstGeom prst="line">
-            <a:avLst/>
-          </a:prstGeom>
-          <a:ln w="15875">
-            <a:solidFill>
-              <a:srgbClr val="D1980B"/>
-            </a:solidFill>
-            <a:prstDash val="dash"/>
-          </a:ln>
-        </p:spPr>
-        <p:style>
-          <a:lnRef idx="2">
-            <a:schemeClr val="accent1"/>
-          </a:lnRef>
-          <a:fillRef idx="0">
-            <a:schemeClr val="accent1"/>
-          </a:fillRef>
-          <a:effectRef idx="1">
-            <a:schemeClr val="accent1"/>
-          </a:effectRef>
-          <a:fontRef idx="minor">
-            <a:schemeClr val="tx1"/>
-          </a:fontRef>
-        </p:style>
-      </p:cxnSp>
-      <p:cxnSp>
-        <p:nvCxnSpPr>
-          <p:cNvPr id="74" name="Connector 73"/>
-          <p:cNvCxnSpPr/>
-          <p:nvPr/>
-        </p:nvCxnSpPr>
-        <p:spPr>
-          <a:xfrm flipH="1">
-            <a:off x="1188719" y="5038344"/>
-            <a:ext cx="7040881" cy="0"/>
-          </a:xfrm>
-          <a:prstGeom prst="line">
-            <a:avLst/>
-          </a:prstGeom>
-          <a:ln w="15875">
-            <a:solidFill>
-              <a:srgbClr val="D1980B"/>
-            </a:solidFill>
-            <a:prstDash val="dash"/>
-          </a:ln>
-        </p:spPr>
-        <p:style>
-          <a:lnRef idx="2">
-            <a:schemeClr val="accent1"/>
-          </a:lnRef>
-          <a:fillRef idx="0">
-            <a:schemeClr val="accent1"/>
-          </a:fillRef>
-          <a:effectRef idx="1">
-            <a:schemeClr val="accent1"/>
-          </a:effectRef>
-          <a:fontRef idx="minor">
-            <a:schemeClr val="tx1"/>
-          </a:fontRef>
-        </p:style>
-      </p:cxnSp>
-      <p:cxnSp>
-        <p:nvCxnSpPr>
-          <p:cNvPr id="75" name="Connector 74"/>
-          <p:cNvCxnSpPr/>
-          <p:nvPr/>
-        </p:nvCxnSpPr>
-        <p:spPr>
-          <a:xfrm flipV="1">
-            <a:off x="1188719" y="4818888"/>
-            <a:ext cx="0" cy="219456"/>
+            <a:off x="347472" y="1883664"/>
+            <a:ext cx="182880" cy="0"/>
           </a:xfrm>
           <a:prstGeom prst="line">
             <a:avLst/>
@@ -5836,14 +6165,14 @@
       </p:cxnSp>
       <p:sp>
         <p:nvSpPr>
-          <p:cNvPr id="76" name="TextBox 75"/>
+          <p:cNvPr id="84" name="TextBox 83"/>
           <p:cNvSpPr txBox="1"/>
           <p:nvPr/>
         </p:nvSpPr>
         <p:spPr>
-          <a:xfrm>
-            <a:off x="1097280" y="5111496"/>
-            <a:ext cx="8778240" cy="237744"/>
+          <a:xfrm rot="16200000">
+            <a:off x="-877824" y="3602735"/>
+            <a:ext cx="2103120" cy="219456"/>
           </a:xfrm>
           <a:prstGeom prst="rect">
             <a:avLst/>
@@ -5858,62 +6187,27 @@
           <a:p>
             <a:pPr algn="ctr"/>
             <a:r>
-              <a:rPr sz="950" b="1">
+              <a:rPr sz="850" b="1">
                 <a:solidFill>
                   <a:srgbClr val="866103"/>
                 </a:solidFill>
                 <a:latin typeface="Calibri"/>
               </a:rPr>
-              <a:t>the reviewer uploads the approved STTM   →   the next sync pairs it   →   it becomes a template</a:t>
-            </a:r>
-          </a:p>
-        </p:txBody>
-      </p:sp>
-      <p:cxnSp>
-        <p:nvCxnSpPr>
-          <p:cNvPr id="77" name="Connector 76"/>
-          <p:cNvCxnSpPr/>
-          <p:nvPr/>
-        </p:nvCxnSpPr>
-        <p:spPr>
-          <a:xfrm>
-            <a:off x="548640" y="5760720"/>
-            <a:ext cx="11094415" cy="0"/>
-          </a:xfrm>
-          <a:prstGeom prst="line">
-            <a:avLst/>
-          </a:prstGeom>
-          <a:ln w="6350">
-            <a:solidFill>
-              <a:srgbClr val="D3D8DE"/>
-            </a:solidFill>
-          </a:ln>
-        </p:spPr>
-        <p:style>
-          <a:lnRef idx="2">
-            <a:schemeClr val="accent1"/>
-          </a:lnRef>
-          <a:fillRef idx="0">
-            <a:schemeClr val="accent1"/>
-          </a:fillRef>
-          <a:effectRef idx="1">
-            <a:schemeClr val="accent1"/>
-          </a:effectRef>
-          <a:fontRef idx="minor">
-            <a:schemeClr val="tx1"/>
-          </a:fontRef>
-        </p:style>
-      </p:cxnSp>
-      <p:sp>
-        <p:nvSpPr>
-          <p:cNvPr id="78" name="TextBox 77"/>
+              <a:t>approved STTM goes back</a:t>
+            </a:r>
+          </a:p>
+        </p:txBody>
+      </p:sp>
+      <p:sp>
+        <p:nvSpPr>
+          <p:cNvPr id="85" name="TextBox 84"/>
           <p:cNvSpPr txBox="1"/>
           <p:nvPr/>
         </p:nvSpPr>
         <p:spPr>
           <a:xfrm>
-            <a:off x="548640" y="5888736"/>
-            <a:ext cx="8686800" cy="310896"/>
+            <a:off x="548640" y="6510528"/>
+            <a:ext cx="7772400" cy="274320"/>
           </a:xfrm>
           <a:prstGeom prst="rect">
             <a:avLst/>
@@ -5928,7 +6222,7 @@
           <a:p>
             <a:pPr algn="l"/>
             <a:r>
-              <a:rPr sz="1200" b="1">
+              <a:rPr sz="1100" b="1">
                 <a:solidFill>
                   <a:srgbClr val="A04D2C"/>
                 </a:solidFill>
@@ -5937,16 +6231,16 @@
               <a:t>the model proposes</a:t>
             </a:r>
             <a:r>
-              <a:rPr sz="1200" b="0">
+              <a:rPr sz="1100" b="0">
                 <a:solidFill>
                   <a:srgbClr val="C5CBD3"/>
                 </a:solidFill>
                 <a:latin typeface="Calibri"/>
               </a:rPr>
-              <a:t>      ·      </a:t>
-            </a:r>
-            <a:r>
-              <a:rPr sz="1200" b="1">
+              <a:t>     ·     </a:t>
+            </a:r>
+            <a:r>
+              <a:rPr sz="1100" b="1">
                 <a:solidFill>
                   <a:srgbClr val="007067"/>
                 </a:solidFill>
@@ -5955,16 +6249,16 @@
               <a:t>deterministic code audits and decides</a:t>
             </a:r>
             <a:r>
-              <a:rPr sz="1200" b="0">
+              <a:rPr sz="1100" b="0">
                 <a:solidFill>
                   <a:srgbClr val="C5CBD3"/>
                 </a:solidFill>
                 <a:latin typeface="Calibri"/>
               </a:rPr>
-              <a:t>      ·      </a:t>
-            </a:r>
-            <a:r>
-              <a:rPr sz="1200" b="1">
+              <a:t>     ·     </a:t>
+            </a:r>
+            <a:r>
+              <a:rPr sz="1100" b="1">
                 <a:solidFill>
                   <a:srgbClr val="866103"/>
                 </a:solidFill>
@@ -5977,48 +6271,13 @@
       </p:sp>
       <p:sp>
         <p:nvSpPr>
-          <p:cNvPr id="79" name="TextBox 78"/>
+          <p:cNvPr id="86" name="TextBox 85"/>
           <p:cNvSpPr txBox="1"/>
           <p:nvPr/>
         </p:nvSpPr>
         <p:spPr>
           <a:xfrm>
-            <a:off x="548640" y="6217920"/>
-            <a:ext cx="11064240" cy="274320"/>
-          </a:xfrm>
-          <a:prstGeom prst="rect">
-            <a:avLst/>
-          </a:prstGeom>
-          <a:noFill/>
-        </p:spPr>
-        <p:txBody>
-          <a:bodyPr wrap="square" lIns="0" rIns="0" tIns="0" bIns="0" anchor="t">
-            <a:spAutoFit/>
-          </a:bodyPr>
-          <a:lstStyle/>
-          <a:p>
-            <a:pPr algn="l"/>
-            <a:r>
-              <a:rPr sz="1000" b="0">
-                <a:solidFill>
-                  <a:srgbClr val="2F343C"/>
-                </a:solidFill>
-                <a:latin typeface="Calibri"/>
-              </a:rPr>
-              <a:t>Grounding checks, gate status, pairing verdicts, template choice and eval scores are computed in code, never by the model. Fail loud — no silent mock, no silent live, no stale copies.</a:t>
-            </a:r>
-          </a:p>
-        </p:txBody>
-      </p:sp>
-      <p:sp>
-        <p:nvSpPr>
-          <p:cNvPr id="80" name="TextBox 79"/>
-          <p:cNvSpPr txBox="1"/>
-          <p:nvPr/>
-        </p:nvSpPr>
-        <p:spPr>
-          <a:xfrm>
-            <a:off x="7253935" y="5943600"/>
+            <a:off x="7253935" y="6547104"/>
             <a:ext cx="4389120" cy="201168"/>
           </a:xfrm>
           <a:prstGeom prst="rect">

</xml_diff>

<commit_message>
context: one-slide architecture v5.1 — 'solution architecture'; drop AI-IN-ENGINEERING, the subtitle and the version tag; pad logos so PowerPoint cannot clip them
Co-Authored-By: Claude Fable 5 <noreply@anthropic.com>
</commit_message>
<xml_diff>
--- a/context/FRD_to_STTM_Agent_System_Architecture.pptx
+++ b/context/FRD_to_STTM_Agent_System_Architecture.pptx
@@ -3422,7 +3422,7 @@
                 </a:solidFill>
                 <a:latin typeface="Calibri"/>
               </a:rPr>
-              <a:t>HEXAWARE  ·  AMERIHEALTH CARITAS  ·  AI-IN-ENGINEERING  ·  AGENT 01 / 03</a:t>
+              <a:t>HEXAWARE  ·  AMERIHEALTH CARITAS  ·  AGENT 01 / 03</a:t>
             </a:r>
           </a:p>
         </p:txBody>
@@ -3435,7 +3435,7 @@
         </p:nvSpPr>
         <p:spPr>
           <a:xfrm>
-            <a:off x="548640" y="548640"/>
+            <a:off x="548640" y="566928"/>
             <a:ext cx="8686800" cy="502920"/>
           </a:xfrm>
           <a:prstGeom prst="rect">
@@ -3466,49 +3466,14 @@
                 </a:solidFill>
                 <a:latin typeface="Calibri"/>
               </a:rPr>
-              <a:t>    system architecture</a:t>
-            </a:r>
-          </a:p>
-        </p:txBody>
-      </p:sp>
-      <p:sp>
-        <p:nvSpPr>
-          <p:cNvPr id="13" name="TextBox 12"/>
-          <p:cNvSpPr txBox="1"/>
-          <p:nvPr/>
-        </p:nvSpPr>
-        <p:spPr>
-          <a:xfrm>
-            <a:off x="548640" y="1024128"/>
-            <a:ext cx="11064240" cy="237744"/>
-          </a:xfrm>
-          <a:prstGeom prst="rect">
-            <a:avLst/>
-          </a:prstGeom>
-          <a:noFill/>
-        </p:spPr>
-        <p:txBody>
-          <a:bodyPr wrap="square" lIns="0" rIns="0" tIns="0" bIns="0" anchor="t">
-            <a:spAutoFit/>
-          </a:bodyPr>
-          <a:lstStyle/>
-          <a:p>
-            <a:pPr algn="l"/>
-            <a:r>
-              <a:rPr sz="1150" b="0">
-                <a:solidFill>
-                  <a:srgbClr val="2F343C"/>
-                </a:solidFill>
-                <a:latin typeface="Calibri"/>
-              </a:rPr>
-              <a:t>Top to bottom: the technologies the agent runs on, and what flows between them — FRD in, audited STTM and contract out, a person in the loop.</a:t>
-            </a:r>
-          </a:p>
-        </p:txBody>
-      </p:sp>
-      <p:sp>
-        <p:nvSpPr>
-          <p:cNvPr id="14" name="Rounded Rectangle 13"/>
+              <a:t>    solution architecture</a:t>
+            </a:r>
+          </a:p>
+        </p:txBody>
+      </p:sp>
+      <p:sp>
+        <p:nvSpPr>
+          <p:cNvPr id="13" name="Rounded Rectangle 12"/>
           <p:cNvSpPr/>
           <p:nvPr/>
         </p:nvSpPr>
@@ -3554,7 +3519,7 @@
       </p:sp>
       <p:sp>
         <p:nvSpPr>
-          <p:cNvPr id="15" name="TextBox 14"/>
+          <p:cNvPr id="14" name="TextBox 13"/>
           <p:cNvSpPr txBox="1"/>
           <p:nvPr/>
         </p:nvSpPr>
@@ -3589,7 +3554,7 @@
       </p:sp>
       <p:pic>
         <p:nvPicPr>
-          <p:cNvPr id="16" name="Picture 15" descr="sharepoint.png"/>
+          <p:cNvPr id="15" name="Picture 14" descr="sharepoint.png"/>
           <p:cNvPicPr>
             <a:picLocks noChangeAspect="1"/>
           </p:cNvPicPr>
@@ -3603,8 +3568,8 @@
         </p:blipFill>
         <p:spPr>
           <a:xfrm>
-            <a:off x="777240" y="1743789"/>
-            <a:ext cx="548640" cy="535781"/>
+            <a:off x="777240" y="1743075"/>
+            <a:ext cx="548640" cy="537210"/>
           </a:xfrm>
           <a:prstGeom prst="rect">
             <a:avLst/>
@@ -3613,7 +3578,7 @@
       </p:pic>
       <p:sp>
         <p:nvSpPr>
-          <p:cNvPr id="17" name="TextBox 16"/>
+          <p:cNvPr id="16" name="TextBox 15"/>
           <p:cNvSpPr txBox="1"/>
           <p:nvPr/>
         </p:nvSpPr>
@@ -3648,7 +3613,7 @@
       </p:sp>
       <p:sp>
         <p:nvSpPr>
-          <p:cNvPr id="18" name="TextBox 17"/>
+          <p:cNvPr id="17" name="TextBox 16"/>
           <p:cNvSpPr txBox="1"/>
           <p:nvPr/>
         </p:nvSpPr>
@@ -3683,7 +3648,7 @@
       </p:sp>
       <p:sp>
         <p:nvSpPr>
-          <p:cNvPr id="19" name="Rounded Rectangle 18"/>
+          <p:cNvPr id="18" name="Rounded Rectangle 17"/>
           <p:cNvSpPr/>
           <p:nvPr/>
         </p:nvSpPr>
@@ -3729,7 +3694,7 @@
       </p:sp>
       <p:pic>
         <p:nvPicPr>
-          <p:cNvPr id="20" name="Picture 19" descr="word.png"/>
+          <p:cNvPr id="19" name="Picture 18" descr="word.png"/>
           <p:cNvPicPr>
             <a:picLocks noChangeAspect="1"/>
           </p:cNvPicPr>
@@ -3743,8 +3708,8 @@
         </p:blipFill>
         <p:spPr>
           <a:xfrm>
-            <a:off x="5093207" y="1795295"/>
-            <a:ext cx="347472" cy="323040"/>
+            <a:off x="5093207" y="1795145"/>
+            <a:ext cx="347472" cy="323342"/>
           </a:xfrm>
           <a:prstGeom prst="rect">
             <a:avLst/>
@@ -3753,7 +3718,7 @@
       </p:pic>
       <p:sp>
         <p:nvSpPr>
-          <p:cNvPr id="21" name="TextBox 20"/>
+          <p:cNvPr id="20" name="TextBox 19"/>
           <p:cNvSpPr txBox="1"/>
           <p:nvPr/>
         </p:nvSpPr>
@@ -3788,7 +3753,7 @@
       </p:sp>
       <p:sp>
         <p:nvSpPr>
-          <p:cNvPr id="22" name="TextBox 21"/>
+          <p:cNvPr id="21" name="TextBox 20"/>
           <p:cNvSpPr txBox="1"/>
           <p:nvPr/>
         </p:nvSpPr>
@@ -3823,7 +3788,7 @@
       </p:sp>
       <p:sp>
         <p:nvSpPr>
-          <p:cNvPr id="23" name="Rounded Rectangle 22"/>
+          <p:cNvPr id="22" name="Rounded Rectangle 21"/>
           <p:cNvSpPr/>
           <p:nvPr/>
         </p:nvSpPr>
@@ -3869,7 +3834,7 @@
       </p:sp>
       <p:pic>
         <p:nvPicPr>
-          <p:cNvPr id="24" name="Picture 23" descr="excel.png"/>
+          <p:cNvPr id="23" name="Picture 22" descr="excel.png"/>
           <p:cNvPicPr>
             <a:picLocks noChangeAspect="1"/>
           </p:cNvPicPr>
@@ -3883,8 +3848,8 @@
         </p:blipFill>
         <p:spPr>
           <a:xfrm>
-            <a:off x="7607807" y="1795295"/>
-            <a:ext cx="347472" cy="323040"/>
+            <a:off x="7607807" y="1795145"/>
+            <a:ext cx="347472" cy="323342"/>
           </a:xfrm>
           <a:prstGeom prst="rect">
             <a:avLst/>
@@ -3893,7 +3858,7 @@
       </p:pic>
       <p:sp>
         <p:nvSpPr>
-          <p:cNvPr id="25" name="TextBox 24"/>
+          <p:cNvPr id="24" name="TextBox 23"/>
           <p:cNvSpPr txBox="1"/>
           <p:nvPr/>
         </p:nvSpPr>
@@ -3928,7 +3893,7 @@
       </p:sp>
       <p:sp>
         <p:nvSpPr>
-          <p:cNvPr id="26" name="TextBox 25"/>
+          <p:cNvPr id="25" name="TextBox 24"/>
           <p:cNvSpPr txBox="1"/>
           <p:nvPr/>
         </p:nvSpPr>
@@ -3963,7 +3928,7 @@
       </p:sp>
       <p:pic>
         <p:nvPicPr>
-          <p:cNvPr id="27" name="Picture 26" descr="entra.png"/>
+          <p:cNvPr id="26" name="Picture 25" descr="entra.png"/>
           <p:cNvPicPr>
             <a:picLocks noChangeAspect="1"/>
           </p:cNvPicPr>
@@ -3977,8 +3942,8 @@
         </p:blipFill>
         <p:spPr>
           <a:xfrm>
-            <a:off x="10104119" y="1762363"/>
-            <a:ext cx="457200" cy="407193"/>
+            <a:off x="10104119" y="1761966"/>
+            <a:ext cx="457200" cy="407987"/>
           </a:xfrm>
           <a:prstGeom prst="rect">
             <a:avLst/>
@@ -3987,7 +3952,7 @@
       </p:pic>
       <p:sp>
         <p:nvSpPr>
-          <p:cNvPr id="28" name="TextBox 27"/>
+          <p:cNvPr id="27" name="TextBox 26"/>
           <p:cNvSpPr txBox="1"/>
           <p:nvPr/>
         </p:nvSpPr>
@@ -4058,7 +4023,7 @@
       </p:sp>
       <p:cxnSp>
         <p:nvCxnSpPr>
-          <p:cNvPr id="29" name="Connector 28"/>
+          <p:cNvPr id="28" name="Connector 27"/>
           <p:cNvCxnSpPr/>
           <p:nvPr/>
         </p:nvCxnSpPr>
@@ -4094,7 +4059,7 @@
       </p:cxnSp>
       <p:sp>
         <p:nvSpPr>
-          <p:cNvPr id="30" name="TextBox 29"/>
+          <p:cNvPr id="29" name="TextBox 28"/>
           <p:cNvSpPr txBox="1"/>
           <p:nvPr/>
         </p:nvSpPr>
@@ -4129,7 +4094,7 @@
       </p:sp>
       <p:sp>
         <p:nvSpPr>
-          <p:cNvPr id="31" name="Rounded Rectangle 30"/>
+          <p:cNvPr id="30" name="Rounded Rectangle 29"/>
           <p:cNvSpPr/>
           <p:nvPr/>
         </p:nvSpPr>
@@ -4175,7 +4140,7 @@
       </p:sp>
       <p:sp>
         <p:nvSpPr>
-          <p:cNvPr id="32" name="TextBox 31"/>
+          <p:cNvPr id="31" name="TextBox 30"/>
           <p:cNvSpPr txBox="1"/>
           <p:nvPr/>
         </p:nvSpPr>
@@ -4210,7 +4175,7 @@
       </p:sp>
       <p:pic>
         <p:nvPicPr>
-          <p:cNvPr id="33" name="Picture 32" descr="databricks.png"/>
+          <p:cNvPr id="32" name="Picture 31" descr="databricks.png"/>
           <p:cNvPicPr>
             <a:picLocks noChangeAspect="1"/>
           </p:cNvPicPr>
@@ -4224,8 +4189,8 @@
         </p:blipFill>
         <p:spPr>
           <a:xfrm>
-            <a:off x="1112402" y="3099815"/>
-            <a:ext cx="655554" cy="365760"/>
+            <a:off x="1071020" y="3063239"/>
+            <a:ext cx="784039" cy="438912"/>
           </a:xfrm>
           <a:prstGeom prst="rect">
             <a:avLst/>
@@ -4234,7 +4199,7 @@
       </p:pic>
       <p:sp>
         <p:nvSpPr>
-          <p:cNvPr id="34" name="TextBox 33"/>
+          <p:cNvPr id="33" name="TextBox 32"/>
           <p:cNvSpPr txBox="1"/>
           <p:nvPr/>
         </p:nvSpPr>
@@ -4278,7 +4243,7 @@
       </p:sp>
       <p:sp>
         <p:nvSpPr>
-          <p:cNvPr id="35" name="Rounded Rectangle 34"/>
+          <p:cNvPr id="34" name="Rounded Rectangle 33"/>
           <p:cNvSpPr/>
           <p:nvPr/>
         </p:nvSpPr>
@@ -4324,7 +4289,7 @@
       </p:sp>
       <p:pic>
         <p:nvPicPr>
-          <p:cNvPr id="36" name="Picture 35" descr="unitycatalog.png"/>
+          <p:cNvPr id="35" name="Picture 34" descr="unitycatalog.png"/>
           <p:cNvPicPr>
             <a:picLocks noChangeAspect="1"/>
           </p:cNvPicPr>
@@ -4338,8 +4303,8 @@
         </p:blipFill>
         <p:spPr>
           <a:xfrm>
-            <a:off x="988278" y="3712463"/>
-            <a:ext cx="1232987" cy="420623"/>
+            <a:off x="989890" y="3712463"/>
+            <a:ext cx="1229763" cy="420624"/>
           </a:xfrm>
           <a:prstGeom prst="rect">
             <a:avLst/>
@@ -4348,7 +4313,7 @@
       </p:pic>
       <p:sp>
         <p:nvSpPr>
-          <p:cNvPr id="37" name="TextBox 36"/>
+          <p:cNvPr id="36" name="TextBox 35"/>
           <p:cNvSpPr txBox="1"/>
           <p:nvPr/>
         </p:nvSpPr>
@@ -4437,7 +4402,7 @@
       </p:sp>
       <p:sp>
         <p:nvSpPr>
-          <p:cNvPr id="38" name="Rounded Rectangle 37"/>
+          <p:cNvPr id="37" name="Rounded Rectangle 36"/>
           <p:cNvSpPr/>
           <p:nvPr/>
         </p:nvSpPr>
@@ -4483,7 +4448,7 @@
       </p:sp>
       <p:sp>
         <p:nvSpPr>
-          <p:cNvPr id="39" name="TextBox 38"/>
+          <p:cNvPr id="38" name="TextBox 37"/>
           <p:cNvSpPr txBox="1"/>
           <p:nvPr/>
         </p:nvSpPr>
@@ -4527,7 +4492,7 @@
       </p:sp>
       <p:sp>
         <p:nvSpPr>
-          <p:cNvPr id="40" name="Rounded Rectangle 39"/>
+          <p:cNvPr id="39" name="Rounded Rectangle 38"/>
           <p:cNvSpPr/>
           <p:nvPr/>
         </p:nvSpPr>
@@ -4573,7 +4538,7 @@
       </p:sp>
       <p:sp>
         <p:nvSpPr>
-          <p:cNvPr id="41" name="TextBox 40"/>
+          <p:cNvPr id="40" name="TextBox 39"/>
           <p:cNvSpPr txBox="1"/>
           <p:nvPr/>
         </p:nvSpPr>
@@ -4608,7 +4573,7 @@
       </p:sp>
       <p:sp>
         <p:nvSpPr>
-          <p:cNvPr id="42" name="TextBox 41"/>
+          <p:cNvPr id="41" name="TextBox 40"/>
           <p:cNvSpPr txBox="1"/>
           <p:nvPr/>
         </p:nvSpPr>
@@ -4643,7 +4608,7 @@
       </p:sp>
       <p:sp>
         <p:nvSpPr>
-          <p:cNvPr id="43" name="TextBox 42"/>
+          <p:cNvPr id="42" name="TextBox 41"/>
           <p:cNvSpPr txBox="1"/>
           <p:nvPr/>
         </p:nvSpPr>
@@ -4678,7 +4643,7 @@
       </p:sp>
       <p:cxnSp>
         <p:nvCxnSpPr>
-          <p:cNvPr id="44" name="Connector 43"/>
+          <p:cNvPr id="43" name="Connector 42"/>
           <p:cNvCxnSpPr/>
           <p:nvPr/>
         </p:nvCxnSpPr>
@@ -4714,7 +4679,7 @@
       </p:cxnSp>
       <p:sp>
         <p:nvSpPr>
-          <p:cNvPr id="45" name="Rounded Rectangle 44"/>
+          <p:cNvPr id="44" name="Rounded Rectangle 43"/>
           <p:cNvSpPr/>
           <p:nvPr/>
         </p:nvSpPr>
@@ -4760,7 +4725,7 @@
       </p:sp>
       <p:sp>
         <p:nvSpPr>
-          <p:cNvPr id="46" name="TextBox 45"/>
+          <p:cNvPr id="45" name="TextBox 44"/>
           <p:cNvSpPr txBox="1"/>
           <p:nvPr/>
         </p:nvSpPr>
@@ -4795,7 +4760,7 @@
       </p:sp>
       <p:sp>
         <p:nvSpPr>
-          <p:cNvPr id="47" name="TextBox 46"/>
+          <p:cNvPr id="46" name="TextBox 45"/>
           <p:cNvSpPr txBox="1"/>
           <p:nvPr/>
         </p:nvSpPr>
@@ -4830,7 +4795,7 @@
       </p:sp>
       <p:sp>
         <p:nvSpPr>
-          <p:cNvPr id="48" name="TextBox 47"/>
+          <p:cNvPr id="47" name="TextBox 46"/>
           <p:cNvSpPr txBox="1"/>
           <p:nvPr/>
         </p:nvSpPr>
@@ -4865,7 +4830,7 @@
       </p:sp>
       <p:cxnSp>
         <p:nvCxnSpPr>
-          <p:cNvPr id="49" name="Connector 48"/>
+          <p:cNvPr id="48" name="Connector 47"/>
           <p:cNvCxnSpPr/>
           <p:nvPr/>
         </p:nvCxnSpPr>
@@ -4901,7 +4866,7 @@
       </p:cxnSp>
       <p:sp>
         <p:nvSpPr>
-          <p:cNvPr id="50" name="Rounded Rectangle 49"/>
+          <p:cNvPr id="49" name="Rounded Rectangle 48"/>
           <p:cNvSpPr/>
           <p:nvPr/>
         </p:nvSpPr>
@@ -4947,7 +4912,7 @@
       </p:sp>
       <p:sp>
         <p:nvSpPr>
-          <p:cNvPr id="51" name="TextBox 50"/>
+          <p:cNvPr id="50" name="TextBox 49"/>
           <p:cNvSpPr txBox="1"/>
           <p:nvPr/>
         </p:nvSpPr>
@@ -4982,7 +4947,7 @@
       </p:sp>
       <p:sp>
         <p:nvSpPr>
-          <p:cNvPr id="52" name="TextBox 51"/>
+          <p:cNvPr id="51" name="TextBox 50"/>
           <p:cNvSpPr txBox="1"/>
           <p:nvPr/>
         </p:nvSpPr>
@@ -5017,7 +4982,7 @@
       </p:sp>
       <p:sp>
         <p:nvSpPr>
-          <p:cNvPr id="53" name="TextBox 52"/>
+          <p:cNvPr id="52" name="TextBox 51"/>
           <p:cNvSpPr txBox="1"/>
           <p:nvPr/>
         </p:nvSpPr>
@@ -5052,7 +5017,7 @@
       </p:sp>
       <p:cxnSp>
         <p:nvCxnSpPr>
-          <p:cNvPr id="54" name="Connector 53"/>
+          <p:cNvPr id="53" name="Connector 52"/>
           <p:cNvCxnSpPr/>
           <p:nvPr/>
         </p:nvCxnSpPr>
@@ -5088,7 +5053,7 @@
       </p:cxnSp>
       <p:sp>
         <p:nvSpPr>
-          <p:cNvPr id="55" name="Rounded Rectangle 54"/>
+          <p:cNvPr id="54" name="Rounded Rectangle 53"/>
           <p:cNvSpPr/>
           <p:nvPr/>
         </p:nvSpPr>
@@ -5134,7 +5099,7 @@
       </p:sp>
       <p:sp>
         <p:nvSpPr>
-          <p:cNvPr id="56" name="TextBox 55"/>
+          <p:cNvPr id="55" name="TextBox 54"/>
           <p:cNvSpPr txBox="1"/>
           <p:nvPr/>
         </p:nvSpPr>
@@ -5169,7 +5134,7 @@
       </p:sp>
       <p:sp>
         <p:nvSpPr>
-          <p:cNvPr id="57" name="TextBox 56"/>
+          <p:cNvPr id="56" name="TextBox 55"/>
           <p:cNvSpPr txBox="1"/>
           <p:nvPr/>
         </p:nvSpPr>
@@ -5204,7 +5169,7 @@
       </p:sp>
       <p:sp>
         <p:nvSpPr>
-          <p:cNvPr id="58" name="TextBox 57"/>
+          <p:cNvPr id="57" name="TextBox 56"/>
           <p:cNvSpPr txBox="1"/>
           <p:nvPr/>
         </p:nvSpPr>
@@ -5239,7 +5204,7 @@
       </p:sp>
       <p:pic>
         <p:nvPicPr>
-          <p:cNvPr id="59" name="Picture 58" descr="claude.png"/>
+          <p:cNvPr id="58" name="Picture 57" descr="claude.png"/>
           <p:cNvPicPr>
             <a:picLocks noChangeAspect="1"/>
           </p:cNvPicPr>
@@ -5253,8 +5218,8 @@
         </p:blipFill>
         <p:spPr>
           <a:xfrm>
-            <a:off x="4187952" y="4757576"/>
-            <a:ext cx="868680" cy="186630"/>
+            <a:off x="4187952" y="4755451"/>
+            <a:ext cx="914400" cy="200025"/>
           </a:xfrm>
           <a:prstGeom prst="rect">
             <a:avLst/>
@@ -5263,7 +5228,7 @@
       </p:pic>
       <p:sp>
         <p:nvSpPr>
-          <p:cNvPr id="60" name="TextBox 59"/>
+          <p:cNvPr id="59" name="TextBox 58"/>
           <p:cNvSpPr txBox="1"/>
           <p:nvPr/>
         </p:nvSpPr>
@@ -5298,7 +5263,7 @@
       </p:sp>
       <p:sp>
         <p:nvSpPr>
-          <p:cNvPr id="61" name="Rounded Rectangle 60"/>
+          <p:cNvPr id="60" name="Rounded Rectangle 59"/>
           <p:cNvSpPr/>
           <p:nvPr/>
         </p:nvSpPr>
@@ -5344,7 +5309,7 @@
       </p:sp>
       <p:sp>
         <p:nvSpPr>
-          <p:cNvPr id="62" name="TextBox 61"/>
+          <p:cNvPr id="61" name="TextBox 60"/>
           <p:cNvSpPr txBox="1"/>
           <p:nvPr/>
         </p:nvSpPr>
@@ -5388,7 +5353,7 @@
       </p:sp>
       <p:pic>
         <p:nvPicPr>
-          <p:cNvPr id="63" name="Picture 62" descr="fastapi.png"/>
+          <p:cNvPr id="62" name="Picture 61" descr="fastapi.png"/>
           <p:cNvPicPr>
             <a:picLocks noChangeAspect="1"/>
           </p:cNvPicPr>
@@ -5402,8 +5367,8 @@
         </p:blipFill>
         <p:spPr>
           <a:xfrm>
-            <a:off x="9262872" y="4028976"/>
-            <a:ext cx="777240" cy="144214"/>
+            <a:off x="9262872" y="4027543"/>
+            <a:ext cx="777240" cy="147081"/>
           </a:xfrm>
           <a:prstGeom prst="rect">
             <a:avLst/>
@@ -5412,7 +5377,7 @@
       </p:pic>
       <p:pic>
         <p:nvPicPr>
-          <p:cNvPr id="64" name="Picture 63" descr="react.png"/>
+          <p:cNvPr id="63" name="Picture 62" descr="react.png"/>
           <p:cNvPicPr>
             <a:picLocks noChangeAspect="1"/>
           </p:cNvPicPr>
@@ -5426,8 +5391,8 @@
         </p:blipFill>
         <p:spPr>
           <a:xfrm>
-            <a:off x="10122408" y="3982497"/>
-            <a:ext cx="256032" cy="228028"/>
+            <a:off x="10122408" y="3982275"/>
+            <a:ext cx="256032" cy="228473"/>
           </a:xfrm>
           <a:prstGeom prst="rect">
             <a:avLst/>
@@ -5436,7 +5401,7 @@
       </p:pic>
       <p:sp>
         <p:nvSpPr>
-          <p:cNvPr id="65" name="TextBox 64"/>
+          <p:cNvPr id="64" name="TextBox 63"/>
           <p:cNvSpPr txBox="1"/>
           <p:nvPr/>
         </p:nvSpPr>
@@ -5475,7 +5440,7 @@
       </p:sp>
       <p:cxnSp>
         <p:nvCxnSpPr>
-          <p:cNvPr id="66" name="Connector 65"/>
+          <p:cNvPr id="65" name="Connector 64"/>
           <p:cNvCxnSpPr/>
           <p:nvPr/>
         </p:nvCxnSpPr>
@@ -5511,7 +5476,7 @@
       </p:cxnSp>
       <p:sp>
         <p:nvSpPr>
-          <p:cNvPr id="67" name="TextBox 66"/>
+          <p:cNvPr id="66" name="TextBox 65"/>
           <p:cNvSpPr txBox="1"/>
           <p:nvPr/>
         </p:nvSpPr>
@@ -5546,7 +5511,7 @@
       </p:sp>
       <p:sp>
         <p:nvSpPr>
-          <p:cNvPr id="68" name="Rounded Rectangle 67"/>
+          <p:cNvPr id="67" name="Rounded Rectangle 66"/>
           <p:cNvSpPr/>
           <p:nvPr/>
         </p:nvSpPr>
@@ -5592,7 +5557,7 @@
       </p:sp>
       <p:sp>
         <p:nvSpPr>
-          <p:cNvPr id="69" name="TextBox 68"/>
+          <p:cNvPr id="68" name="TextBox 67"/>
           <p:cNvSpPr txBox="1"/>
           <p:nvPr/>
         </p:nvSpPr>
@@ -5627,7 +5592,7 @@
       </p:sp>
       <p:pic>
         <p:nvPicPr>
-          <p:cNvPr id="70" name="Picture 69" descr="user.png"/>
+          <p:cNvPr id="69" name="Picture 68" descr="user.png"/>
           <p:cNvPicPr>
             <a:picLocks noChangeAspect="1"/>
           </p:cNvPicPr>
@@ -5651,7 +5616,7 @@
       </p:pic>
       <p:sp>
         <p:nvSpPr>
-          <p:cNvPr id="71" name="TextBox 70"/>
+          <p:cNvPr id="70" name="TextBox 69"/>
           <p:cNvSpPr txBox="1"/>
           <p:nvPr/>
         </p:nvSpPr>
@@ -5690,7 +5655,7 @@
       </p:sp>
       <p:sp>
         <p:nvSpPr>
-          <p:cNvPr id="72" name="Rounded Rectangle 71"/>
+          <p:cNvPr id="71" name="Rounded Rectangle 70"/>
           <p:cNvSpPr/>
           <p:nvPr/>
         </p:nvSpPr>
@@ -5736,7 +5701,7 @@
       </p:sp>
       <p:sp>
         <p:nvSpPr>
-          <p:cNvPr id="73" name="TextBox 72"/>
+          <p:cNvPr id="72" name="TextBox 71"/>
           <p:cNvSpPr txBox="1"/>
           <p:nvPr/>
         </p:nvSpPr>
@@ -5771,7 +5736,7 @@
       </p:sp>
       <p:pic>
         <p:nvPicPr>
-          <p:cNvPr id="74" name="Picture 73" descr="excel.png"/>
+          <p:cNvPr id="73" name="Picture 72" descr="excel.png"/>
           <p:cNvPicPr>
             <a:picLocks noChangeAspect="1"/>
           </p:cNvPicPr>
@@ -5785,8 +5750,8 @@
         </p:blipFill>
         <p:spPr>
           <a:xfrm>
-            <a:off x="6217920" y="5937527"/>
-            <a:ext cx="347472" cy="323040"/>
+            <a:off x="6217920" y="5937376"/>
+            <a:ext cx="347472" cy="323342"/>
           </a:xfrm>
           <a:prstGeom prst="rect">
             <a:avLst/>
@@ -5795,7 +5760,7 @@
       </p:pic>
       <p:sp>
         <p:nvSpPr>
-          <p:cNvPr id="75" name="TextBox 74"/>
+          <p:cNvPr id="74" name="TextBox 73"/>
           <p:cNvSpPr txBox="1"/>
           <p:nvPr/>
         </p:nvSpPr>
@@ -5850,7 +5815,7 @@
       </p:sp>
       <p:pic>
         <p:nvPicPr>
-          <p:cNvPr id="76" name="Picture 75" descr="json.png"/>
+          <p:cNvPr id="75" name="Picture 74" descr="json.png"/>
           <p:cNvPicPr>
             <a:picLocks noChangeAspect="1"/>
           </p:cNvPicPr>
@@ -5874,7 +5839,7 @@
       </p:pic>
       <p:sp>
         <p:nvSpPr>
-          <p:cNvPr id="77" name="TextBox 76"/>
+          <p:cNvPr id="76" name="TextBox 75"/>
           <p:cNvSpPr txBox="1"/>
           <p:nvPr/>
         </p:nvSpPr>
@@ -5929,7 +5894,7 @@
       </p:sp>
       <p:cxnSp>
         <p:nvCxnSpPr>
-          <p:cNvPr id="78" name="Connector 77"/>
+          <p:cNvPr id="77" name="Connector 76"/>
           <p:cNvCxnSpPr/>
           <p:nvPr/>
         </p:nvCxnSpPr>
@@ -5965,7 +5930,7 @@
       </p:cxnSp>
       <p:sp>
         <p:nvSpPr>
-          <p:cNvPr id="79" name="TextBox 78"/>
+          <p:cNvPr id="78" name="TextBox 77"/>
           <p:cNvSpPr txBox="1"/>
           <p:nvPr/>
         </p:nvSpPr>
@@ -6020,7 +5985,7 @@
       </p:sp>
       <p:cxnSp>
         <p:nvCxnSpPr>
-          <p:cNvPr id="80" name="Connector 79"/>
+          <p:cNvPr id="79" name="Connector 78"/>
           <p:cNvCxnSpPr/>
           <p:nvPr/>
         </p:nvCxnSpPr>
@@ -6028,6 +5993,42 @@
           <a:xfrm flipV="1">
             <a:off x="1371600" y="5376672"/>
             <a:ext cx="0" cy="164592"/>
+          </a:xfrm>
+          <a:prstGeom prst="line">
+            <a:avLst/>
+          </a:prstGeom>
+          <a:ln w="15875">
+            <a:solidFill>
+              <a:srgbClr val="D1980B"/>
+            </a:solidFill>
+            <a:prstDash val="dash"/>
+          </a:ln>
+        </p:spPr>
+        <p:style>
+          <a:lnRef idx="2">
+            <a:schemeClr val="accent1"/>
+          </a:lnRef>
+          <a:fillRef idx="0">
+            <a:schemeClr val="accent1"/>
+          </a:fillRef>
+          <a:effectRef idx="1">
+            <a:schemeClr val="accent1"/>
+          </a:effectRef>
+          <a:fontRef idx="minor">
+            <a:schemeClr val="tx1"/>
+          </a:fontRef>
+        </p:style>
+      </p:cxnSp>
+      <p:cxnSp>
+        <p:nvCxnSpPr>
+          <p:cNvPr id="80" name="Connector 79"/>
+          <p:cNvCxnSpPr/>
+          <p:nvPr/>
+        </p:nvCxnSpPr>
+        <p:spPr>
+          <a:xfrm flipH="1">
+            <a:off x="347472" y="5376672"/>
+            <a:ext cx="1024128" cy="0"/>
           </a:xfrm>
           <a:prstGeom prst="line">
             <a:avLst/>
@@ -6061,9 +6062,9 @@
           <p:nvPr/>
         </p:nvCxnSpPr>
         <p:spPr>
-          <a:xfrm flipH="1">
-            <a:off x="347472" y="5376672"/>
-            <a:ext cx="1024128" cy="0"/>
+          <a:xfrm flipV="1">
+            <a:off x="347472" y="1883664"/>
+            <a:ext cx="0" cy="3493008"/>
           </a:xfrm>
           <a:prstGeom prst="line">
             <a:avLst/>
@@ -6097,42 +6098,6 @@
           <p:nvPr/>
         </p:nvCxnSpPr>
         <p:spPr>
-          <a:xfrm flipV="1">
-            <a:off x="347472" y="1883664"/>
-            <a:ext cx="0" cy="3493008"/>
-          </a:xfrm>
-          <a:prstGeom prst="line">
-            <a:avLst/>
-          </a:prstGeom>
-          <a:ln w="15875">
-            <a:solidFill>
-              <a:srgbClr val="D1980B"/>
-            </a:solidFill>
-            <a:prstDash val="dash"/>
-          </a:ln>
-        </p:spPr>
-        <p:style>
-          <a:lnRef idx="2">
-            <a:schemeClr val="accent1"/>
-          </a:lnRef>
-          <a:fillRef idx="0">
-            <a:schemeClr val="accent1"/>
-          </a:fillRef>
-          <a:effectRef idx="1">
-            <a:schemeClr val="accent1"/>
-          </a:effectRef>
-          <a:fontRef idx="minor">
-            <a:schemeClr val="tx1"/>
-          </a:fontRef>
-        </p:style>
-      </p:cxnSp>
-      <p:cxnSp>
-        <p:nvCxnSpPr>
-          <p:cNvPr id="83" name="Connector 82"/>
-          <p:cNvCxnSpPr/>
-          <p:nvPr/>
-        </p:nvCxnSpPr>
-        <p:spPr>
           <a:xfrm>
             <a:off x="347472" y="1883664"/>
             <a:ext cx="182880" cy="0"/>
@@ -6165,7 +6130,7 @@
       </p:cxnSp>
       <p:sp>
         <p:nvSpPr>
-          <p:cNvPr id="84" name="TextBox 83"/>
+          <p:cNvPr id="83" name="TextBox 82"/>
           <p:cNvSpPr txBox="1"/>
           <p:nvPr/>
         </p:nvSpPr>
@@ -6200,7 +6165,7 @@
       </p:sp>
       <p:sp>
         <p:nvSpPr>
-          <p:cNvPr id="85" name="TextBox 84"/>
+          <p:cNvPr id="84" name="TextBox 83"/>
           <p:cNvSpPr txBox="1"/>
           <p:nvPr/>
         </p:nvSpPr>
@@ -6265,41 +6230,6 @@
                 <a:latin typeface="Calibri"/>
               </a:rPr>
               <a:t>a person resolves</a:t>
-            </a:r>
-          </a:p>
-        </p:txBody>
-      </p:sp>
-      <p:sp>
-        <p:nvSpPr>
-          <p:cNvPr id="86" name="TextBox 85"/>
-          <p:cNvSpPr txBox="1"/>
-          <p:nvPr/>
-        </p:nvSpPr>
-        <p:spPr>
-          <a:xfrm>
-            <a:off x="7253935" y="6547104"/>
-            <a:ext cx="4389120" cy="201168"/>
-          </a:xfrm>
-          <a:prstGeom prst="rect">
-            <a:avLst/>
-          </a:prstGeom>
-          <a:noFill/>
-        </p:spPr>
-        <p:txBody>
-          <a:bodyPr wrap="square" lIns="0" rIns="0" tIns="0" bIns="0" anchor="t">
-            <a:spAutoFit/>
-          </a:bodyPr>
-          <a:lstStyle/>
-          <a:p>
-            <a:pPr algn="r"/>
-            <a:r>
-              <a:rPr sz="850" b="0">
-                <a:solidFill>
-                  <a:srgbClr val="5F6B7C"/>
-                </a:solidFill>
-                <a:latin typeface="Calibri"/>
-              </a:rPr>
-              <a:t>staging · 2026-08-22 · verified offline · live deploy pending</a:t>
             </a:r>
           </a:p>
         </p:txBody>

</xml_diff>

<commit_message>
docs + slide: sync on app START-UP (not a schedule) and the FRD_/STTM_ naming convention — decided 2026-08-22 late, not yet in code
CLAUDE.md: decision block at the top with the implementation list (start-up
hook in the app backend, drop the cron schedule, prefix-first pairing in
sync.py); every 'scheduled' mention annotated as pre-decision code.
Master context doc: Monday checklist step 3, pipeline table, template
section, review-app section, unproven list, decisions log.
Slide: sync arrow reads 'on app start-up'; inputs shown as FRD_<name>.docx /
STTM_<name>.xlsx; review-app card notes the start-up sync.

Co-Authored-By: Claude Fable 5 <noreply@anthropic.com>
</commit_message>
<xml_diff>
--- a/context/FRD_to_STTM_Agent_System_Architecture.pptx
+++ b/context/FRD_to_STTM_Agent_System_Architecture.pptx
@@ -3746,7 +3746,7 @@
                 </a:solidFill>
                 <a:latin typeface="Calibri"/>
               </a:rPr>
-              <a:t>FRD  ·  .docx</a:t>
+              <a:t>FRD_&lt;name&gt;.docx</a:t>
             </a:r>
           </a:p>
         </p:txBody>
@@ -3886,7 +3886,7 @@
                 </a:solidFill>
                 <a:latin typeface="Calibri"/>
               </a:rPr>
-              <a:t>Approved STTM  ·  .xlsx</a:t>
+              <a:t>STTM_&lt;name&gt;.xlsx</a:t>
             </a:r>
           </a:p>
         </p:txBody>
@@ -4066,7 +4066,7 @@
         <p:spPr>
           <a:xfrm>
             <a:off x="4517136" y="2491740"/>
-            <a:ext cx="5486400" cy="201168"/>
+            <a:ext cx="7132320" cy="201168"/>
           </a:xfrm>
           <a:prstGeom prst="rect">
             <a:avLst/>
@@ -4087,7 +4087,7 @@
                 </a:solidFill>
                 <a:latin typeface="Calibri"/>
               </a:rPr>
-              <a:t>00  scheduled sync — every 15 min, incremental · pulls FRDs and STTMs down · never writes back</a:t>
+              <a:t>00  sync on app start-up — imports every FRD_* / STTM_* not yet in Unity Catalog · never writes back</a:t>
             </a:r>
           </a:p>
         </p:txBody>
@@ -5433,7 +5433,7 @@
                 </a:solidFill>
                 <a:latin typeface="Calibri"/>
               </a:rPr>
-              <a:t>Pick an FRD · run (confirm-gated) · answer what the agent could not settle · re-render · download.</a:t>
+              <a:t>On start-up: syncs SharePoint → Unity Catalog. Then pick an FRD · run (confirm-gated) · answer what the agent could not settle · re-render · download.</a:t>
             </a:r>
           </a:p>
         </p:txBody>
@@ -5483,7 +5483,7 @@
         <p:spPr>
           <a:xfrm>
             <a:off x="4517136" y="5262372"/>
-            <a:ext cx="5486400" cy="201168"/>
+            <a:ext cx="7132320" cy="201168"/>
           </a:xfrm>
           <a:prstGeom prst="rect">
             <a:avLst/>
@@ -5648,7 +5648,7 @@
                 </a:solidFill>
                 <a:latin typeface="Calibri"/>
               </a:rPr>
-              <a:t>The reviewer approves the STTM (edits in Excel if needed) and uploads it to SharePoint themselves. The next sync pairs it — it becomes a template.</a:t>
+              <a:t>The reviewer approves the STTM (edits in Excel if needed) and uploads it to SharePoint themselves. The next start-up sync pairs it — it becomes a template.</a:t>
             </a:r>
           </a:p>
         </p:txBody>

</xml_diff>